<commit_message>
Add AI agent code slide to deck and host guide
Co-Authored-By: Claude Sonnet 5.5 <noreply@anthropic.com>
Claude-Session: https://claude.ai/code/session_01NX2zRNpdVAnzFNKmqomzKu
</commit_message>
<xml_diff>
--- a/docs/RUDP_Host_Guide.pptx
+++ b/docs/RUDP_Host_Guide.pptx
@@ -31,9 +31,10 @@
     <p:sldId id="279" r:id="rId25"/>
     <p:sldId id="280" r:id="rId26"/>
     <p:sldId id="281" r:id="rId27"/>
+    <p:sldId id="282" r:id="rId28"/>
   </p:sldIdLst>
   <p:notesMasterIdLst>
-    <p:notesMasterId r:id="rId28"/>
+    <p:notesMasterId r:id="rId29"/>
   </p:notesMasterIdLst>
   <p:sldSz cx="12192000" cy="6858000"/>
   <p:notesSz cx="6858000" cy="12192000"/>
@@ -2135,6 +2136,94 @@
             <a:fld id="{F7021451-1387-4CA6-816F-3879F97B5CBC}" type="slidenum">
               <a:rPr lang="en-US"/>
               <a:t>26</a:t>
+            </a:fld>
+            <a:endParaRPr lang="en-US"/>
+          </a:p>
+        </p:txBody>
+      </p:sp>
+    </p:spTree>
+    <p:extLst>
+      <p:ext uri="{BB962C8B-B14F-4D97-AF65-F5344CB8AC3E}">
+        <p14:creationId xmlns:p14="http://schemas.microsoft.com/office/powerpoint/2010/main" val="1024086991"/>
+      </p:ext>
+    </p:extLst>
+  </p:cSld>
+  <p:clrMapOvr>
+    <a:masterClrMapping/>
+  </p:clrMapOvr>
+</p:notes>
+</file>
+
+<file path=ppt/notesSlides/notesSlide27.xml><?xml version="1.0" encoding="utf-8"?>
+<p:notes xmlns:a="http://schemas.openxmlformats.org/drawingml/2006/main" xmlns:r="http://schemas.openxmlformats.org/officeDocument/2006/relationships" xmlns:p="http://schemas.openxmlformats.org/presentationml/2006/main">
+  <p:cSld>
+    <p:spTree>
+      <p:nvGrpSpPr>
+        <p:cNvPr id="1" name=""/>
+        <p:cNvGrpSpPr/>
+        <p:nvPr/>
+      </p:nvGrpSpPr>
+      <p:grpSpPr>
+        <a:xfrm>
+          <a:off x="0" y="0"/>
+          <a:ext cx="0" cy="0"/>
+          <a:chOff x="0" y="0"/>
+          <a:chExt cx="0" cy="0"/>
+        </a:xfrm>
+      </p:grpSpPr>
+      <p:sp>
+        <p:nvSpPr>
+          <p:cNvPr id="2" name="Slide Image Placeholder 1"/>
+          <p:cNvSpPr>
+            <a:spLocks noGrp="1" noRot="1" noChangeAspect="1"/>
+          </p:cNvSpPr>
+          <p:nvPr>
+            <p:ph type="sldImg"/>
+          </p:nvPr>
+        </p:nvSpPr>
+        <p:spPr/>
+      </p:sp>
+      <p:sp>
+        <p:nvSpPr>
+          <p:cNvPr id="3" name="Notes Placeholder 2"/>
+          <p:cNvSpPr>
+            <a:spLocks noGrp="1"/>
+          </p:cNvSpPr>
+          <p:nvPr>
+            <p:ph type="body" idx="1"/>
+          </p:nvPr>
+        </p:nvSpPr>
+        <p:spPr/>
+        <p:txBody>
+          <a:bodyPr/>
+          <a:lstStyle/>
+          <a:p>
+            <a:r>
+              <a:rPr lang="en-US" dirty="0"/>
+              <a:t/>
+            </a:r>
+            <a:endParaRPr lang="en-US" dirty="0"/>
+          </a:p>
+        </p:txBody>
+      </p:sp>
+      <p:sp>
+        <p:nvSpPr>
+          <p:cNvPr id="4" name="Slide Number Placeholder 3"/>
+          <p:cNvSpPr>
+            <a:spLocks noGrp="1"/>
+          </p:cNvSpPr>
+          <p:nvPr>
+            <p:ph type="sldNum" sz="quarter" idx="10"/>
+          </p:nvPr>
+        </p:nvSpPr>
+        <p:spPr/>
+        <p:txBody>
+          <a:bodyPr/>
+          <a:lstStyle/>
+          <a:p>
+            <a:fld id="{F7021451-1387-4CA6-816F-3879F97B5CBC}" type="slidenum">
+              <a:rPr lang="en-US"/>
+              <a:t>27</a:t>
             </a:fld>
             <a:endParaRPr lang="en-US"/>
           </a:p>
@@ -6304,7 +6393,7 @@
                 <a:ea typeface="Calibri" pitchFamily="34" charset="-122"/>
                 <a:cs typeface="Calibri" pitchFamily="34" charset="-120"/>
               </a:rPr>
-              <a:t>16. Smart-RUDP result</a:t>
+              <a:t>16. The AI agent in our code</a:t>
             </a:r>
             <a:endParaRPr lang="en-US" sz="2600" dirty="0"/>
           </a:p>
@@ -6343,7 +6432,7 @@
                 <a:ea typeface="Calibri" pitchFamily="34" charset="-122"/>
                 <a:cs typeface="Calibri" pitchFamily="34" charset="-120"/>
               </a:rPr>
-              <a:t>Time on this slide: 0:50</a:t>
+              <a:t>Time on this slide: 1:00</a:t>
             </a:r>
             <a:endParaRPr lang="en-US" sz="1300" dirty="0"/>
           </a:p>
@@ -6496,7 +6585,7 @@
                 <a:ea typeface="Calibri" pitchFamily="34" charset="-122"/>
                 <a:cs typeface="Calibri" pitchFamily="34" charset="-120"/>
               </a:rPr>
-              <a:t>Be honest: it did not beat AIMD. Plus 63 percent time on 5G-like, plus 10 percent on satellite, a tie on the lossy path.</a:t>
+              <a:t>This is the agent itself. Left: rl_cc.h, 73 lines of C. The state is 80 buckets of RTT ratio, loss and window size.</a:t>
             </a:r>
             <a:endParaRPr lang="en-US" sz="1400" dirty="0"/>
           </a:p>
@@ -6517,7 +6606,7 @@
                 <a:ea typeface="Calibri" pitchFamily="34" charset="-122"/>
                 <a:cs typeface="Calibri" pitchFamily="34" charset="-120"/>
               </a:rPr>
-              <a:t>It used somewhat fewer retransmissions on two paths, within run-to-run noise.</a:t>
+              <a:t>choose picks one of five window multipliers, usually the best, sometimes random so it keeps exploring.</a:t>
             </a:r>
             <a:endParaRPr lang="en-US" sz="1400" dirty="0"/>
           </a:p>
@@ -6538,7 +6627,7 @@
                 <a:ea typeface="Calibri" pitchFamily="34" charset="-122"/>
                 <a:cs typeface="Calibri" pitchFamily="34" charset="-120"/>
               </a:rPr>
-              <a:t>Earlier training rounds were much worse; this is the final configuration. The finding is that a simple learner does not beat a tuned rule.</a:t>
+              <a:t>update is the Q-learning rule: move the value of the action we took toward the reward plus the best value of the next state.</a:t>
             </a:r>
             <a:endParaRPr lang="en-US" sz="1400" dirty="0"/>
           </a:p>
@@ -6559,7 +6648,28 @@
                 <a:ea typeface="Calibri" pitchFamily="34" charset="-122"/>
                 <a:cs typeface="Calibri" pitchFamily="34" charset="-120"/>
               </a:rPr>
-              <a:t>In the chat, retrained for bursty random-loss traffic, it does beat AIMD on most simulated paths; mention that on slide 19.</a:t>
+              <a:t>Right: the loop in smart_client.c. Once per RTT it computes the reward, throughput minus delay growth minus loss, updates the table, picks the next action and scales the window.</a:t>
+            </a:r>
+            <a:endParaRPr lang="en-US" sz="1400" dirty="0"/>
+          </a:p>
+          <a:p>
+            <a:pPr marL="342900" indent="-342900">
+              <a:spcAft>
+                <a:spcPts val="600"/>
+              </a:spcAft>
+              <a:buSzPct val="100000"/>
+              <a:buChar char="•"/>
+            </a:pPr>
+            <a:r>
+              <a:rPr lang="en-US" sz="1400" dirty="0">
+                <a:solidFill>
+                  <a:srgbClr val="1B2430"/>
+                </a:solidFill>
+                <a:latin typeface="Calibri" pitchFamily="34" charset="0"/>
+                <a:ea typeface="Calibri" pitchFamily="34" charset="-122"/>
+                <a:cs typeface="Calibri" pitchFamily="34" charset="-120"/>
+              </a:rPr>
+              <a:t>The code on the slide is simplified; the real files are in the repo.</a:t>
             </a:r>
             <a:endParaRPr lang="en-US" sz="1400" dirty="0"/>
           </a:p>
@@ -6637,7 +6747,7 @@
                 <a:ea typeface="Calibri" pitchFamily="34" charset="-122"/>
                 <a:cs typeface="Calibri" pitchFamily="34" charset="-120"/>
               </a:rPr>
-              <a:t>Q: Then what was the point? A: The experiment. We tested whether a learned window helps and report the answer, including the negative result.</a:t>
+              <a:t>Q: Is this deep RL? A: No, tabular Q-learning. 80 states fit in a table; a neural network is future work. Q: Where is it trained? A: web/train.py for the chat, the smart client trains online for the main experiments; table in results/q_chat.txt.</a:t>
             </a:r>
             <a:endParaRPr lang="en-US" sz="1400" dirty="0"/>
           </a:p>
@@ -6708,7 +6818,7 @@
                 <a:ea typeface="Calibri" pitchFamily="34" charset="-122"/>
                 <a:cs typeface="Calibri" pitchFamily="34" charset="-120"/>
               </a:rPr>
-              <a:t>17. Wireshark traces</a:t>
+              <a:t>17. Smart-RUDP result</a:t>
             </a:r>
             <a:endParaRPr lang="en-US" sz="2600" dirty="0"/>
           </a:p>
@@ -6747,7 +6857,7 @@
                 <a:ea typeface="Calibri" pitchFamily="34" charset="-122"/>
                 <a:cs typeface="Calibri" pitchFamily="34" charset="-120"/>
               </a:rPr>
-              <a:t>Time on this slide: 0:40</a:t>
+              <a:t>Time on this slide: 0:50</a:t>
             </a:r>
             <a:endParaRPr lang="en-US" sz="1300" dirty="0"/>
           </a:p>
@@ -6892,7 +7002,7 @@
               <a:buChar char="•"/>
             </a:pPr>
             <a:r>
-              <a:rPr lang="en-US" sz="1600" dirty="0">
+              <a:rPr lang="en-US" sz="1400" dirty="0">
                 <a:solidFill>
                   <a:srgbClr val="1B2430"/>
                 </a:solidFill>
@@ -6900,9 +7010,9 @@
                 <a:ea typeface="Calibri" pitchFamily="34" charset="-122"/>
                 <a:cs typeface="Calibri" pitchFamily="34" charset="-120"/>
               </a:rPr>
-              <a:t>We wrote a Lua dissector, named smartrudp, that decodes sequence, ack, flags, checksum and length.</a:t>
-            </a:r>
-            <a:endParaRPr lang="en-US" sz="1600" dirty="0"/>
+              <a:t>Be honest: it did not beat AIMD. Plus 63 percent time on 5G-like, plus 10 percent on satellite, a tie on the lossy path.</a:t>
+            </a:r>
+            <a:endParaRPr lang="en-US" sz="1400" dirty="0"/>
           </a:p>
           <a:p>
             <a:pPr marL="342900" indent="-342900">
@@ -6913,7 +7023,7 @@
               <a:buChar char="•"/>
             </a:pPr>
             <a:r>
-              <a:rPr lang="en-US" sz="1600" dirty="0">
+              <a:rPr lang="en-US" sz="1400" dirty="0">
                 <a:solidFill>
                   <a:srgbClr val="1B2430"/>
                 </a:solidFill>
@@ -6921,9 +7031,9 @@
                 <a:ea typeface="Calibri" pitchFamily="34" charset="-122"/>
                 <a:cs typeface="Calibri" pitchFamily="34" charset="-120"/>
               </a:rPr>
-              <a:t>Useful filters: smartrudp.flags.data == 1 and smartrudp.seq == N.</a:t>
-            </a:r>
-            <a:endParaRPr lang="en-US" sz="1600" dirty="0"/>
+              <a:t>It used somewhat fewer retransmissions on two paths, within run-to-run noise.</a:t>
+            </a:r>
+            <a:endParaRPr lang="en-US" sz="1400" dirty="0"/>
           </a:p>
           <a:p>
             <a:pPr marL="342900" indent="-342900">
@@ -6934,7 +7044,7 @@
               <a:buChar char="•"/>
             </a:pPr>
             <a:r>
-              <a:rPr lang="en-US" sz="1600" dirty="0">
+              <a:rPr lang="en-US" sz="1400" dirty="0">
                 <a:solidFill>
                   <a:srgbClr val="1B2430"/>
                 </a:solidFill>
@@ -6942,9 +7052,9 @@
                 <a:ea typeface="Calibri" pitchFamily="34" charset="-122"/>
                 <a:cs typeface="Calibri" pitchFamily="34" charset="-120"/>
               </a:rPr>
-              <a:t>In a 400-packet lossy run the receiver saw 87 (AIMD) and 95 (Smart) repeated data segments.</a:t>
-            </a:r>
-            <a:endParaRPr lang="en-US" sz="1600" dirty="0"/>
+              <a:t>Earlier training rounds were much worse; this is the final configuration. The finding is that a simple learner does not beat a tuned rule.</a:t>
+            </a:r>
+            <a:endParaRPr lang="en-US" sz="1400" dirty="0"/>
           </a:p>
           <a:p>
             <a:pPr marL="342900" indent="-342900">
@@ -6955,7 +7065,7 @@
               <a:buChar char="•"/>
             </a:pPr>
             <a:r>
-              <a:rPr lang="en-US" sz="1600" dirty="0">
+              <a:rPr lang="en-US" sz="1400" dirty="0">
                 <a:solidFill>
                   <a:srgbClr val="1B2430"/>
                 </a:solidFill>
@@ -6963,9 +7073,9 @@
                 <a:ea typeface="Calibri" pitchFamily="34" charset="-122"/>
                 <a:cs typeface="Calibri" pitchFamily="34" charset="-120"/>
               </a:rPr>
-              <a:t>The program's exported trace uses topology addresses and has no handshake.</a:t>
-            </a:r>
-            <a:endParaRPr lang="en-US" sz="1600" dirty="0"/>
+              <a:t>In the chat, retrained for bursty random-loss traffic, it does beat AIMD on most simulated paths; mention that on slide 19.</a:t>
+            </a:r>
+            <a:endParaRPr lang="en-US" sz="1400" dirty="0"/>
           </a:p>
         </p:txBody>
       </p:sp>
@@ -7041,7 +7151,7 @@
                 <a:ea typeface="Calibri" pitchFamily="34" charset="-122"/>
                 <a:cs typeface="Calibri" pitchFamily="34" charset="-120"/>
               </a:rPr>
-              <a:t>Q: Why no handshake in the export? A: The export builds synthetic packets. The real tshark capture on the next slide shows the handshake.</a:t>
+              <a:t>Q: Then what was the point? A: The experiment. We tested whether a learned window helps and report the answer, including the negative result.</a:t>
             </a:r>
             <a:endParaRPr lang="en-US" sz="1400" dirty="0"/>
           </a:p>
@@ -7835,7 +7945,7 @@
                           <a:ea typeface="Calibri" pitchFamily="34" charset="-122"/>
                           <a:cs typeface="Calibri" pitchFamily="34" charset="-120"/>
                         </a:rPr>
-                        <a:t>12</a:t>
+                        <a:t>13</a:t>
                       </a:r>
                       <a:endParaRPr lang="en-US" sz="1200" dirty="0">
                         <a:latin typeface="Calibri" charset="0"/>
@@ -7900,7 +8010,7 @@
                           <a:ea typeface="Calibri" pitchFamily="34" charset="-122"/>
                           <a:cs typeface="Calibri" pitchFamily="34" charset="-120"/>
                         </a:rPr>
-                        <a:t>Literature</a:t>
+                        <a:t>Network design</a:t>
                       </a:r>
                       <a:endParaRPr lang="en-US" sz="1200" dirty="0">
                         <a:latin typeface="Calibri" charset="0"/>
@@ -7965,7 +8075,7 @@
                           <a:ea typeface="Calibri" pitchFamily="34" charset="-122"/>
                           <a:cs typeface="Calibri" pitchFamily="34" charset="-120"/>
                         </a:rPr>
-                        <a:t>0:30</a:t>
+                        <a:t>0:50</a:t>
                       </a:r>
                       <a:endParaRPr lang="en-US" sz="1200" dirty="0">
                         <a:latin typeface="Calibri" charset="0"/>
@@ -8227,7 +8337,7 @@
                           <a:ea typeface="Calibri" pitchFamily="34" charset="-122"/>
                           <a:cs typeface="Calibri" pitchFamily="34" charset="-120"/>
                         </a:rPr>
-                        <a:t>13</a:t>
+                        <a:t>14</a:t>
                       </a:r>
                       <a:endParaRPr lang="en-US" sz="1200" dirty="0">
                         <a:latin typeface="Calibri" charset="0"/>
@@ -8292,7 +8402,7 @@
                           <a:ea typeface="Calibri" pitchFamily="34" charset="-122"/>
                           <a:cs typeface="Calibri" pitchFamily="34" charset="-120"/>
                         </a:rPr>
-                        <a:t>Network design</a:t>
+                        <a:t>Packet Tracer results</a:t>
                       </a:r>
                       <a:endParaRPr lang="en-US" sz="1200" dirty="0">
                         <a:latin typeface="Calibri" charset="0"/>
@@ -8357,7 +8467,7 @@
                           <a:ea typeface="Calibri" pitchFamily="34" charset="-122"/>
                           <a:cs typeface="Calibri" pitchFamily="34" charset="-120"/>
                         </a:rPr>
-                        <a:t>0:50</a:t>
+                        <a:t>0:40</a:t>
                       </a:r>
                       <a:endParaRPr lang="en-US" sz="1200" dirty="0">
                         <a:latin typeface="Calibri" charset="0"/>
@@ -8619,7 +8729,7 @@
                           <a:ea typeface="Calibri" pitchFamily="34" charset="-122"/>
                           <a:cs typeface="Calibri" pitchFamily="34" charset="-120"/>
                         </a:rPr>
-                        <a:t>14</a:t>
+                        <a:t>15</a:t>
                       </a:r>
                       <a:endParaRPr lang="en-US" sz="1200" dirty="0">
                         <a:latin typeface="Calibri" charset="0"/>
@@ -8684,7 +8794,7 @@
                           <a:ea typeface="Calibri" pitchFamily="34" charset="-122"/>
                           <a:cs typeface="Calibri" pitchFamily="34" charset="-120"/>
                         </a:rPr>
-                        <a:t>Packet Tracer results</a:t>
+                        <a:t>Smart-RUDP design</a:t>
                       </a:r>
                       <a:endParaRPr lang="en-US" sz="1200" dirty="0">
                         <a:latin typeface="Calibri" charset="0"/>
@@ -8749,7 +8859,7 @@
                           <a:ea typeface="Calibri" pitchFamily="34" charset="-122"/>
                           <a:cs typeface="Calibri" pitchFamily="34" charset="-120"/>
                         </a:rPr>
-                        <a:t>0:40</a:t>
+                        <a:t>0:50</a:t>
                       </a:r>
                       <a:endParaRPr lang="en-US" sz="1200" dirty="0">
                         <a:latin typeface="Calibri" charset="0"/>
@@ -9011,7 +9121,7 @@
                           <a:ea typeface="Calibri" pitchFamily="34" charset="-122"/>
                           <a:cs typeface="Calibri" pitchFamily="34" charset="-120"/>
                         </a:rPr>
-                        <a:t>15</a:t>
+                        <a:t>16</a:t>
                       </a:r>
                       <a:endParaRPr lang="en-US" sz="1200" dirty="0">
                         <a:latin typeface="Calibri" charset="0"/>
@@ -9076,7 +9186,7 @@
                           <a:ea typeface="Calibri" pitchFamily="34" charset="-122"/>
                           <a:cs typeface="Calibri" pitchFamily="34" charset="-120"/>
                         </a:rPr>
-                        <a:t>Smart-RUDP design</a:t>
+                        <a:t>The AI agent in our code</a:t>
                       </a:r>
                       <a:endParaRPr lang="en-US" sz="1200" dirty="0">
                         <a:latin typeface="Calibri" charset="0"/>
@@ -9141,7 +9251,7 @@
                           <a:ea typeface="Calibri" pitchFamily="34" charset="-122"/>
                           <a:cs typeface="Calibri" pitchFamily="34" charset="-120"/>
                         </a:rPr>
-                        <a:t>0:50</a:t>
+                        <a:t>1:00</a:t>
                       </a:r>
                       <a:endParaRPr lang="en-US" sz="1200" dirty="0">
                         <a:latin typeface="Calibri" charset="0"/>
@@ -9403,7 +9513,7 @@
                           <a:ea typeface="Calibri" pitchFamily="34" charset="-122"/>
                           <a:cs typeface="Calibri" pitchFamily="34" charset="-120"/>
                         </a:rPr>
-                        <a:t>16</a:t>
+                        <a:t>17</a:t>
                       </a:r>
                       <a:endParaRPr lang="en-US" sz="1200" dirty="0">
                         <a:latin typeface="Calibri" charset="0"/>
@@ -9795,7 +9905,7 @@
                           <a:ea typeface="Calibri" pitchFamily="34" charset="-122"/>
                           <a:cs typeface="Calibri" pitchFamily="34" charset="-120"/>
                         </a:rPr>
-                        <a:t>17</a:t>
+                        <a:t>18</a:t>
                       </a:r>
                       <a:endParaRPr lang="en-US" sz="1200" dirty="0">
                         <a:latin typeface="Calibri" charset="0"/>
@@ -10187,7 +10297,7 @@
                           <a:ea typeface="Calibri" pitchFamily="34" charset="-122"/>
                           <a:cs typeface="Calibri" pitchFamily="34" charset="-120"/>
                         </a:rPr>
-                        <a:t>18</a:t>
+                        <a:t>19</a:t>
                       </a:r>
                       <a:endParaRPr lang="en-US" sz="1200" dirty="0">
                         <a:latin typeface="Calibri" charset="0"/>
@@ -10579,7 +10689,7 @@
                           <a:ea typeface="Calibri" pitchFamily="34" charset="-122"/>
                           <a:cs typeface="Calibri" pitchFamily="34" charset="-120"/>
                         </a:rPr>
-                        <a:t>19</a:t>
+                        <a:t>20</a:t>
                       </a:r>
                       <a:endParaRPr lang="en-US" sz="1200" dirty="0">
                         <a:latin typeface="Calibri" charset="0"/>
@@ -10971,7 +11081,7 @@
                           <a:ea typeface="Calibri" pitchFamily="34" charset="-122"/>
                           <a:cs typeface="Calibri" pitchFamily="34" charset="-120"/>
                         </a:rPr>
-                        <a:t>20</a:t>
+                        <a:t>21</a:t>
                       </a:r>
                       <a:endParaRPr lang="en-US" sz="1200" dirty="0">
                         <a:latin typeface="Calibri" charset="0"/>
@@ -11363,7 +11473,7 @@
                           <a:ea typeface="Calibri" pitchFamily="34" charset="-122"/>
                           <a:cs typeface="Calibri" pitchFamily="34" charset="-120"/>
                         </a:rPr>
-                        <a:t>21</a:t>
+                        <a:t>22</a:t>
                       </a:r>
                       <a:endParaRPr lang="en-US" sz="1200" dirty="0">
                         <a:latin typeface="Calibri" charset="0"/>
@@ -11755,7 +11865,7 @@
                           <a:ea typeface="Calibri" pitchFamily="34" charset="-122"/>
                           <a:cs typeface="Calibri" pitchFamily="34" charset="-120"/>
                         </a:rPr>
-                        <a:t>22</a:t>
+                        <a:t>23</a:t>
                       </a:r>
                       <a:endParaRPr lang="en-US" sz="1200" dirty="0">
                         <a:latin typeface="Calibri" charset="0"/>
@@ -11887,6 +11997,365 @@
                         </a:rPr>
                         <a:t>-</a:t>
                       </a:r>
+                      <a:endParaRPr lang="en-US" sz="1200" dirty="0">
+                        <a:latin typeface="Calibri" charset="0"/>
+                        <a:ea typeface="Calibri" charset="0"/>
+                        <a:cs typeface="Calibri" charset="0"/>
+                      </a:endParaRPr>
+                    </a:p>
+                  </a:txBody>
+                  <a:tcPr marL="91440" marR="91440" marT="45720" marB="45720">
+                    <a:lnL w="6350" cap="flat" cmpd="sng" algn="ctr">
+                      <a:solidFill>
+                        <a:srgbClr val="D5DEE9"/>
+                      </a:solidFill>
+                      <a:prstDash val="solid"/>
+                      <a:round/>
+                      <a:headEnd type="none" w="med" len="med"/>
+                      <a:tailEnd type="none" w="med" len="med"/>
+                    </a:lnL>
+                    <a:lnR w="6350" cap="flat" cmpd="sng" algn="ctr">
+                      <a:solidFill>
+                        <a:srgbClr val="D5DEE9"/>
+                      </a:solidFill>
+                      <a:prstDash val="solid"/>
+                      <a:round/>
+                      <a:headEnd type="none" w="med" len="med"/>
+                      <a:tailEnd type="none" w="med" len="med"/>
+                    </a:lnR>
+                    <a:lnT w="6350" cap="flat" cmpd="sng" algn="ctr">
+                      <a:solidFill>
+                        <a:srgbClr val="D5DEE9"/>
+                      </a:solidFill>
+                      <a:prstDash val="solid"/>
+                      <a:round/>
+                      <a:headEnd type="none" w="med" len="med"/>
+                      <a:tailEnd type="none" w="med" len="med"/>
+                    </a:lnT>
+                    <a:lnB w="6350" cap="flat" cmpd="sng" algn="ctr">
+                      <a:solidFill>
+                        <a:srgbClr val="D5DEE9"/>
+                      </a:solidFill>
+                      <a:prstDash val="solid"/>
+                      <a:round/>
+                      <a:headEnd type="none" w="med" len="med"/>
+                      <a:tailEnd type="none" w="med" len="med"/>
+                    </a:lnB>
+                  </a:tcPr>
+                </a:tc>
+              </a:tr>
+              <a:tr h="347472">
+                <a:tc>
+                  <a:txBody>
+                    <a:bodyPr/>
+                    <a:lstStyle/>
+                    <a:p>
+                      <a:pPr indent="0" marL="0">
+                        <a:buNone/>
+                      </a:pPr>
+                      <a:r>
+                        <a:rPr lang="en-US" sz="1200" dirty="0">
+                          <a:solidFill>
+                            <a:srgbClr val="1B2430"/>
+                          </a:solidFill>
+                          <a:latin typeface="Calibri" pitchFamily="34" charset="0"/>
+                          <a:ea typeface="Calibri" pitchFamily="34" charset="-122"/>
+                          <a:cs typeface="Calibri" pitchFamily="34" charset="-120"/>
+                        </a:rPr>
+                        <a:t>12</a:t>
+                      </a:r>
+                      <a:endParaRPr lang="en-US" sz="1200" dirty="0">
+                        <a:latin typeface="Calibri" charset="0"/>
+                        <a:ea typeface="Calibri" charset="0"/>
+                        <a:cs typeface="Calibri" charset="0"/>
+                      </a:endParaRPr>
+                    </a:p>
+                  </a:txBody>
+                  <a:tcPr marL="91440" marR="91440" marT="45720" marB="45720">
+                    <a:lnL w="6350" cap="flat" cmpd="sng" algn="ctr">
+                      <a:solidFill>
+                        <a:srgbClr val="D5DEE9"/>
+                      </a:solidFill>
+                      <a:prstDash val="solid"/>
+                      <a:round/>
+                      <a:headEnd type="none" w="med" len="med"/>
+                      <a:tailEnd type="none" w="med" len="med"/>
+                    </a:lnL>
+                    <a:lnR w="6350" cap="flat" cmpd="sng" algn="ctr">
+                      <a:solidFill>
+                        <a:srgbClr val="D5DEE9"/>
+                      </a:solidFill>
+                      <a:prstDash val="solid"/>
+                      <a:round/>
+                      <a:headEnd type="none" w="med" len="med"/>
+                      <a:tailEnd type="none" w="med" len="med"/>
+                    </a:lnR>
+                    <a:lnT w="6350" cap="flat" cmpd="sng" algn="ctr">
+                      <a:solidFill>
+                        <a:srgbClr val="D5DEE9"/>
+                      </a:solidFill>
+                      <a:prstDash val="solid"/>
+                      <a:round/>
+                      <a:headEnd type="none" w="med" len="med"/>
+                      <a:tailEnd type="none" w="med" len="med"/>
+                    </a:lnT>
+                    <a:lnB w="6350" cap="flat" cmpd="sng" algn="ctr">
+                      <a:solidFill>
+                        <a:srgbClr val="D5DEE9"/>
+                      </a:solidFill>
+                      <a:prstDash val="solid"/>
+                      <a:round/>
+                      <a:headEnd type="none" w="med" len="med"/>
+                      <a:tailEnd type="none" w="med" len="med"/>
+                    </a:lnB>
+                  </a:tcPr>
+                </a:tc>
+                <a:tc>
+                  <a:txBody>
+                    <a:bodyPr/>
+                    <a:lstStyle/>
+                    <a:p>
+                      <a:pPr indent="0" marL="0">
+                        <a:buNone/>
+                      </a:pPr>
+                      <a:r>
+                        <a:rPr lang="en-US" sz="1200" dirty="0">
+                          <a:solidFill>
+                            <a:srgbClr val="1B2430"/>
+                          </a:solidFill>
+                          <a:latin typeface="Calibri" pitchFamily="34" charset="0"/>
+                          <a:ea typeface="Calibri" pitchFamily="34" charset="-122"/>
+                          <a:cs typeface="Calibri" pitchFamily="34" charset="-120"/>
+                        </a:rPr>
+                        <a:t>Literature</a:t>
+                      </a:r>
+                      <a:endParaRPr lang="en-US" sz="1200" dirty="0">
+                        <a:latin typeface="Calibri" charset="0"/>
+                        <a:ea typeface="Calibri" charset="0"/>
+                        <a:cs typeface="Calibri" charset="0"/>
+                      </a:endParaRPr>
+                    </a:p>
+                  </a:txBody>
+                  <a:tcPr marL="91440" marR="91440" marT="45720" marB="45720">
+                    <a:lnL w="6350" cap="flat" cmpd="sng" algn="ctr">
+                      <a:solidFill>
+                        <a:srgbClr val="D5DEE9"/>
+                      </a:solidFill>
+                      <a:prstDash val="solid"/>
+                      <a:round/>
+                      <a:headEnd type="none" w="med" len="med"/>
+                      <a:tailEnd type="none" w="med" len="med"/>
+                    </a:lnL>
+                    <a:lnR w="6350" cap="flat" cmpd="sng" algn="ctr">
+                      <a:solidFill>
+                        <a:srgbClr val="D5DEE9"/>
+                      </a:solidFill>
+                      <a:prstDash val="solid"/>
+                      <a:round/>
+                      <a:headEnd type="none" w="med" len="med"/>
+                      <a:tailEnd type="none" w="med" len="med"/>
+                    </a:lnR>
+                    <a:lnT w="6350" cap="flat" cmpd="sng" algn="ctr">
+                      <a:solidFill>
+                        <a:srgbClr val="D5DEE9"/>
+                      </a:solidFill>
+                      <a:prstDash val="solid"/>
+                      <a:round/>
+                      <a:headEnd type="none" w="med" len="med"/>
+                      <a:tailEnd type="none" w="med" len="med"/>
+                    </a:lnT>
+                    <a:lnB w="6350" cap="flat" cmpd="sng" algn="ctr">
+                      <a:solidFill>
+                        <a:srgbClr val="D5DEE9"/>
+                      </a:solidFill>
+                      <a:prstDash val="solid"/>
+                      <a:round/>
+                      <a:headEnd type="none" w="med" len="med"/>
+                      <a:tailEnd type="none" w="med" len="med"/>
+                    </a:lnB>
+                  </a:tcPr>
+                </a:tc>
+                <a:tc>
+                  <a:txBody>
+                    <a:bodyPr/>
+                    <a:lstStyle/>
+                    <a:p>
+                      <a:pPr indent="0" marL="0">
+                        <a:buNone/>
+                      </a:pPr>
+                      <a:r>
+                        <a:rPr lang="en-US" sz="1200" dirty="0">
+                          <a:solidFill>
+                            <a:srgbClr val="1B2430"/>
+                          </a:solidFill>
+                          <a:latin typeface="Calibri" pitchFamily="34" charset="0"/>
+                          <a:ea typeface="Calibri" pitchFamily="34" charset="-122"/>
+                          <a:cs typeface="Calibri" pitchFamily="34" charset="-120"/>
+                        </a:rPr>
+                        <a:t>0:30</a:t>
+                      </a:r>
+                      <a:endParaRPr lang="en-US" sz="1200" dirty="0">
+                        <a:latin typeface="Calibri" charset="0"/>
+                        <a:ea typeface="Calibri" charset="0"/>
+                        <a:cs typeface="Calibri" charset="0"/>
+                      </a:endParaRPr>
+                    </a:p>
+                  </a:txBody>
+                  <a:tcPr marL="91440" marR="91440" marT="45720" marB="45720">
+                    <a:lnL w="6350" cap="flat" cmpd="sng" algn="ctr">
+                      <a:solidFill>
+                        <a:srgbClr val="D5DEE9"/>
+                      </a:solidFill>
+                      <a:prstDash val="solid"/>
+                      <a:round/>
+                      <a:headEnd type="none" w="med" len="med"/>
+                      <a:tailEnd type="none" w="med" len="med"/>
+                    </a:lnL>
+                    <a:lnR w="6350" cap="flat" cmpd="sng" algn="ctr">
+                      <a:solidFill>
+                        <a:srgbClr val="D5DEE9"/>
+                      </a:solidFill>
+                      <a:prstDash val="solid"/>
+                      <a:round/>
+                      <a:headEnd type="none" w="med" len="med"/>
+                      <a:tailEnd type="none" w="med" len="med"/>
+                    </a:lnR>
+                    <a:lnT w="6350" cap="flat" cmpd="sng" algn="ctr">
+                      <a:solidFill>
+                        <a:srgbClr val="D5DEE9"/>
+                      </a:solidFill>
+                      <a:prstDash val="solid"/>
+                      <a:round/>
+                      <a:headEnd type="none" w="med" len="med"/>
+                      <a:tailEnd type="none" w="med" len="med"/>
+                    </a:lnT>
+                    <a:lnB w="6350" cap="flat" cmpd="sng" algn="ctr">
+                      <a:solidFill>
+                        <a:srgbClr val="D5DEE9"/>
+                      </a:solidFill>
+                      <a:prstDash val="solid"/>
+                      <a:round/>
+                      <a:headEnd type="none" w="med" len="med"/>
+                      <a:tailEnd type="none" w="med" len="med"/>
+                    </a:lnB>
+                  </a:tcPr>
+                </a:tc>
+                <a:tc>
+                  <a:txBody>
+                    <a:bodyPr/>
+                    <a:lstStyle/>
+                    <a:p>
+                      <a:pPr indent="0" marL="0">
+                        <a:buNone/>
+                      </a:pPr>
+                      <a:endParaRPr lang="en-US" sz="1200" dirty="0">
+                        <a:latin typeface="Calibri" charset="0"/>
+                        <a:ea typeface="Calibri" charset="0"/>
+                        <a:cs typeface="Calibri" charset="0"/>
+                      </a:endParaRPr>
+                    </a:p>
+                  </a:txBody>
+                  <a:tcPr marL="91440" marR="91440" marT="45720" marB="45720">
+                    <a:lnL w="6350" cap="flat" cmpd="sng" algn="ctr">
+                      <a:solidFill>
+                        <a:srgbClr val="D5DEE9"/>
+                      </a:solidFill>
+                      <a:prstDash val="solid"/>
+                      <a:round/>
+                      <a:headEnd type="none" w="med" len="med"/>
+                      <a:tailEnd type="none" w="med" len="med"/>
+                    </a:lnL>
+                    <a:lnR w="6350" cap="flat" cmpd="sng" algn="ctr">
+                      <a:solidFill>
+                        <a:srgbClr val="D5DEE9"/>
+                      </a:solidFill>
+                      <a:prstDash val="solid"/>
+                      <a:round/>
+                      <a:headEnd type="none" w="med" len="med"/>
+                      <a:tailEnd type="none" w="med" len="med"/>
+                    </a:lnR>
+                    <a:lnT w="6350" cap="flat" cmpd="sng" algn="ctr">
+                      <a:solidFill>
+                        <a:srgbClr val="D5DEE9"/>
+                      </a:solidFill>
+                      <a:prstDash val="solid"/>
+                      <a:round/>
+                      <a:headEnd type="none" w="med" len="med"/>
+                      <a:tailEnd type="none" w="med" len="med"/>
+                    </a:lnT>
+                    <a:lnB w="6350" cap="flat" cmpd="sng" algn="ctr">
+                      <a:solidFill>
+                        <a:srgbClr val="D5DEE9"/>
+                      </a:solidFill>
+                      <a:prstDash val="solid"/>
+                      <a:round/>
+                      <a:headEnd type="none" w="med" len="med"/>
+                      <a:tailEnd type="none" w="med" len="med"/>
+                    </a:lnB>
+                  </a:tcPr>
+                </a:tc>
+                <a:tc>
+                  <a:txBody>
+                    <a:bodyPr/>
+                    <a:lstStyle/>
+                    <a:p>
+                      <a:pPr indent="0" marL="0">
+                        <a:buNone/>
+                      </a:pPr>
+                      <a:endParaRPr lang="en-US" sz="1200" dirty="0">
+                        <a:latin typeface="Calibri" charset="0"/>
+                        <a:ea typeface="Calibri" charset="0"/>
+                        <a:cs typeface="Calibri" charset="0"/>
+                      </a:endParaRPr>
+                    </a:p>
+                  </a:txBody>
+                  <a:tcPr marL="91440" marR="91440" marT="45720" marB="45720">
+                    <a:lnL w="6350" cap="flat" cmpd="sng" algn="ctr">
+                      <a:solidFill>
+                        <a:srgbClr val="D5DEE9"/>
+                      </a:solidFill>
+                      <a:prstDash val="solid"/>
+                      <a:round/>
+                      <a:headEnd type="none" w="med" len="med"/>
+                      <a:tailEnd type="none" w="med" len="med"/>
+                    </a:lnL>
+                    <a:lnR w="6350" cap="flat" cmpd="sng" algn="ctr">
+                      <a:solidFill>
+                        <a:srgbClr val="D5DEE9"/>
+                      </a:solidFill>
+                      <a:prstDash val="solid"/>
+                      <a:round/>
+                      <a:headEnd type="none" w="med" len="med"/>
+                      <a:tailEnd type="none" w="med" len="med"/>
+                    </a:lnR>
+                    <a:lnT w="6350" cap="flat" cmpd="sng" algn="ctr">
+                      <a:solidFill>
+                        <a:srgbClr val="D5DEE9"/>
+                      </a:solidFill>
+                      <a:prstDash val="solid"/>
+                      <a:round/>
+                      <a:headEnd type="none" w="med" len="med"/>
+                      <a:tailEnd type="none" w="med" len="med"/>
+                    </a:lnT>
+                    <a:lnB w="6350" cap="flat" cmpd="sng" algn="ctr">
+                      <a:solidFill>
+                        <a:srgbClr val="D5DEE9"/>
+                      </a:solidFill>
+                      <a:prstDash val="solid"/>
+                      <a:round/>
+                      <a:headEnd type="none" w="med" len="med"/>
+                      <a:tailEnd type="none" w="med" len="med"/>
+                    </a:lnB>
+                  </a:tcPr>
+                </a:tc>
+                <a:tc>
+                  <a:txBody>
+                    <a:bodyPr/>
+                    <a:lstStyle/>
+                    <a:p>
+                      <a:pPr indent="0" marL="0">
+                        <a:buNone/>
+                      </a:pPr>
                       <a:endParaRPr lang="en-US" sz="1200" dirty="0">
                         <a:latin typeface="Calibri" charset="0"/>
                         <a:ea typeface="Calibri" charset="0"/>
@@ -12042,7 +12511,7 @@
                 <a:ea typeface="Calibri" pitchFamily="34" charset="-122"/>
                 <a:cs typeface="Calibri" pitchFamily="34" charset="-120"/>
               </a:rPr>
-              <a:t>18. Wireshark real capture</a:t>
+              <a:t>18. Wireshark traces</a:t>
             </a:r>
             <a:endParaRPr lang="en-US" sz="2600" dirty="0"/>
           </a:p>
@@ -12081,7 +12550,7 @@
                 <a:ea typeface="Calibri" pitchFamily="34" charset="-122"/>
                 <a:cs typeface="Calibri" pitchFamily="34" charset="-120"/>
               </a:rPr>
-              <a:t>Time on this slide: 0:50</a:t>
+              <a:t>Time on this slide: 0:40</a:t>
             </a:r>
             <a:endParaRPr lang="en-US" sz="1300" dirty="0"/>
           </a:p>
@@ -12234,7 +12703,7 @@
                 <a:ea typeface="Calibri" pitchFamily="34" charset="-122"/>
                 <a:cs typeface="Calibri" pitchFamily="34" charset="-120"/>
               </a:rPr>
-              <a:t>Left: the first three packets, SYN, SYN-ACK and ACK, decoded by our dissector (filter frame.number &lt;= 3).</a:t>
+              <a:t>We wrote a Lua dissector, named smartrudp, that decodes sequence, ack, flags, checksum and length.</a:t>
             </a:r>
             <a:endParaRPr lang="en-US" sz="1600" dirty="0"/>
           </a:p>
@@ -12255,7 +12724,49 @@
                 <a:ea typeface="Calibri" pitchFamily="34" charset="-122"/>
                 <a:cs typeface="Calibri" pitchFamily="34" charset="-120"/>
               </a:rPr>
-              <a:t>Right: filter smartrudp.seq == N shows the same segment twice, a retransmission.</a:t>
+              <a:t>Useful filters: smartrudp.flags.data == 1 and smartrudp.seq == N.</a:t>
+            </a:r>
+            <a:endParaRPr lang="en-US" sz="1600" dirty="0"/>
+          </a:p>
+          <a:p>
+            <a:pPr marL="342900" indent="-342900">
+              <a:spcAft>
+                <a:spcPts val="600"/>
+              </a:spcAft>
+              <a:buSzPct val="100000"/>
+              <a:buChar char="•"/>
+            </a:pPr>
+            <a:r>
+              <a:rPr lang="en-US" sz="1600" dirty="0">
+                <a:solidFill>
+                  <a:srgbClr val="1B2430"/>
+                </a:solidFill>
+                <a:latin typeface="Calibri" pitchFamily="34" charset="0"/>
+                <a:ea typeface="Calibri" pitchFamily="34" charset="-122"/>
+                <a:cs typeface="Calibri" pitchFamily="34" charset="-120"/>
+              </a:rPr>
+              <a:t>In a 400-packet lossy run the receiver saw 87 (AIMD) and 95 (Smart) repeated data segments.</a:t>
+            </a:r>
+            <a:endParaRPr lang="en-US" sz="1600" dirty="0"/>
+          </a:p>
+          <a:p>
+            <a:pPr marL="342900" indent="-342900">
+              <a:spcAft>
+                <a:spcPts val="600"/>
+              </a:spcAft>
+              <a:buSzPct val="100000"/>
+              <a:buChar char="•"/>
+            </a:pPr>
+            <a:r>
+              <a:rPr lang="en-US" sz="1600" dirty="0">
+                <a:solidFill>
+                  <a:srgbClr val="1B2430"/>
+                </a:solidFill>
+                <a:latin typeface="Calibri" pitchFamily="34" charset="0"/>
+                <a:ea typeface="Calibri" pitchFamily="34" charset="-122"/>
+                <a:cs typeface="Calibri" pitchFamily="34" charset="-120"/>
+              </a:rPr>
+              <a:t>The program's exported trace uses topology addresses and has no handshake.</a:t>
             </a:r>
             <a:endParaRPr lang="en-US" sz="1600" dirty="0"/>
           </a:p>
@@ -12333,7 +12844,7 @@
                 <a:ea typeface="Calibri" pitchFamily="34" charset="-122"/>
                 <a:cs typeface="Calibri" pitchFamily="34" charset="-120"/>
               </a:rPr>
-              <a:t>If Wireshark is open live: Analyze, Decode As, UDP 8888 = RUDP, then use these two filters.</a:t>
+              <a:t>Q: Why no handshake in the export? A: The export builds synthetic packets. The real tshark capture on the next slide shows the handshake.</a:t>
             </a:r>
             <a:endParaRPr lang="en-US" sz="1400" dirty="0"/>
           </a:p>
@@ -12404,7 +12915,7 @@
                 <a:ea typeface="Calibri" pitchFamily="34" charset="-122"/>
                 <a:cs typeface="Calibri" pitchFamily="34" charset="-120"/>
               </a:rPr>
-              <a:t>19. RUDP Chat demo</a:t>
+              <a:t>19. Wireshark real capture</a:t>
             </a:r>
             <a:endParaRPr lang="en-US" sz="2600" dirty="0"/>
           </a:p>
@@ -12443,7 +12954,7 @@
                 <a:ea typeface="Calibri" pitchFamily="34" charset="-122"/>
                 <a:cs typeface="Calibri" pitchFamily="34" charset="-120"/>
               </a:rPr>
-              <a:t>Time on this slide: 1:00</a:t>
+              <a:t>Time on this slide: 0:50</a:t>
             </a:r>
             <a:endParaRPr lang="en-US" sz="1300" dirty="0"/>
           </a:p>
@@ -12588,7 +13099,7 @@
               <a:buChar char="•"/>
             </a:pPr>
             <a:r>
-              <a:rPr lang="en-US" sz="1400" dirty="0">
+              <a:rPr lang="en-US" sz="1600" dirty="0">
                 <a:solidFill>
                   <a:srgbClr val="1B2430"/>
                 </a:solidFill>
@@ -12596,9 +13107,9 @@
                 <a:ea typeface="Calibri" pitchFamily="34" charset="-122"/>
                 <a:cs typeface="Calibri" pitchFamily="34" charset="-120"/>
               </a:rPr>
-              <a:t>The protocol in use: each message is one numbered, checksummed RUDP segment, ACKed in order.</a:t>
-            </a:r>
-            <a:endParaRPr lang="en-US" sz="1400" dirty="0"/>
+              <a:t>Left: the first three packets, SYN, SYN-ACK and ACK, decoded by our dissector (filter frame.number &lt;= 3).</a:t>
+            </a:r>
+            <a:endParaRPr lang="en-US" sz="1600" dirty="0"/>
           </a:p>
           <a:p>
             <a:pPr marL="342900" indent="-342900">
@@ -12609,7 +13120,7 @@
               <a:buChar char="•"/>
             </a:pPr>
             <a:r>
-              <a:rPr lang="en-US" sz="1400" dirty="0">
+              <a:rPr lang="en-US" sz="1600" dirty="0">
                 <a:solidFill>
                   <a:srgbClr val="1B2430"/>
                 </a:solidFill>
@@ -12617,51 +13128,9 @@
                 <a:ea typeface="Calibri" pitchFamily="34" charset="-122"/>
                 <a:cs typeface="Calibri" pitchFamily="34" charset="-120"/>
               </a:rPr>
-              <a:t>There is a terminal version and a browser version; two devices were linked over Tailscale, laptop and phone.</a:t>
-            </a:r>
-            <a:endParaRPr lang="en-US" sz="1400" dirty="0"/>
-          </a:p>
-          <a:p>
-            <a:pPr marL="342900" indent="-342900">
-              <a:spcAft>
-                <a:spcPts val="600"/>
-              </a:spcAft>
-              <a:buSzPct val="100000"/>
-              <a:buChar char="•"/>
-            </a:pPr>
-            <a:r>
-              <a:rPr lang="en-US" sz="1400" dirty="0">
-                <a:solidFill>
-                  <a:srgbClr val="1B2430"/>
-                </a:solidFill>
-                <a:latin typeface="Calibri" pitchFamily="34" charset="0"/>
-                <a:ea typeface="Calibri" pitchFamily="34" charset="-122"/>
-                <a:cs typeface="Calibri" pitchFamily="34" charset="-120"/>
-              </a:rPr>
-              <a:t>Drag the loss slider: lost messages are resent and still arrive in order. The right panel shows sent, lost and resent counts and the log.</a:t>
-            </a:r>
-            <a:endParaRPr lang="en-US" sz="1400" dirty="0"/>
-          </a:p>
-          <a:p>
-            <a:pPr marL="342900" indent="-342900">
-              <a:spcAft>
-                <a:spcPts val="600"/>
-              </a:spcAft>
-              <a:buSzPct val="100000"/>
-              <a:buChar char="•"/>
-            </a:pPr>
-            <a:r>
-              <a:rPr lang="en-US" sz="1400" dirty="0">
-                <a:solidFill>
-                  <a:srgbClr val="1B2430"/>
-                </a:solidFill>
-                <a:latin typeface="Calibri" pitchFamily="34" charset="0"/>
-                <a:ea typeface="Calibri" pitchFamily="34" charset="-122"/>
-                <a:cs typeface="Calibri" pitchFamily="34" charset="-120"/>
-              </a:rPr>
-              <a:t>There is a controller switch: fixed window, AIMD, or Smart-RUDP. For the chat we retrained Smart-RUDP on simulated paths: it was faster than AIMD on 5 of 6 held-out paths and equal on 1, because AIMD resets to one packet on random loss. Say it is simulated, and that the agent may not shrink the window without a congestion signal. Stress test: 48 random paths the agent never trained on, 3 seeds each. Mean delivery time was 3.73 seconds for Smart-RUDP against 7.16 for AIMD. Smart-RUDP was faster on 27 paths, slower on 5, within 5 percent on 16. So on our data, in simulation, it beats AIMD in the chat setting.</a:t>
-            </a:r>
-            <a:endParaRPr lang="en-US" sz="1400" dirty="0"/>
+              <a:t>Right: filter smartrudp.seq == N shows the same segment twice, a retransmission.</a:t>
+            </a:r>
+            <a:endParaRPr lang="en-US" sz="1600" dirty="0"/>
           </a:p>
         </p:txBody>
       </p:sp>
@@ -12737,7 +13206,7 @@
                 <a:ea typeface="Calibri" pitchFamily="34" charset="-122"/>
                 <a:cs typeface="Calibri" pitchFamily="34" charset="-120"/>
               </a:rPr>
-              <a:t>Q: Is that a fair win? A: Both start from the same window of 10; held-out paths and seeds; honest limits: simulated, and without the no-shrink rule the agent lost. Q: Did it win in Section 8? A: No, that result stands. Q: Where does it lose? A: Tight bottleneck queues and very high loss; the fixed window of 8 is hard to beat there. A broader-trained agent did worse, so we kept the first.</a:t>
+              <a:t>If Wireshark is open live: Analyze, Decode As, UDP 8888 = RUDP, then use these two filters.</a:t>
             </a:r>
             <a:endParaRPr lang="en-US" sz="1400" dirty="0"/>
           </a:p>
@@ -12808,7 +13277,7 @@
                 <a:ea typeface="Calibri" pitchFamily="34" charset="-122"/>
                 <a:cs typeface="Calibri" pitchFamily="34" charset="-120"/>
               </a:rPr>
-              <a:t>20. Learnings and future work</a:t>
+              <a:t>20. RUDP Chat demo</a:t>
             </a:r>
             <a:endParaRPr lang="en-US" sz="2600" dirty="0"/>
           </a:p>
@@ -12847,7 +13316,7 @@
                 <a:ea typeface="Calibri" pitchFamily="34" charset="-122"/>
                 <a:cs typeface="Calibri" pitchFamily="34" charset="-120"/>
               </a:rPr>
-              <a:t>Time on this slide: 0:50</a:t>
+              <a:t>Time on this slide: 1:00</a:t>
             </a:r>
             <a:endParaRPr lang="en-US" sz="1300" dirty="0"/>
           </a:p>
@@ -12992,7 +13461,7 @@
               <a:buChar char="•"/>
             </a:pPr>
             <a:r>
-              <a:rPr lang="en-US" sz="1600" dirty="0">
+              <a:rPr lang="en-US" sz="1400" dirty="0">
                 <a:solidFill>
                   <a:srgbClr val="1B2430"/>
                 </a:solidFill>
@@ -13000,9 +13469,9 @@
                 <a:ea typeface="Calibri" pitchFamily="34" charset="-122"/>
                 <a:cs typeface="Calibri" pitchFamily="34" charset="-120"/>
               </a:rPr>
-              <a:t>Learned: reliability is a set of simple rules working together; congestion control matters as much as retransmission; testing tools fail in surprising ways.</a:t>
-            </a:r>
-            <a:endParaRPr lang="en-US" sz="1600" dirty="0"/>
+              <a:t>The protocol in use: each message is one numbered, checksummed RUDP segment, ACKed in order.</a:t>
+            </a:r>
+            <a:endParaRPr lang="en-US" sz="1400" dirty="0"/>
           </a:p>
           <a:p>
             <a:pPr marL="342900" indent="-342900">
@@ -13013,7 +13482,7 @@
               <a:buChar char="•"/>
             </a:pPr>
             <a:r>
-              <a:rPr lang="en-US" sz="1600" dirty="0">
+              <a:rPr lang="en-US" sz="1400" dirty="0">
                 <a:solidFill>
                   <a:srgbClr val="1B2430"/>
                 </a:solidFill>
@@ -13021,9 +13490,9 @@
                 <a:ea typeface="Calibri" pitchFamily="34" charset="-122"/>
                 <a:cs typeface="Calibri" pitchFamily="34" charset="-120"/>
               </a:rPr>
-              <a:t>Next: Selective Repeat with SACK, a stronger learning agent, adaptive timeout, and tests on a real multi-machine network.</a:t>
-            </a:r>
-            <a:endParaRPr lang="en-US" sz="1600" dirty="0"/>
+              <a:t>There is a terminal version and a browser version; two devices were linked over Tailscale, laptop and phone.</a:t>
+            </a:r>
+            <a:endParaRPr lang="en-US" sz="1400" dirty="0"/>
           </a:p>
           <a:p>
             <a:pPr marL="342900" indent="-342900">
@@ -13034,7 +13503,7 @@
               <a:buChar char="•"/>
             </a:pPr>
             <a:r>
-              <a:rPr lang="en-US" sz="1600" dirty="0">
+              <a:rPr lang="en-US" sz="1400" dirty="0">
                 <a:solidFill>
                   <a:srgbClr val="1B2430"/>
                 </a:solidFill>
@@ -13042,9 +13511,30 @@
                 <a:ea typeface="Calibri" pitchFamily="34" charset="-122"/>
                 <a:cs typeface="Calibri" pitchFamily="34" charset="-120"/>
               </a:rPr>
-              <a:t>Name the limits before she does: Go-Back-N, loopback-only protocol tests, Smart-RUDP not beating AIMD.</a:t>
-            </a:r>
-            <a:endParaRPr lang="en-US" sz="1600" dirty="0"/>
+              <a:t>Drag the loss slider: lost messages are resent and still arrive in order. The right panel shows sent, lost and resent counts and the log.</a:t>
+            </a:r>
+            <a:endParaRPr lang="en-US" sz="1400" dirty="0"/>
+          </a:p>
+          <a:p>
+            <a:pPr marL="342900" indent="-342900">
+              <a:spcAft>
+                <a:spcPts val="600"/>
+              </a:spcAft>
+              <a:buSzPct val="100000"/>
+              <a:buChar char="•"/>
+            </a:pPr>
+            <a:r>
+              <a:rPr lang="en-US" sz="1400" dirty="0">
+                <a:solidFill>
+                  <a:srgbClr val="1B2430"/>
+                </a:solidFill>
+                <a:latin typeface="Calibri" pitchFamily="34" charset="0"/>
+                <a:ea typeface="Calibri" pitchFamily="34" charset="-122"/>
+                <a:cs typeface="Calibri" pitchFamily="34" charset="-120"/>
+              </a:rPr>
+              <a:t>There is a controller switch: fixed window, AIMD, or Smart-RUDP. For the chat we retrained Smart-RUDP on simulated paths: it was faster than AIMD on 5 of 6 held-out paths and equal on 1, because AIMD resets to one packet on random loss. Say it is simulated, and that the agent may not shrink the window without a congestion signal. Stress test: 48 random paths the agent never trained on, 3 seeds each. Mean delivery time was 3.73 seconds for Smart-RUDP against 7.16 for AIMD. Smart-RUDP was faster on 27 paths, slower on 5, within 5 percent on 16. So on our data, in simulation, it beats AIMD in the chat setting.</a:t>
+            </a:r>
+            <a:endParaRPr lang="en-US" sz="1400" dirty="0"/>
           </a:p>
         </p:txBody>
       </p:sp>
@@ -13120,7 +13610,7 @@
                 <a:ea typeface="Calibri" pitchFamily="34" charset="-122"/>
                 <a:cs typeface="Calibri" pitchFamily="34" charset="-120"/>
               </a:rPr>
-              <a:t>End on the limits and the fix order: SACK, adaptive timeout, real-network tests.</a:t>
+              <a:t>Q: Is that a fair win? A: Both start from the same window of 10; held-out paths and seeds; honest limits: simulated, and without the no-shrink rule the agent lost. Q: Did it win in Section 8? A: No, that result stands. Q: Where does it lose? A: Tight bottleneck queues and very high loss; the fixed window of 8 is hard to beat there. A broader-trained agent did worse, so we kept the first.</a:t>
             </a:r>
             <a:endParaRPr lang="en-US" sz="1400" dirty="0"/>
           </a:p>
@@ -13191,7 +13681,7 @@
                 <a:ea typeface="Calibri" pitchFamily="34" charset="-122"/>
                 <a:cs typeface="Calibri" pitchFamily="34" charset="-120"/>
               </a:rPr>
-              <a:t>21. Thank you</a:t>
+              <a:t>21. Learnings and future work</a:t>
             </a:r>
             <a:endParaRPr lang="en-US" sz="2600" dirty="0"/>
           </a:p>
@@ -13230,7 +13720,7 @@
                 <a:ea typeface="Calibri" pitchFamily="34" charset="-122"/>
                 <a:cs typeface="Calibri" pitchFamily="34" charset="-120"/>
               </a:rPr>
-              <a:t>Time on this slide: 0:15</a:t>
+              <a:t>Time on this slide: 0:50</a:t>
             </a:r>
             <a:endParaRPr lang="en-US" sz="1300" dirty="0"/>
           </a:p>
@@ -13383,7 +13873,49 @@
                 <a:ea typeface="Calibri" pitchFamily="34" charset="-122"/>
                 <a:cs typeface="Calibri" pitchFamily="34" charset="-120"/>
               </a:rPr>
-              <a:t>Thank you. The code, report and captures are at github.com/Capsturrrr/rudp. Happy to take questions.</a:t>
+              <a:t>Learned: reliability is a set of simple rules working together; congestion control matters as much as retransmission; testing tools fail in surprising ways.</a:t>
+            </a:r>
+            <a:endParaRPr lang="en-US" sz="1600" dirty="0"/>
+          </a:p>
+          <a:p>
+            <a:pPr marL="342900" indent="-342900">
+              <a:spcAft>
+                <a:spcPts val="600"/>
+              </a:spcAft>
+              <a:buSzPct val="100000"/>
+              <a:buChar char="•"/>
+            </a:pPr>
+            <a:r>
+              <a:rPr lang="en-US" sz="1600" dirty="0">
+                <a:solidFill>
+                  <a:srgbClr val="1B2430"/>
+                </a:solidFill>
+                <a:latin typeface="Calibri" pitchFamily="34" charset="0"/>
+                <a:ea typeface="Calibri" pitchFamily="34" charset="-122"/>
+                <a:cs typeface="Calibri" pitchFamily="34" charset="-120"/>
+              </a:rPr>
+              <a:t>Next: Selective Repeat with SACK, a stronger learning agent, adaptive timeout, and tests on a real multi-machine network.</a:t>
+            </a:r>
+            <a:endParaRPr lang="en-US" sz="1600" dirty="0"/>
+          </a:p>
+          <a:p>
+            <a:pPr marL="342900" indent="-342900">
+              <a:spcAft>
+                <a:spcPts val="600"/>
+              </a:spcAft>
+              <a:buSzPct val="100000"/>
+              <a:buChar char="•"/>
+            </a:pPr>
+            <a:r>
+              <a:rPr lang="en-US" sz="1600" dirty="0">
+                <a:solidFill>
+                  <a:srgbClr val="1B2430"/>
+                </a:solidFill>
+                <a:latin typeface="Calibri" pitchFamily="34" charset="0"/>
+                <a:ea typeface="Calibri" pitchFamily="34" charset="-122"/>
+                <a:cs typeface="Calibri" pitchFamily="34" charset="-120"/>
+              </a:rPr>
+              <a:t>Name the limits before she does: Go-Back-N, loopback-only protocol tests, Smart-RUDP not beating AIMD.</a:t>
             </a:r>
             <a:endParaRPr lang="en-US" sz="1600" dirty="0"/>
           </a:p>
@@ -13461,7 +13993,7 @@
                 <a:ea typeface="Calibri" pitchFamily="34" charset="-122"/>
                 <a:cs typeface="Calibri" pitchFamily="34" charset="-120"/>
               </a:rPr>
-              <a:t>Pause and smile; hand over to questions.</a:t>
+              <a:t>End on the limits and the fix order: SACK, adaptive timeout, real-network tests.</a:t>
             </a:r>
             <a:endParaRPr lang="en-US" sz="1400" dirty="0"/>
           </a:p>
@@ -13532,7 +14064,7 @@
                 <a:ea typeface="Calibri" pitchFamily="34" charset="-122"/>
                 <a:cs typeface="Calibri" pitchFamily="34" charset="-120"/>
               </a:rPr>
-              <a:t>22. Appendix: slow start</a:t>
+              <a:t>22. Thank you</a:t>
             </a:r>
             <a:endParaRPr lang="en-US" sz="2600" dirty="0"/>
           </a:p>
@@ -13571,7 +14103,7 @@
                 <a:ea typeface="Calibri" pitchFamily="34" charset="-122"/>
                 <a:cs typeface="Calibri" pitchFamily="34" charset="-120"/>
               </a:rPr>
-              <a:t>Time on this slide: -</a:t>
+              <a:t>Time on this slide: 0:15</a:t>
             </a:r>
             <a:endParaRPr lang="en-US" sz="1300" dirty="0"/>
           </a:p>
@@ -13724,7 +14256,7 @@
                 <a:ea typeface="Calibri" pitchFamily="34" charset="-122"/>
                 <a:cs typeface="Calibri" pitchFamily="34" charset="-120"/>
               </a:rPr>
-              <a:t>Only if asked: the window starts at 1, adds 1 per ACK until the threshold 16, then 1/window per ACK. In the 62-packet run the final window was 18.71.</a:t>
+              <a:t>Thank you. The code, report and captures are at github.com/Capsturrrr/rudp. Happy to take questions.</a:t>
             </a:r>
             <a:endParaRPr lang="en-US" sz="1600" dirty="0"/>
           </a:p>
@@ -13802,7 +14334,7 @@
                 <a:ea typeface="Calibri" pitchFamily="34" charset="-122"/>
                 <a:cs typeface="Calibri" pitchFamily="34" charset="-120"/>
               </a:rPr>
-              <a:t>Use this slide to answer 'show me congestion avoidance'.</a:t>
+              <a:t>Pause and smile; hand over to questions.</a:t>
             </a:r>
             <a:endParaRPr lang="en-US" sz="1400" dirty="0"/>
           </a:p>
@@ -13873,7 +14405,7 @@
                 <a:ea typeface="Calibri" pitchFamily="34" charset="-122"/>
                 <a:cs typeface="Calibri" pitchFamily="34" charset="-120"/>
               </a:rPr>
-              <a:t>Hard questions and short answers (1 of 2)</a:t>
+              <a:t>23. Appendix: slow start</a:t>
             </a:r>
             <a:endParaRPr lang="en-US" sz="2600" dirty="0"/>
           </a:p>
@@ -13881,7 +14413,46 @@
       </p:sp>
       <p:sp>
         <p:nvSpPr>
-          <p:cNvPr id="3" name="Shape 1"/>
+          <p:cNvPr id="3" name="Text 1"/>
+          <p:cNvSpPr/>
+          <p:nvPr/>
+        </p:nvSpPr>
+        <p:spPr>
+          <a:xfrm>
+            <a:off x="457200" y="804672"/>
+            <a:ext cx="10972800" cy="320040"/>
+          </a:xfrm>
+          <a:prstGeom prst="rect">
+            <a:avLst/>
+          </a:prstGeom>
+          <a:noFill/>
+          <a:ln/>
+        </p:spPr>
+        <p:txBody>
+          <a:bodyPr wrap="square" lIns="0" tIns="0" rIns="0" bIns="0" rtlCol="0" anchor="ctr"/>
+          <a:lstStyle/>
+          <a:p>
+            <a:pPr indent="0" marL="0">
+              <a:buNone/>
+            </a:pPr>
+            <a:r>
+              <a:rPr lang="en-US" sz="1300" dirty="0">
+                <a:solidFill>
+                  <a:srgbClr val="5B6775"/>
+                </a:solidFill>
+                <a:latin typeface="Calibri" pitchFamily="34" charset="0"/>
+                <a:ea typeface="Calibri" pitchFamily="34" charset="-122"/>
+                <a:cs typeface="Calibri" pitchFamily="34" charset="-120"/>
+              </a:rPr>
+              <a:t>Time on this slide: -</a:t>
+            </a:r>
+            <a:endParaRPr lang="en-US" sz="1300" dirty="0"/>
+          </a:p>
+        </p:txBody>
+      </p:sp>
+      <p:sp>
+        <p:nvSpPr>
+          <p:cNvPr id="4" name="Shape 2"/>
           <p:cNvSpPr/>
           <p:nvPr/>
         </p:nvSpPr>
@@ -13904,26 +14475,47 @@
           </a:ln>
         </p:spPr>
       </p:sp>
-      <p:sp>
-        <p:nvSpPr>
-          <p:cNvPr id="4" name="Shape 2"/>
-          <p:cNvSpPr/>
-          <p:nvPr/>
-        </p:nvSpPr>
+      <p:pic>
+        <p:nvPicPr>
+          <p:cNvPr id="5" name="Image 0" descr="th-23.png">    </p:cNvPr>
+          <p:cNvPicPr>
+            <a:picLocks noChangeAspect="1"/>
+          </p:cNvPicPr>
+          <p:nvPr/>
+        </p:nvPicPr>
+        <p:blipFill>
+          <a:blip r:embed="rId1"/>
+          <a:stretch>
+            <a:fillRect/>
+          </a:stretch>
+        </p:blipFill>
         <p:spPr>
           <a:xfrm>
             <a:off x="457200" y="1371600"/>
-            <a:ext cx="11274552" cy="914400"/>
-          </a:xfrm>
-          <a:prstGeom prst="rect">
-            <a:avLst/>
-          </a:prstGeom>
-          <a:solidFill>
-            <a:srgbClr val="F2F6FB"/>
-          </a:solidFill>
-          <a:ln w="9525">
+            <a:ext cx="5669280" cy="3188970"/>
+          </a:xfrm>
+          <a:prstGeom prst="rect">
+            <a:avLst/>
+          </a:prstGeom>
+        </p:spPr>
+      </p:pic>
+      <p:sp>
+        <p:nvSpPr>
+          <p:cNvPr id="6" name="Shape 3"/>
+          <p:cNvSpPr/>
+          <p:nvPr/>
+        </p:nvSpPr>
+        <p:spPr>
+          <a:xfrm>
+            <a:off x="457200" y="1371600"/>
+            <a:ext cx="5669280" cy="3188970"/>
+          </a:xfrm>
+          <a:prstGeom prst="rect">
+            <a:avLst/>
+          </a:prstGeom>
+          <a:ln w="12700">
             <a:solidFill>
-              <a:srgbClr val="D5DEE9"/>
+              <a:srgbClr val="C9D3E0"/>
             </a:solidFill>
             <a:prstDash val="solid"/>
           </a:ln>
@@ -13931,14 +14523,14 @@
       </p:sp>
       <p:sp>
         <p:nvSpPr>
-          <p:cNvPr id="5" name="Text 3"/>
-          <p:cNvSpPr/>
-          <p:nvPr/>
-        </p:nvSpPr>
-        <p:spPr>
-          <a:xfrm>
-            <a:off x="640080" y="1417320"/>
-            <a:ext cx="10972800" cy="320040"/>
+          <p:cNvPr id="7" name="Text 4"/>
+          <p:cNvSpPr/>
+          <p:nvPr/>
+        </p:nvSpPr>
+        <p:spPr>
+          <a:xfrm>
+            <a:off x="6400800" y="1325880"/>
+            <a:ext cx="1828800" cy="320040"/>
           </a:xfrm>
           <a:prstGeom prst="rect">
             <a:avLst/>
@@ -13954,7 +14546,7 @@
               <a:buNone/>
             </a:pPr>
             <a:r>
-              <a:rPr lang="en-US" sz="1500" b="1" dirty="0">
+              <a:rPr lang="en-US" sz="1300" b="1" dirty="0">
                 <a:solidFill>
                   <a:srgbClr val="1F6FEB"/>
                 </a:solidFill>
@@ -13962,22 +14554,22 @@
                 <a:ea typeface="Calibri" pitchFamily="34" charset="-122"/>
                 <a:cs typeface="Calibri" pitchFamily="34" charset="-120"/>
               </a:rPr>
-              <a:t>Is this a lab exercise?</a:t>
-            </a:r>
-            <a:endParaRPr lang="en-US" sz="1500" dirty="0"/>
-          </a:p>
-        </p:txBody>
-      </p:sp>
-      <p:sp>
-        <p:nvSpPr>
-          <p:cNvPr id="6" name="Text 4"/>
-          <p:cNvSpPr/>
-          <p:nvPr/>
-        </p:nvSpPr>
-        <p:spPr>
-          <a:xfrm>
-            <a:off x="640080" y="1737360"/>
-            <a:ext cx="10972800" cy="530352"/>
+              <a:t>SAY</a:t>
+            </a:r>
+            <a:endParaRPr lang="en-US" sz="1300" dirty="0"/>
+          </a:p>
+        </p:txBody>
+      </p:sp>
+      <p:sp>
+        <p:nvSpPr>
+          <p:cNvPr id="8" name="Text 5"/>
+          <p:cNvSpPr/>
+          <p:nvPr/>
+        </p:nvSpPr>
+        <p:spPr>
+          <a:xfrm>
+            <a:off x="6400800" y="1645920"/>
+            <a:ext cx="5349240" cy="3017520"/>
           </a:xfrm>
           <a:prstGeom prst="rect">
             <a:avLst/>
@@ -13989,11 +14581,15 @@
           <a:bodyPr wrap="square" lIns="0" tIns="0" rIns="0" bIns="0" rtlCol="0" anchor="t"/>
           <a:lstStyle/>
           <a:p>
-            <a:pPr indent="0" marL="0">
-              <a:buNone/>
-            </a:pPr>
-            <a:r>
-              <a:rPr lang="en-US" sz="1350" dirty="0">
+            <a:pPr marL="342900" indent="-342900">
+              <a:spcAft>
+                <a:spcPts val="600"/>
+              </a:spcAft>
+              <a:buSzPct val="100000"/>
+              <a:buChar char="•"/>
+            </a:pPr>
+            <a:r>
+              <a:rPr lang="en-US" sz="1600" dirty="0">
                 <a:solidFill>
                   <a:srgbClr val="1B2430"/>
                 </a:solidFill>
@@ -14001,32 +14597,32 @@
                 <a:ea typeface="Calibri" pitchFamily="34" charset="-122"/>
                 <a:cs typeface="Calibri" pitchFamily="34" charset="-120"/>
               </a:rPr>
-              <a:t>A lab sends datagrams. We built reliability and congestion control on top, measured them, and used them in a real chat and a routed network.</a:t>
-            </a:r>
-            <a:endParaRPr lang="en-US" sz="1350" dirty="0"/>
-          </a:p>
-        </p:txBody>
-      </p:sp>
-      <p:sp>
-        <p:nvSpPr>
-          <p:cNvPr id="7" name="Shape 5"/>
-          <p:cNvSpPr/>
-          <p:nvPr/>
-        </p:nvSpPr>
-        <p:spPr>
-          <a:xfrm>
-            <a:off x="457200" y="2377440"/>
-            <a:ext cx="11274552" cy="914400"/>
+              <a:t>Only if asked: the window starts at 1, adds 1 per ACK until the threshold 16, then 1/window per ACK. In the 62-packet run the final window was 18.71.</a:t>
+            </a:r>
+            <a:endParaRPr lang="en-US" sz="1600" dirty="0"/>
+          </a:p>
+        </p:txBody>
+      </p:sp>
+      <p:sp>
+        <p:nvSpPr>
+          <p:cNvPr id="9" name="Shape 6"/>
+          <p:cNvSpPr/>
+          <p:nvPr/>
+        </p:nvSpPr>
+        <p:spPr>
+          <a:xfrm>
+            <a:off x="457200" y="4709160"/>
+            <a:ext cx="5669280" cy="1737360"/>
           </a:xfrm>
           <a:prstGeom prst="rect">
             <a:avLst/>
           </a:prstGeom>
           <a:solidFill>
-            <a:srgbClr val="F2F6FB"/>
+            <a:srgbClr val="FFF6E5"/>
           </a:solidFill>
-          <a:ln w="9525">
+          <a:ln w="12700">
             <a:solidFill>
-              <a:srgbClr val="D5DEE9"/>
+              <a:srgbClr val="F0C987"/>
             </a:solidFill>
             <a:prstDash val="solid"/>
           </a:ln>
@@ -14034,14 +14630,14 @@
       </p:sp>
       <p:sp>
         <p:nvSpPr>
-          <p:cNvPr id="8" name="Text 6"/>
-          <p:cNvSpPr/>
-          <p:nvPr/>
-        </p:nvSpPr>
-        <p:spPr>
-          <a:xfrm>
-            <a:off x="640080" y="2423160"/>
-            <a:ext cx="10972800" cy="320040"/>
+          <p:cNvPr id="10" name="Text 7"/>
+          <p:cNvSpPr/>
+          <p:nvPr/>
+        </p:nvSpPr>
+        <p:spPr>
+          <a:xfrm>
+            <a:off x="594360" y="4754880"/>
+            <a:ext cx="5394960" cy="1645920"/>
           </a:xfrm>
           <a:prstGeom prst="rect">
             <a:avLst/>
@@ -14050,53 +14646,28 @@
           <a:ln/>
         </p:spPr>
         <p:txBody>
-          <a:bodyPr wrap="square" lIns="0" tIns="0" rIns="0" bIns="0" rtlCol="0" anchor="ctr"/>
+          <a:bodyPr wrap="square" lIns="0" tIns="0" rIns="0" bIns="0" rtlCol="0" anchor="t"/>
           <a:lstStyle/>
           <a:p>
             <a:pPr indent="0" marL="0">
               <a:buNone/>
             </a:pPr>
             <a:r>
-              <a:rPr lang="en-US" sz="1500" b="1" dirty="0">
-                <a:solidFill>
-                  <a:srgbClr val="1F6FEB"/>
-                </a:solidFill>
-                <a:latin typeface="Calibri" pitchFamily="34" charset="0"/>
-                <a:ea typeface="Calibri" pitchFamily="34" charset="-122"/>
-                <a:cs typeface="Calibri" pitchFamily="34" charset="-120"/>
-              </a:rPr>
-              <a:t>Why not TCP?</a:t>
-            </a:r>
-            <a:endParaRPr lang="en-US" sz="1500" dirty="0"/>
-          </a:p>
-        </p:txBody>
-      </p:sp>
-      <p:sp>
-        <p:nvSpPr>
-          <p:cNvPr id="9" name="Text 7"/>
-          <p:cNvSpPr/>
-          <p:nvPr/>
-        </p:nvSpPr>
-        <p:spPr>
-          <a:xfrm>
-            <a:off x="640080" y="2743200"/>
-            <a:ext cx="10972800" cy="530352"/>
-          </a:xfrm>
-          <a:prstGeom prst="rect">
-            <a:avLst/>
-          </a:prstGeom>
-          <a:noFill/>
-          <a:ln/>
-        </p:spPr>
-        <p:txBody>
-          <a:bodyPr wrap="square" lIns="0" tIns="0" rIns="0" bIns="0" rtlCol="0" anchor="t"/>
-          <a:lstStyle/>
-          <a:p>
+              <a:rPr lang="en-US" sz="1400" b="1" dirty="0">
+                <a:solidFill>
+                  <a:srgbClr val="B45309"/>
+                </a:solidFill>
+                <a:latin typeface="Calibri" pitchFamily="34" charset="0"/>
+                <a:ea typeface="Calibri" pitchFamily="34" charset="-122"/>
+                <a:cs typeface="Calibri" pitchFamily="34" charset="-120"/>
+              </a:rPr>
+              <a:t>IF ASKED  </a:t>
+            </a:r>
             <a:pPr indent="0" marL="0">
               <a:buNone/>
             </a:pPr>
             <a:r>
-              <a:rPr lang="en-US" sz="1350" dirty="0">
+              <a:rPr lang="en-US" sz="1400" dirty="0">
                 <a:solidFill>
                   <a:srgbClr val="1B2430"/>
                 </a:solidFill>
@@ -14104,318 +14675,9 @@
                 <a:ea typeface="Calibri" pitchFamily="34" charset="-122"/>
                 <a:cs typeface="Calibri" pitchFamily="34" charset="-120"/>
               </a:rPr>
-              <a:t>TCP is in the kernel and cannot be changed. Building our own makes every mechanism visible. QUIC and HTTP/3 do the same.</a:t>
-            </a:r>
-            <a:endParaRPr lang="en-US" sz="1350" dirty="0"/>
-          </a:p>
-        </p:txBody>
-      </p:sp>
-      <p:sp>
-        <p:nvSpPr>
-          <p:cNvPr id="10" name="Shape 8"/>
-          <p:cNvSpPr/>
-          <p:nvPr/>
-        </p:nvSpPr>
-        <p:spPr>
-          <a:xfrm>
-            <a:off x="457200" y="3383280"/>
-            <a:ext cx="11274552" cy="914400"/>
-          </a:xfrm>
-          <a:prstGeom prst="rect">
-            <a:avLst/>
-          </a:prstGeom>
-          <a:solidFill>
-            <a:srgbClr val="F2F6FB"/>
-          </a:solidFill>
-          <a:ln w="9525">
-            <a:solidFill>
-              <a:srgbClr val="D5DEE9"/>
-            </a:solidFill>
-            <a:prstDash val="solid"/>
-          </a:ln>
-        </p:spPr>
-      </p:sp>
-      <p:sp>
-        <p:nvSpPr>
-          <p:cNvPr id="11" name="Text 9"/>
-          <p:cNvSpPr/>
-          <p:nvPr/>
-        </p:nvSpPr>
-        <p:spPr>
-          <a:xfrm>
-            <a:off x="640080" y="3429000"/>
-            <a:ext cx="10972800" cy="320040"/>
-          </a:xfrm>
-          <a:prstGeom prst="rect">
-            <a:avLst/>
-          </a:prstGeom>
-          <a:noFill/>
-          <a:ln/>
-        </p:spPr>
-        <p:txBody>
-          <a:bodyPr wrap="square" lIns="0" tIns="0" rIns="0" bIns="0" rtlCol="0" anchor="ctr"/>
-          <a:lstStyle/>
-          <a:p>
-            <a:pPr indent="0" marL="0">
-              <a:buNone/>
-            </a:pPr>
-            <a:r>
-              <a:rPr lang="en-US" sz="1500" b="1" dirty="0">
-                <a:solidFill>
-                  <a:srgbClr val="1F6FEB"/>
-                </a:solidFill>
-                <a:latin typeface="Calibri" pitchFamily="34" charset="0"/>
-                <a:ea typeface="Calibri" pitchFamily="34" charset="-122"/>
-                <a:cs typeface="Calibri" pitchFamily="34" charset="-120"/>
-              </a:rPr>
-              <a:t>Did Smart-RUDP win?</a:t>
-            </a:r>
-            <a:endParaRPr lang="en-US" sz="1500" dirty="0"/>
-          </a:p>
-        </p:txBody>
-      </p:sp>
-      <p:sp>
-        <p:nvSpPr>
-          <p:cNvPr id="12" name="Text 10"/>
-          <p:cNvSpPr/>
-          <p:nvPr/>
-        </p:nvSpPr>
-        <p:spPr>
-          <a:xfrm>
-            <a:off x="640080" y="3749040"/>
-            <a:ext cx="10972800" cy="530352"/>
-          </a:xfrm>
-          <a:prstGeom prst="rect">
-            <a:avLst/>
-          </a:prstGeom>
-          <a:noFill/>
-          <a:ln/>
-        </p:spPr>
-        <p:txBody>
-          <a:bodyPr wrap="square" lIns="0" tIns="0" rIns="0" bIns="0" rtlCol="0" anchor="t"/>
-          <a:lstStyle/>
-          <a:p>
-            <a:pPr indent="0" marL="0">
-              <a:buNone/>
-            </a:pPr>
-            <a:r>
-              <a:rPr lang="en-US" sz="1350" dirty="0">
-                <a:solidFill>
-                  <a:srgbClr val="1B2430"/>
-                </a:solidFill>
-                <a:latin typeface="Calibri" pitchFamily="34" charset="0"/>
-                <a:ea typeface="Calibri" pitchFamily="34" charset="-122"/>
-                <a:cs typeface="Calibri" pitchFamily="34" charset="-120"/>
-              </a:rPr>
-              <a:t>Experiments: tied on one path, slower on two, and we say so. Chat, retrained on simulated paths: faster than AIMD on 5 of 6 held-out paths, equal on 1, because AIMD resets to 1 on every timeout. Stress test on 48 unseen random paths: mean 3.73 s Smart vs 7.16 s AIMD; faster on 27, slower on 5, within 5% on 16. Simulated; same start window 10; agent may not shrink without a congestion signal.</a:t>
-            </a:r>
-            <a:endParaRPr lang="en-US" sz="1350" dirty="0"/>
-          </a:p>
-        </p:txBody>
-      </p:sp>
-      <p:sp>
-        <p:nvSpPr>
-          <p:cNvPr id="13" name="Shape 11"/>
-          <p:cNvSpPr/>
-          <p:nvPr/>
-        </p:nvSpPr>
-        <p:spPr>
-          <a:xfrm>
-            <a:off x="457200" y="4389120"/>
-            <a:ext cx="11274552" cy="914400"/>
-          </a:xfrm>
-          <a:prstGeom prst="rect">
-            <a:avLst/>
-          </a:prstGeom>
-          <a:solidFill>
-            <a:srgbClr val="F2F6FB"/>
-          </a:solidFill>
-          <a:ln w="9525">
-            <a:solidFill>
-              <a:srgbClr val="D5DEE9"/>
-            </a:solidFill>
-            <a:prstDash val="solid"/>
-          </a:ln>
-        </p:spPr>
-      </p:sp>
-      <p:sp>
-        <p:nvSpPr>
-          <p:cNvPr id="14" name="Text 12"/>
-          <p:cNvSpPr/>
-          <p:nvPr/>
-        </p:nvSpPr>
-        <p:spPr>
-          <a:xfrm>
-            <a:off x="640080" y="4434840"/>
-            <a:ext cx="10972800" cy="320040"/>
-          </a:xfrm>
-          <a:prstGeom prst="rect">
-            <a:avLst/>
-          </a:prstGeom>
-          <a:noFill/>
-          <a:ln/>
-        </p:spPr>
-        <p:txBody>
-          <a:bodyPr wrap="square" lIns="0" tIns="0" rIns="0" bIns="0" rtlCol="0" anchor="ctr"/>
-          <a:lstStyle/>
-          <a:p>
-            <a:pPr indent="0" marL="0">
-              <a:buNone/>
-            </a:pPr>
-            <a:r>
-              <a:rPr lang="en-US" sz="1500" b="1" dirty="0">
-                <a:solidFill>
-                  <a:srgbClr val="1F6FEB"/>
-                </a:solidFill>
-                <a:latin typeface="Calibri" pitchFamily="34" charset="0"/>
-                <a:ea typeface="Calibri" pitchFamily="34" charset="-122"/>
-                <a:cs typeface="Calibri" pitchFamily="34" charset="-120"/>
-              </a:rPr>
-              <a:t>Why Go-Back-N?</a:t>
-            </a:r>
-            <a:endParaRPr lang="en-US" sz="1500" dirty="0"/>
-          </a:p>
-        </p:txBody>
-      </p:sp>
-      <p:sp>
-        <p:nvSpPr>
-          <p:cNvPr id="15" name="Text 13"/>
-          <p:cNvSpPr/>
-          <p:nvPr/>
-        </p:nvSpPr>
-        <p:spPr>
-          <a:xfrm>
-            <a:off x="640080" y="4754880"/>
-            <a:ext cx="10972800" cy="530352"/>
-          </a:xfrm>
-          <a:prstGeom prst="rect">
-            <a:avLst/>
-          </a:prstGeom>
-          <a:noFill/>
-          <a:ln/>
-        </p:spPr>
-        <p:txBody>
-          <a:bodyPr wrap="square" lIns="0" tIns="0" rIns="0" bIns="0" rtlCol="0" anchor="t"/>
-          <a:lstStyle/>
-          <a:p>
-            <a:pPr indent="0" marL="0">
-              <a:buNone/>
-            </a:pPr>
-            <a:r>
-              <a:rPr lang="en-US" sz="1350" dirty="0">
-                <a:solidFill>
-                  <a:srgbClr val="1B2430"/>
-                </a:solidFill>
-                <a:latin typeface="Calibri" pitchFamily="34" charset="0"/>
-                <a:ea typeface="Calibri" pitchFamily="34" charset="-122"/>
-                <a:cs typeface="Calibri" pitchFamily="34" charset="-120"/>
-              </a:rPr>
-              <a:t>Simpler to build and explain. It wastes bandwidth under loss; Selective Repeat with SACK is future work.</a:t>
-            </a:r>
-            <a:endParaRPr lang="en-US" sz="1350" dirty="0"/>
-          </a:p>
-        </p:txBody>
-      </p:sp>
-      <p:sp>
-        <p:nvSpPr>
-          <p:cNvPr id="16" name="Shape 14"/>
-          <p:cNvSpPr/>
-          <p:nvPr/>
-        </p:nvSpPr>
-        <p:spPr>
-          <a:xfrm>
-            <a:off x="457200" y="5394960"/>
-            <a:ext cx="11274552" cy="914400"/>
-          </a:xfrm>
-          <a:prstGeom prst="rect">
-            <a:avLst/>
-          </a:prstGeom>
-          <a:solidFill>
-            <a:srgbClr val="F2F6FB"/>
-          </a:solidFill>
-          <a:ln w="9525">
-            <a:solidFill>
-              <a:srgbClr val="D5DEE9"/>
-            </a:solidFill>
-            <a:prstDash val="solid"/>
-          </a:ln>
-        </p:spPr>
-      </p:sp>
-      <p:sp>
-        <p:nvSpPr>
-          <p:cNvPr id="17" name="Text 15"/>
-          <p:cNvSpPr/>
-          <p:nvPr/>
-        </p:nvSpPr>
-        <p:spPr>
-          <a:xfrm>
-            <a:off x="640080" y="5440680"/>
-            <a:ext cx="10972800" cy="320040"/>
-          </a:xfrm>
-          <a:prstGeom prst="rect">
-            <a:avLst/>
-          </a:prstGeom>
-          <a:noFill/>
-          <a:ln/>
-        </p:spPr>
-        <p:txBody>
-          <a:bodyPr wrap="square" lIns="0" tIns="0" rIns="0" bIns="0" rtlCol="0" anchor="ctr"/>
-          <a:lstStyle/>
-          <a:p>
-            <a:pPr indent="0" marL="0">
-              <a:buNone/>
-            </a:pPr>
-            <a:r>
-              <a:rPr lang="en-US" sz="1500" b="1" dirty="0">
-                <a:solidFill>
-                  <a:srgbClr val="1F6FEB"/>
-                </a:solidFill>
-                <a:latin typeface="Calibri" pitchFamily="34" charset="0"/>
-                <a:ea typeface="Calibri" pitchFamily="34" charset="-122"/>
-                <a:cs typeface="Calibri" pitchFamily="34" charset="-120"/>
-              </a:rPr>
-              <a:t>Tests ran on one machine?</a:t>
-            </a:r>
-            <a:endParaRPr lang="en-US" sz="1500" dirty="0"/>
-          </a:p>
-        </p:txBody>
-      </p:sp>
-      <p:sp>
-        <p:nvSpPr>
-          <p:cNvPr id="18" name="Text 16"/>
-          <p:cNvSpPr/>
-          <p:nvPr/>
-        </p:nvSpPr>
-        <p:spPr>
-          <a:xfrm>
-            <a:off x="640080" y="5760720"/>
-            <a:ext cx="10972800" cy="530352"/>
-          </a:xfrm>
-          <a:prstGeom prst="rect">
-            <a:avLst/>
-          </a:prstGeom>
-          <a:noFill/>
-          <a:ln/>
-        </p:spPr>
-        <p:txBody>
-          <a:bodyPr wrap="square" lIns="0" tIns="0" rIns="0" bIns="0" rtlCol="0" anchor="t"/>
-          <a:lstStyle/>
-          <a:p>
-            <a:pPr indent="0" marL="0">
-              <a:buNone/>
-            </a:pPr>
-            <a:r>
-              <a:rPr lang="en-US" sz="1350" dirty="0">
-                <a:solidFill>
-                  <a:srgbClr val="1B2430"/>
-                </a:solidFill>
-                <a:latin typeface="Calibri" pitchFamily="34" charset="0"/>
-                <a:ea typeface="Calibri" pitchFamily="34" charset="-122"/>
-                <a:cs typeface="Calibri" pitchFamily="34" charset="-120"/>
-              </a:rPr>
-              <a:t>Yes, with emulated delay, loss and jitter. They do not prove internet performance; the report says so. Chat between laptop and phone is a small real-network check.</a:t>
-            </a:r>
-            <a:endParaRPr lang="en-US" sz="1350" dirty="0"/>
+              <a:t>Use this slide to answer 'show me congestion avoidance'.</a:t>
+            </a:r>
+            <a:endParaRPr lang="en-US" sz="1400" dirty="0"/>
           </a:p>
         </p:txBody>
       </p:sp>
@@ -14430,6 +14692,617 @@
 <file path=ppt/slides/slide26.xml><?xml version="1.0" encoding="utf-8"?>
 <p:sld xmlns:a="http://schemas.openxmlformats.org/drawingml/2006/main" xmlns:r="http://schemas.openxmlformats.org/officeDocument/2006/relationships" xmlns:p="http://schemas.openxmlformats.org/presentationml/2006/main">
   <p:cSld name="Slide 26">
+    <p:bg>
+      <p:bgPr>
+        <a:solidFill>
+          <a:srgbClr val="FFFFFF"/>
+        </a:solidFill>
+      </p:bgPr>
+    </p:bg>
+    <p:spTree>
+      <p:nvGrpSpPr>
+        <p:cNvPr id="1" name=""/>
+        <p:cNvGrpSpPr/>
+        <p:nvPr/>
+      </p:nvGrpSpPr>
+      <p:grpSpPr>
+        <a:xfrm>
+          <a:off x="0" y="0"/>
+          <a:ext cx="0" cy="0"/>
+          <a:chOff x="0" y="0"/>
+          <a:chExt cx="0" cy="0"/>
+        </a:xfrm>
+      </p:grpSpPr>
+      <p:sp>
+        <p:nvSpPr>
+          <p:cNvPr id="2" name="Text 0"/>
+          <p:cNvSpPr/>
+          <p:nvPr/>
+        </p:nvSpPr>
+        <p:spPr>
+          <a:xfrm>
+            <a:off x="457200" y="274320"/>
+            <a:ext cx="9601200" cy="548640"/>
+          </a:xfrm>
+          <a:prstGeom prst="rect">
+            <a:avLst/>
+          </a:prstGeom>
+          <a:noFill/>
+          <a:ln/>
+        </p:spPr>
+        <p:txBody>
+          <a:bodyPr wrap="square" lIns="0" tIns="0" rIns="0" bIns="0" rtlCol="0" anchor="ctr"/>
+          <a:lstStyle/>
+          <a:p>
+            <a:pPr indent="0" marL="0">
+              <a:buNone/>
+            </a:pPr>
+            <a:r>
+              <a:rPr lang="en-US" sz="2600" b="1" dirty="0">
+                <a:solidFill>
+                  <a:srgbClr val="1B2430"/>
+                </a:solidFill>
+                <a:latin typeface="Calibri" pitchFamily="34" charset="0"/>
+                <a:ea typeface="Calibri" pitchFamily="34" charset="-122"/>
+                <a:cs typeface="Calibri" pitchFamily="34" charset="-120"/>
+              </a:rPr>
+              <a:t>Hard questions and short answers (1 of 2)</a:t>
+            </a:r>
+            <a:endParaRPr lang="en-US" sz="2600" dirty="0"/>
+          </a:p>
+        </p:txBody>
+      </p:sp>
+      <p:sp>
+        <p:nvSpPr>
+          <p:cNvPr id="3" name="Shape 1"/>
+          <p:cNvSpPr/>
+          <p:nvPr/>
+        </p:nvSpPr>
+        <p:spPr>
+          <a:xfrm>
+            <a:off x="457200" y="1143000"/>
+            <a:ext cx="11274552" cy="36576"/>
+          </a:xfrm>
+          <a:prstGeom prst="rect">
+            <a:avLst/>
+          </a:prstGeom>
+          <a:solidFill>
+            <a:srgbClr val="1F6FEB"/>
+          </a:solidFill>
+          <a:ln w="12700">
+            <a:solidFill>
+              <a:srgbClr val="1F6FEB"/>
+            </a:solidFill>
+            <a:prstDash val="solid"/>
+          </a:ln>
+        </p:spPr>
+      </p:sp>
+      <p:sp>
+        <p:nvSpPr>
+          <p:cNvPr id="4" name="Shape 2"/>
+          <p:cNvSpPr/>
+          <p:nvPr/>
+        </p:nvSpPr>
+        <p:spPr>
+          <a:xfrm>
+            <a:off x="457200" y="1371600"/>
+            <a:ext cx="11274552" cy="914400"/>
+          </a:xfrm>
+          <a:prstGeom prst="rect">
+            <a:avLst/>
+          </a:prstGeom>
+          <a:solidFill>
+            <a:srgbClr val="F2F6FB"/>
+          </a:solidFill>
+          <a:ln w="9525">
+            <a:solidFill>
+              <a:srgbClr val="D5DEE9"/>
+            </a:solidFill>
+            <a:prstDash val="solid"/>
+          </a:ln>
+        </p:spPr>
+      </p:sp>
+      <p:sp>
+        <p:nvSpPr>
+          <p:cNvPr id="5" name="Text 3"/>
+          <p:cNvSpPr/>
+          <p:nvPr/>
+        </p:nvSpPr>
+        <p:spPr>
+          <a:xfrm>
+            <a:off x="640080" y="1417320"/>
+            <a:ext cx="10972800" cy="320040"/>
+          </a:xfrm>
+          <a:prstGeom prst="rect">
+            <a:avLst/>
+          </a:prstGeom>
+          <a:noFill/>
+          <a:ln/>
+        </p:spPr>
+        <p:txBody>
+          <a:bodyPr wrap="square" lIns="0" tIns="0" rIns="0" bIns="0" rtlCol="0" anchor="ctr"/>
+          <a:lstStyle/>
+          <a:p>
+            <a:pPr indent="0" marL="0">
+              <a:buNone/>
+            </a:pPr>
+            <a:r>
+              <a:rPr lang="en-US" sz="1500" b="1" dirty="0">
+                <a:solidFill>
+                  <a:srgbClr val="1F6FEB"/>
+                </a:solidFill>
+                <a:latin typeface="Calibri" pitchFamily="34" charset="0"/>
+                <a:ea typeface="Calibri" pitchFamily="34" charset="-122"/>
+                <a:cs typeface="Calibri" pitchFamily="34" charset="-120"/>
+              </a:rPr>
+              <a:t>Is this a lab exercise?</a:t>
+            </a:r>
+            <a:endParaRPr lang="en-US" sz="1500" dirty="0"/>
+          </a:p>
+        </p:txBody>
+      </p:sp>
+      <p:sp>
+        <p:nvSpPr>
+          <p:cNvPr id="6" name="Text 4"/>
+          <p:cNvSpPr/>
+          <p:nvPr/>
+        </p:nvSpPr>
+        <p:spPr>
+          <a:xfrm>
+            <a:off x="640080" y="1737360"/>
+            <a:ext cx="10972800" cy="530352"/>
+          </a:xfrm>
+          <a:prstGeom prst="rect">
+            <a:avLst/>
+          </a:prstGeom>
+          <a:noFill/>
+          <a:ln/>
+        </p:spPr>
+        <p:txBody>
+          <a:bodyPr wrap="square" lIns="0" tIns="0" rIns="0" bIns="0" rtlCol="0" anchor="t"/>
+          <a:lstStyle/>
+          <a:p>
+            <a:pPr indent="0" marL="0">
+              <a:buNone/>
+            </a:pPr>
+            <a:r>
+              <a:rPr lang="en-US" sz="1350" dirty="0">
+                <a:solidFill>
+                  <a:srgbClr val="1B2430"/>
+                </a:solidFill>
+                <a:latin typeface="Calibri" pitchFamily="34" charset="0"/>
+                <a:ea typeface="Calibri" pitchFamily="34" charset="-122"/>
+                <a:cs typeface="Calibri" pitchFamily="34" charset="-120"/>
+              </a:rPr>
+              <a:t>A lab sends datagrams. We built reliability and congestion control on top, measured them, and used them in a real chat and a routed network.</a:t>
+            </a:r>
+            <a:endParaRPr lang="en-US" sz="1350" dirty="0"/>
+          </a:p>
+        </p:txBody>
+      </p:sp>
+      <p:sp>
+        <p:nvSpPr>
+          <p:cNvPr id="7" name="Shape 5"/>
+          <p:cNvSpPr/>
+          <p:nvPr/>
+        </p:nvSpPr>
+        <p:spPr>
+          <a:xfrm>
+            <a:off x="457200" y="2377440"/>
+            <a:ext cx="11274552" cy="914400"/>
+          </a:xfrm>
+          <a:prstGeom prst="rect">
+            <a:avLst/>
+          </a:prstGeom>
+          <a:solidFill>
+            <a:srgbClr val="F2F6FB"/>
+          </a:solidFill>
+          <a:ln w="9525">
+            <a:solidFill>
+              <a:srgbClr val="D5DEE9"/>
+            </a:solidFill>
+            <a:prstDash val="solid"/>
+          </a:ln>
+        </p:spPr>
+      </p:sp>
+      <p:sp>
+        <p:nvSpPr>
+          <p:cNvPr id="8" name="Text 6"/>
+          <p:cNvSpPr/>
+          <p:nvPr/>
+        </p:nvSpPr>
+        <p:spPr>
+          <a:xfrm>
+            <a:off x="640080" y="2423160"/>
+            <a:ext cx="10972800" cy="320040"/>
+          </a:xfrm>
+          <a:prstGeom prst="rect">
+            <a:avLst/>
+          </a:prstGeom>
+          <a:noFill/>
+          <a:ln/>
+        </p:spPr>
+        <p:txBody>
+          <a:bodyPr wrap="square" lIns="0" tIns="0" rIns="0" bIns="0" rtlCol="0" anchor="ctr"/>
+          <a:lstStyle/>
+          <a:p>
+            <a:pPr indent="0" marL="0">
+              <a:buNone/>
+            </a:pPr>
+            <a:r>
+              <a:rPr lang="en-US" sz="1500" b="1" dirty="0">
+                <a:solidFill>
+                  <a:srgbClr val="1F6FEB"/>
+                </a:solidFill>
+                <a:latin typeface="Calibri" pitchFamily="34" charset="0"/>
+                <a:ea typeface="Calibri" pitchFamily="34" charset="-122"/>
+                <a:cs typeface="Calibri" pitchFamily="34" charset="-120"/>
+              </a:rPr>
+              <a:t>Why not TCP?</a:t>
+            </a:r>
+            <a:endParaRPr lang="en-US" sz="1500" dirty="0"/>
+          </a:p>
+        </p:txBody>
+      </p:sp>
+      <p:sp>
+        <p:nvSpPr>
+          <p:cNvPr id="9" name="Text 7"/>
+          <p:cNvSpPr/>
+          <p:nvPr/>
+        </p:nvSpPr>
+        <p:spPr>
+          <a:xfrm>
+            <a:off x="640080" y="2743200"/>
+            <a:ext cx="10972800" cy="530352"/>
+          </a:xfrm>
+          <a:prstGeom prst="rect">
+            <a:avLst/>
+          </a:prstGeom>
+          <a:noFill/>
+          <a:ln/>
+        </p:spPr>
+        <p:txBody>
+          <a:bodyPr wrap="square" lIns="0" tIns="0" rIns="0" bIns="0" rtlCol="0" anchor="t"/>
+          <a:lstStyle/>
+          <a:p>
+            <a:pPr indent="0" marL="0">
+              <a:buNone/>
+            </a:pPr>
+            <a:r>
+              <a:rPr lang="en-US" sz="1350" dirty="0">
+                <a:solidFill>
+                  <a:srgbClr val="1B2430"/>
+                </a:solidFill>
+                <a:latin typeface="Calibri" pitchFamily="34" charset="0"/>
+                <a:ea typeface="Calibri" pitchFamily="34" charset="-122"/>
+                <a:cs typeface="Calibri" pitchFamily="34" charset="-120"/>
+              </a:rPr>
+              <a:t>TCP is in the kernel and cannot be changed. Building our own makes every mechanism visible. QUIC and HTTP/3 do the same.</a:t>
+            </a:r>
+            <a:endParaRPr lang="en-US" sz="1350" dirty="0"/>
+          </a:p>
+        </p:txBody>
+      </p:sp>
+      <p:sp>
+        <p:nvSpPr>
+          <p:cNvPr id="10" name="Shape 8"/>
+          <p:cNvSpPr/>
+          <p:nvPr/>
+        </p:nvSpPr>
+        <p:spPr>
+          <a:xfrm>
+            <a:off x="457200" y="3383280"/>
+            <a:ext cx="11274552" cy="914400"/>
+          </a:xfrm>
+          <a:prstGeom prst="rect">
+            <a:avLst/>
+          </a:prstGeom>
+          <a:solidFill>
+            <a:srgbClr val="F2F6FB"/>
+          </a:solidFill>
+          <a:ln w="9525">
+            <a:solidFill>
+              <a:srgbClr val="D5DEE9"/>
+            </a:solidFill>
+            <a:prstDash val="solid"/>
+          </a:ln>
+        </p:spPr>
+      </p:sp>
+      <p:sp>
+        <p:nvSpPr>
+          <p:cNvPr id="11" name="Text 9"/>
+          <p:cNvSpPr/>
+          <p:nvPr/>
+        </p:nvSpPr>
+        <p:spPr>
+          <a:xfrm>
+            <a:off x="640080" y="3429000"/>
+            <a:ext cx="10972800" cy="320040"/>
+          </a:xfrm>
+          <a:prstGeom prst="rect">
+            <a:avLst/>
+          </a:prstGeom>
+          <a:noFill/>
+          <a:ln/>
+        </p:spPr>
+        <p:txBody>
+          <a:bodyPr wrap="square" lIns="0" tIns="0" rIns="0" bIns="0" rtlCol="0" anchor="ctr"/>
+          <a:lstStyle/>
+          <a:p>
+            <a:pPr indent="0" marL="0">
+              <a:buNone/>
+            </a:pPr>
+            <a:r>
+              <a:rPr lang="en-US" sz="1500" b="1" dirty="0">
+                <a:solidFill>
+                  <a:srgbClr val="1F6FEB"/>
+                </a:solidFill>
+                <a:latin typeface="Calibri" pitchFamily="34" charset="0"/>
+                <a:ea typeface="Calibri" pitchFamily="34" charset="-122"/>
+                <a:cs typeface="Calibri" pitchFamily="34" charset="-120"/>
+              </a:rPr>
+              <a:t>Did Smart-RUDP win?</a:t>
+            </a:r>
+            <a:endParaRPr lang="en-US" sz="1500" dirty="0"/>
+          </a:p>
+        </p:txBody>
+      </p:sp>
+      <p:sp>
+        <p:nvSpPr>
+          <p:cNvPr id="12" name="Text 10"/>
+          <p:cNvSpPr/>
+          <p:nvPr/>
+        </p:nvSpPr>
+        <p:spPr>
+          <a:xfrm>
+            <a:off x="640080" y="3749040"/>
+            <a:ext cx="10972800" cy="530352"/>
+          </a:xfrm>
+          <a:prstGeom prst="rect">
+            <a:avLst/>
+          </a:prstGeom>
+          <a:noFill/>
+          <a:ln/>
+        </p:spPr>
+        <p:txBody>
+          <a:bodyPr wrap="square" lIns="0" tIns="0" rIns="0" bIns="0" rtlCol="0" anchor="t"/>
+          <a:lstStyle/>
+          <a:p>
+            <a:pPr indent="0" marL="0">
+              <a:buNone/>
+            </a:pPr>
+            <a:r>
+              <a:rPr lang="en-US" sz="1350" dirty="0">
+                <a:solidFill>
+                  <a:srgbClr val="1B2430"/>
+                </a:solidFill>
+                <a:latin typeface="Calibri" pitchFamily="34" charset="0"/>
+                <a:ea typeface="Calibri" pitchFamily="34" charset="-122"/>
+                <a:cs typeface="Calibri" pitchFamily="34" charset="-120"/>
+              </a:rPr>
+              <a:t>Experiments: tied on one path, slower on two, and we say so. Chat, retrained on simulated paths: faster than AIMD on 5 of 6 held-out paths, equal on 1, because AIMD resets to 1 on every timeout. Stress test on 48 unseen random paths: mean 3.73 s Smart vs 7.16 s AIMD; faster on 27, slower on 5, within 5% on 16. Simulated; same start window 10; agent may not shrink without a congestion signal.</a:t>
+            </a:r>
+            <a:endParaRPr lang="en-US" sz="1350" dirty="0"/>
+          </a:p>
+        </p:txBody>
+      </p:sp>
+      <p:sp>
+        <p:nvSpPr>
+          <p:cNvPr id="13" name="Shape 11"/>
+          <p:cNvSpPr/>
+          <p:nvPr/>
+        </p:nvSpPr>
+        <p:spPr>
+          <a:xfrm>
+            <a:off x="457200" y="4389120"/>
+            <a:ext cx="11274552" cy="914400"/>
+          </a:xfrm>
+          <a:prstGeom prst="rect">
+            <a:avLst/>
+          </a:prstGeom>
+          <a:solidFill>
+            <a:srgbClr val="F2F6FB"/>
+          </a:solidFill>
+          <a:ln w="9525">
+            <a:solidFill>
+              <a:srgbClr val="D5DEE9"/>
+            </a:solidFill>
+            <a:prstDash val="solid"/>
+          </a:ln>
+        </p:spPr>
+      </p:sp>
+      <p:sp>
+        <p:nvSpPr>
+          <p:cNvPr id="14" name="Text 12"/>
+          <p:cNvSpPr/>
+          <p:nvPr/>
+        </p:nvSpPr>
+        <p:spPr>
+          <a:xfrm>
+            <a:off x="640080" y="4434840"/>
+            <a:ext cx="10972800" cy="320040"/>
+          </a:xfrm>
+          <a:prstGeom prst="rect">
+            <a:avLst/>
+          </a:prstGeom>
+          <a:noFill/>
+          <a:ln/>
+        </p:spPr>
+        <p:txBody>
+          <a:bodyPr wrap="square" lIns="0" tIns="0" rIns="0" bIns="0" rtlCol="0" anchor="ctr"/>
+          <a:lstStyle/>
+          <a:p>
+            <a:pPr indent="0" marL="0">
+              <a:buNone/>
+            </a:pPr>
+            <a:r>
+              <a:rPr lang="en-US" sz="1500" b="1" dirty="0">
+                <a:solidFill>
+                  <a:srgbClr val="1F6FEB"/>
+                </a:solidFill>
+                <a:latin typeface="Calibri" pitchFamily="34" charset="0"/>
+                <a:ea typeface="Calibri" pitchFamily="34" charset="-122"/>
+                <a:cs typeface="Calibri" pitchFamily="34" charset="-120"/>
+              </a:rPr>
+              <a:t>Why Go-Back-N?</a:t>
+            </a:r>
+            <a:endParaRPr lang="en-US" sz="1500" dirty="0"/>
+          </a:p>
+        </p:txBody>
+      </p:sp>
+      <p:sp>
+        <p:nvSpPr>
+          <p:cNvPr id="15" name="Text 13"/>
+          <p:cNvSpPr/>
+          <p:nvPr/>
+        </p:nvSpPr>
+        <p:spPr>
+          <a:xfrm>
+            <a:off x="640080" y="4754880"/>
+            <a:ext cx="10972800" cy="530352"/>
+          </a:xfrm>
+          <a:prstGeom prst="rect">
+            <a:avLst/>
+          </a:prstGeom>
+          <a:noFill/>
+          <a:ln/>
+        </p:spPr>
+        <p:txBody>
+          <a:bodyPr wrap="square" lIns="0" tIns="0" rIns="0" bIns="0" rtlCol="0" anchor="t"/>
+          <a:lstStyle/>
+          <a:p>
+            <a:pPr indent="0" marL="0">
+              <a:buNone/>
+            </a:pPr>
+            <a:r>
+              <a:rPr lang="en-US" sz="1350" dirty="0">
+                <a:solidFill>
+                  <a:srgbClr val="1B2430"/>
+                </a:solidFill>
+                <a:latin typeface="Calibri" pitchFamily="34" charset="0"/>
+                <a:ea typeface="Calibri" pitchFamily="34" charset="-122"/>
+                <a:cs typeface="Calibri" pitchFamily="34" charset="-120"/>
+              </a:rPr>
+              <a:t>Simpler to build and explain. It wastes bandwidth under loss; Selective Repeat with SACK is future work.</a:t>
+            </a:r>
+            <a:endParaRPr lang="en-US" sz="1350" dirty="0"/>
+          </a:p>
+        </p:txBody>
+      </p:sp>
+      <p:sp>
+        <p:nvSpPr>
+          <p:cNvPr id="16" name="Shape 14"/>
+          <p:cNvSpPr/>
+          <p:nvPr/>
+        </p:nvSpPr>
+        <p:spPr>
+          <a:xfrm>
+            <a:off x="457200" y="5394960"/>
+            <a:ext cx="11274552" cy="914400"/>
+          </a:xfrm>
+          <a:prstGeom prst="rect">
+            <a:avLst/>
+          </a:prstGeom>
+          <a:solidFill>
+            <a:srgbClr val="F2F6FB"/>
+          </a:solidFill>
+          <a:ln w="9525">
+            <a:solidFill>
+              <a:srgbClr val="D5DEE9"/>
+            </a:solidFill>
+            <a:prstDash val="solid"/>
+          </a:ln>
+        </p:spPr>
+      </p:sp>
+      <p:sp>
+        <p:nvSpPr>
+          <p:cNvPr id="17" name="Text 15"/>
+          <p:cNvSpPr/>
+          <p:nvPr/>
+        </p:nvSpPr>
+        <p:spPr>
+          <a:xfrm>
+            <a:off x="640080" y="5440680"/>
+            <a:ext cx="10972800" cy="320040"/>
+          </a:xfrm>
+          <a:prstGeom prst="rect">
+            <a:avLst/>
+          </a:prstGeom>
+          <a:noFill/>
+          <a:ln/>
+        </p:spPr>
+        <p:txBody>
+          <a:bodyPr wrap="square" lIns="0" tIns="0" rIns="0" bIns="0" rtlCol="0" anchor="ctr"/>
+          <a:lstStyle/>
+          <a:p>
+            <a:pPr indent="0" marL="0">
+              <a:buNone/>
+            </a:pPr>
+            <a:r>
+              <a:rPr lang="en-US" sz="1500" b="1" dirty="0">
+                <a:solidFill>
+                  <a:srgbClr val="1F6FEB"/>
+                </a:solidFill>
+                <a:latin typeface="Calibri" pitchFamily="34" charset="0"/>
+                <a:ea typeface="Calibri" pitchFamily="34" charset="-122"/>
+                <a:cs typeface="Calibri" pitchFamily="34" charset="-120"/>
+              </a:rPr>
+              <a:t>Tests ran on one machine?</a:t>
+            </a:r>
+            <a:endParaRPr lang="en-US" sz="1500" dirty="0"/>
+          </a:p>
+        </p:txBody>
+      </p:sp>
+      <p:sp>
+        <p:nvSpPr>
+          <p:cNvPr id="18" name="Text 16"/>
+          <p:cNvSpPr/>
+          <p:nvPr/>
+        </p:nvSpPr>
+        <p:spPr>
+          <a:xfrm>
+            <a:off x="640080" y="5760720"/>
+            <a:ext cx="10972800" cy="530352"/>
+          </a:xfrm>
+          <a:prstGeom prst="rect">
+            <a:avLst/>
+          </a:prstGeom>
+          <a:noFill/>
+          <a:ln/>
+        </p:spPr>
+        <p:txBody>
+          <a:bodyPr wrap="square" lIns="0" tIns="0" rIns="0" bIns="0" rtlCol="0" anchor="t"/>
+          <a:lstStyle/>
+          <a:p>
+            <a:pPr indent="0" marL="0">
+              <a:buNone/>
+            </a:pPr>
+            <a:r>
+              <a:rPr lang="en-US" sz="1350" dirty="0">
+                <a:solidFill>
+                  <a:srgbClr val="1B2430"/>
+                </a:solidFill>
+                <a:latin typeface="Calibri" pitchFamily="34" charset="0"/>
+                <a:ea typeface="Calibri" pitchFamily="34" charset="-122"/>
+                <a:cs typeface="Calibri" pitchFamily="34" charset="-120"/>
+              </a:rPr>
+              <a:t>Yes, with emulated delay, loss and jitter. They do not prove internet performance; the report says so. Chat between laptop and phone is a small real-network check.</a:t>
+            </a:r>
+            <a:endParaRPr lang="en-US" sz="1350" dirty="0"/>
+          </a:p>
+        </p:txBody>
+      </p:sp>
+    </p:spTree>
+  </p:cSld>
+  <p:clrMapOvr>
+    <a:masterClrMapping/>
+  </p:clrMapOvr>
+</p:sld>
+</file>
+
+<file path=ppt/slides/slide27.xml><?xml version="1.0" encoding="utf-8"?>
+<p:sld xmlns:a="http://schemas.openxmlformats.org/drawingml/2006/main" xmlns:r="http://schemas.openxmlformats.org/officeDocument/2006/relationships" xmlns:p="http://schemas.openxmlformats.org/presentationml/2006/main">
+  <p:cSld name="Slide 27">
     <p:bg>
       <p:bgPr>
         <a:solidFill>

</xml_diff>

<commit_message>
Add deep RL (numpy DQN) controller, seed-selected on validation paths; stress test includes it; docs updated
Co-Authored-By: Claude Sonnet 5.5 <noreply@anthropic.com>
Claude-Session: https://claude.ai/code/session_01NX2zRNpdVAnzFNKmqomzKu
</commit_message>
<xml_diff>
--- a/docs/RUDP_Host_Guide.pptx
+++ b/docs/RUDP_Host_Guide.pptx
@@ -6673,6 +6673,27 @@
             </a:r>
             <a:endParaRPr lang="en-US" sz="1400" dirty="0"/>
           </a:p>
+          <a:p>
+            <a:pPr marL="342900" indent="-342900">
+              <a:spcAft>
+                <a:spcPts val="600"/>
+              </a:spcAft>
+              <a:buSzPct val="100000"/>
+              <a:buChar char="•"/>
+            </a:pPr>
+            <a:r>
+              <a:rPr lang="en-US" sz="1400" dirty="0">
+                <a:solidFill>
+                  <a:srgbClr val="1B2430"/>
+                </a:solidFill>
+                <a:latin typeface="Calibri" pitchFamily="34" charset="0"/>
+                <a:ea typeface="Calibri" pitchFamily="34" charset="-122"/>
+                <a:cs typeface="Calibri" pitchFamily="34" charset="-120"/>
+              </a:rPr>
+              <a:t>We also built a deep version: web/dqn.py is a small neural network, two hidden layers of 32, trained with DQN in the same simulator. It reads continuous inputs instead of buckets.</a:t>
+            </a:r>
+            <a:endParaRPr lang="en-US" sz="1400" dirty="0"/>
+          </a:p>
         </p:txBody>
       </p:sp>
       <p:sp>
@@ -6747,7 +6768,7 @@
                 <a:ea typeface="Calibri" pitchFamily="34" charset="-122"/>
                 <a:cs typeface="Calibri" pitchFamily="34" charset="-120"/>
               </a:rPr>
-              <a:t>Q: Is this deep RL? A: No, tabular Q-learning. 80 states fit in a table; a neural network is future work. Q: Where is it trained? A: web/train.py for the chat, the smart client trains online for the main experiments; table in results/q_chat.txt.</a:t>
+              <a:t>Q: Is this deep RL? A: The C agent is tabular. The chat also has a deep agent, a small DQN in numpy (5-32-32-5). Q: Does deep beat the table? A: Modestly: 3.20 s vs 3.73 s mean on 48 unseen paths, faster on 19, slower on 6. Q: Any problem? A: Training is seed-sensitive: 1 of 4 seeds failed, so we select on validation paths. It is simulated and not in the C code. Q: Where is it trained? A: web/train.py for the chat, the smart client trains online for the main experiments; table in results/q_chat.txt.</a:t>
             </a:r>
             <a:endParaRPr lang="en-US" sz="1400" dirty="0"/>
           </a:p>
@@ -13532,7 +13553,7 @@
                 <a:ea typeface="Calibri" pitchFamily="34" charset="-122"/>
                 <a:cs typeface="Calibri" pitchFamily="34" charset="-120"/>
               </a:rPr>
-              <a:t>There is a controller switch: fixed window, AIMD, or Smart-RUDP. For the chat we retrained Smart-RUDP on simulated paths: it was faster than AIMD on 5 of 6 held-out paths and equal on 1, because AIMD resets to one packet on random loss. Say it is simulated, and that the agent may not shrink the window without a congestion signal. Stress test: 48 random paths the agent never trained on, 3 seeds each. Mean delivery time was 3.73 seconds for Smart-RUDP against 7.16 for AIMD. Smart-RUDP was faster on 27 paths, slower on 5, within 5 percent on 16. So on our data, in simulation, it beats AIMD in the chat setting.</a:t>
+              <a:t>There is a controller switch: fixed window, AIMD, or Smart-RUDP. For the chat we retrained Smart-RUDP on simulated paths: it was faster than AIMD on 5 of 6 held-out paths and equal on 1, because AIMD resets to one packet on random loss. Say it is simulated, and that the agent may not shrink the window without a congestion signal. Stress test: 48 random paths the agent never trained on, 3 seeds each. Mean delivery time was 3.73 seconds for Smart-RUDP against 7.16 for AIMD. Smart-RUDP was faster on 27 paths, slower on 5, within 5 percent on 16. So on our data, in simulation, it beats AIMD in the chat setting. There is also a deep neural-network option in the controller dropdown; it gave 3.20 seconds mean on the stress paths against 3.73 for the table.</a:t>
             </a:r>
             <a:endParaRPr lang="en-US" sz="1400" dirty="0"/>
           </a:p>
@@ -15080,7 +15101,7 @@
                 <a:ea typeface="Calibri" pitchFamily="34" charset="-122"/>
                 <a:cs typeface="Calibri" pitchFamily="34" charset="-120"/>
               </a:rPr>
-              <a:t>Experiments: tied on one path, slower on two, and we say so. Chat, retrained on simulated paths: faster than AIMD on 5 of 6 held-out paths, equal on 1, because AIMD resets to 1 on every timeout. Stress test on 48 unseen random paths: mean 3.73 s Smart vs 7.16 s AIMD; faster on 27, slower on 5, within 5% on 16. Simulated; same start window 10; agent may not shrink without a congestion signal.</a:t>
+              <a:t>Experiments: tied on one path, slower on two, and we say so. Chat, retrained on simulated paths: faster than AIMD on 5 of 6 held-out paths, equal on 1, because AIMD resets to 1 on every timeout. Deep RL: a small DQN in the chat gateway gave 3.20 s mean on the same stress paths (training is seed-sensitive; chosen on validation paths). Stress test on 48 unseen random paths: mean 3.73 s Smart vs 7.16 s AIMD; faster on 27, slower on 5, within 5% on 16. Simulated; same start window 10; agent may not shrink without a congestion signal.</a:t>
             </a:r>
             <a:endParaRPr lang="en-US" sz="1350" dirty="0"/>
           </a:p>

</xml_diff>

<commit_message>
Final docs: baselines, SACK, reordering, confidence intervals in report, deck, notes, manual, cheat sheet, runbook
Co-Authored-By: Claude Sonnet 5.5 <noreply@anthropic.com>
Claude-Session: https://claude.ai/code/session_01NX2zRNpdVAnzFNKmqomzKu
</commit_message>
<xml_diff>
--- a/docs/RUDP_Host_Guide.pptx
+++ b/docs/RUDP_Host_Guide.pptx
@@ -32,9 +32,10 @@
     <p:sldId id="280" r:id="rId26"/>
     <p:sldId id="281" r:id="rId27"/>
     <p:sldId id="282" r:id="rId28"/>
+    <p:sldId id="283" r:id="rId29"/>
   </p:sldIdLst>
   <p:notesMasterIdLst>
-    <p:notesMasterId r:id="rId29"/>
+    <p:notesMasterId r:id="rId30"/>
   </p:notesMasterIdLst>
   <p:sldSz cx="12192000" cy="6858000"/>
   <p:notesSz cx="6858000" cy="12192000"/>
@@ -2224,6 +2225,94 @@
             <a:fld id="{F7021451-1387-4CA6-816F-3879F97B5CBC}" type="slidenum">
               <a:rPr lang="en-US"/>
               <a:t>27</a:t>
+            </a:fld>
+            <a:endParaRPr lang="en-US"/>
+          </a:p>
+        </p:txBody>
+      </p:sp>
+    </p:spTree>
+    <p:extLst>
+      <p:ext uri="{BB962C8B-B14F-4D97-AF65-F5344CB8AC3E}">
+        <p14:creationId xmlns:p14="http://schemas.microsoft.com/office/powerpoint/2010/main" val="1024086991"/>
+      </p:ext>
+    </p:extLst>
+  </p:cSld>
+  <p:clrMapOvr>
+    <a:masterClrMapping/>
+  </p:clrMapOvr>
+</p:notes>
+</file>
+
+<file path=ppt/notesSlides/notesSlide28.xml><?xml version="1.0" encoding="utf-8"?>
+<p:notes xmlns:a="http://schemas.openxmlformats.org/drawingml/2006/main" xmlns:r="http://schemas.openxmlformats.org/officeDocument/2006/relationships" xmlns:p="http://schemas.openxmlformats.org/presentationml/2006/main">
+  <p:cSld>
+    <p:spTree>
+      <p:nvGrpSpPr>
+        <p:cNvPr id="1" name=""/>
+        <p:cNvGrpSpPr/>
+        <p:nvPr/>
+      </p:nvGrpSpPr>
+      <p:grpSpPr>
+        <a:xfrm>
+          <a:off x="0" y="0"/>
+          <a:ext cx="0" cy="0"/>
+          <a:chOff x="0" y="0"/>
+          <a:chExt cx="0" cy="0"/>
+        </a:xfrm>
+      </p:grpSpPr>
+      <p:sp>
+        <p:nvSpPr>
+          <p:cNvPr id="2" name="Slide Image Placeholder 1"/>
+          <p:cNvSpPr>
+            <a:spLocks noGrp="1" noRot="1" noChangeAspect="1"/>
+          </p:cNvSpPr>
+          <p:nvPr>
+            <p:ph type="sldImg"/>
+          </p:nvPr>
+        </p:nvSpPr>
+        <p:spPr/>
+      </p:sp>
+      <p:sp>
+        <p:nvSpPr>
+          <p:cNvPr id="3" name="Notes Placeholder 2"/>
+          <p:cNvSpPr>
+            <a:spLocks noGrp="1"/>
+          </p:cNvSpPr>
+          <p:nvPr>
+            <p:ph type="body" idx="1"/>
+          </p:nvPr>
+        </p:nvSpPr>
+        <p:spPr/>
+        <p:txBody>
+          <a:bodyPr/>
+          <a:lstStyle/>
+          <a:p>
+            <a:r>
+              <a:rPr lang="en-US" dirty="0"/>
+              <a:t/>
+            </a:r>
+            <a:endParaRPr lang="en-US" dirty="0"/>
+          </a:p>
+        </p:txBody>
+      </p:sp>
+      <p:sp>
+        <p:nvSpPr>
+          <p:cNvPr id="4" name="Slide Number Placeholder 3"/>
+          <p:cNvSpPr>
+            <a:spLocks noGrp="1"/>
+          </p:cNvSpPr>
+          <p:nvPr>
+            <p:ph type="sldNum" sz="quarter" idx="10"/>
+          </p:nvPr>
+        </p:nvSpPr>
+        <p:spPr/>
+        <p:txBody>
+          <a:bodyPr/>
+          <a:lstStyle/>
+          <a:p>
+            <a:fld id="{F7021451-1387-4CA6-816F-3879F97B5CBC}" type="slidenum">
+              <a:rPr lang="en-US"/>
+              <a:t>28</a:t>
             </a:fld>
             <a:endParaRPr lang="en-US"/>
           </a:p>
@@ -11167,7 +11256,7 @@
                           <a:ea typeface="Calibri" pitchFamily="34" charset="-122"/>
                           <a:cs typeface="Calibri" pitchFamily="34" charset="-120"/>
                         </a:rPr>
-                        <a:t>Learnings and future work</a:t>
+                        <a:t>More evidence: baselines, SACK, reordering</a:t>
                       </a:r>
                       <a:endParaRPr lang="en-US" sz="1200" dirty="0">
                         <a:latin typeface="Calibri" charset="0"/>
@@ -11232,7 +11321,7 @@
                           <a:ea typeface="Calibri" pitchFamily="34" charset="-122"/>
                           <a:cs typeface="Calibri" pitchFamily="34" charset="-120"/>
                         </a:rPr>
-                        <a:t>0:50</a:t>
+                        <a:t>1:00</a:t>
                       </a:r>
                       <a:endParaRPr lang="en-US" sz="1200" dirty="0">
                         <a:latin typeface="Calibri" charset="0"/>
@@ -11559,7 +11648,7 @@
                           <a:ea typeface="Calibri" pitchFamily="34" charset="-122"/>
                           <a:cs typeface="Calibri" pitchFamily="34" charset="-120"/>
                         </a:rPr>
-                        <a:t>Thank you</a:t>
+                        <a:t>Learnings and future work</a:t>
                       </a:r>
                       <a:endParaRPr lang="en-US" sz="1200" dirty="0">
                         <a:latin typeface="Calibri" charset="0"/>
@@ -11624,7 +11713,7 @@
                           <a:ea typeface="Calibri" pitchFamily="34" charset="-122"/>
                           <a:cs typeface="Calibri" pitchFamily="34" charset="-120"/>
                         </a:rPr>
-                        <a:t>0:15</a:t>
+                        <a:t>0:50</a:t>
                       </a:r>
                       <a:endParaRPr lang="en-US" sz="1200" dirty="0">
                         <a:latin typeface="Calibri" charset="0"/>
@@ -11951,7 +12040,7 @@
                           <a:ea typeface="Calibri" pitchFamily="34" charset="-122"/>
                           <a:cs typeface="Calibri" pitchFamily="34" charset="-120"/>
                         </a:rPr>
-                        <a:t>Appendix: slow start</a:t>
+                        <a:t>Thank you</a:t>
                       </a:r>
                       <a:endParaRPr lang="en-US" sz="1200" dirty="0">
                         <a:latin typeface="Calibri" charset="0"/>
@@ -12016,7 +12105,7 @@
                           <a:ea typeface="Calibri" pitchFamily="34" charset="-122"/>
                           <a:cs typeface="Calibri" pitchFamily="34" charset="-120"/>
                         </a:rPr>
-                        <a:t>-</a:t>
+                        <a:t>0:15</a:t>
                       </a:r>
                       <a:endParaRPr lang="en-US" sz="1200" dirty="0">
                         <a:latin typeface="Calibri" charset="0"/>
@@ -12269,6 +12358,17 @@
                       <a:pPr indent="0" marL="0">
                         <a:buNone/>
                       </a:pPr>
+                      <a:r>
+                        <a:rPr lang="en-US" sz="1200" dirty="0">
+                          <a:solidFill>
+                            <a:srgbClr val="1B2430"/>
+                          </a:solidFill>
+                          <a:latin typeface="Calibri" pitchFamily="34" charset="0"/>
+                          <a:ea typeface="Calibri" pitchFamily="34" charset="-122"/>
+                          <a:cs typeface="Calibri" pitchFamily="34" charset="-120"/>
+                        </a:rPr>
+                        <a:t>24</a:t>
+                      </a:r>
                       <a:endParaRPr lang="en-US" sz="1200" dirty="0">
                         <a:latin typeface="Calibri" charset="0"/>
                         <a:ea typeface="Calibri" charset="0"/>
@@ -12323,6 +12423,17 @@
                       <a:pPr indent="0" marL="0">
                         <a:buNone/>
                       </a:pPr>
+                      <a:r>
+                        <a:rPr lang="en-US" sz="1200" dirty="0">
+                          <a:solidFill>
+                            <a:srgbClr val="1B2430"/>
+                          </a:solidFill>
+                          <a:latin typeface="Calibri" pitchFamily="34" charset="0"/>
+                          <a:ea typeface="Calibri" pitchFamily="34" charset="-122"/>
+                          <a:cs typeface="Calibri" pitchFamily="34" charset="-120"/>
+                        </a:rPr>
+                        <a:t>Appendix: slow start</a:t>
+                      </a:r>
                       <a:endParaRPr lang="en-US" sz="1200" dirty="0">
                         <a:latin typeface="Calibri" charset="0"/>
                         <a:ea typeface="Calibri" charset="0"/>
@@ -12377,6 +12488,17 @@
                       <a:pPr indent="0" marL="0">
                         <a:buNone/>
                       </a:pPr>
+                      <a:r>
+                        <a:rPr lang="en-US" sz="1200" dirty="0">
+                          <a:solidFill>
+                            <a:srgbClr val="1B2430"/>
+                          </a:solidFill>
+                          <a:latin typeface="Calibri" pitchFamily="34" charset="0"/>
+                          <a:ea typeface="Calibri" pitchFamily="34" charset="-122"/>
+                          <a:cs typeface="Calibri" pitchFamily="34" charset="-120"/>
+                        </a:rPr>
+                        <a:t>-</a:t>
+                      </a:r>
                       <a:endParaRPr lang="en-US" sz="1200" dirty="0">
                         <a:latin typeface="Calibri" charset="0"/>
                         <a:ea typeface="Calibri" charset="0"/>
@@ -13702,7 +13824,7 @@
                 <a:ea typeface="Calibri" pitchFamily="34" charset="-122"/>
                 <a:cs typeface="Calibri" pitchFamily="34" charset="-120"/>
               </a:rPr>
-              <a:t>21. Learnings and future work</a:t>
+              <a:t>21. More evidence: baselines, SACK, reordering</a:t>
             </a:r>
             <a:endParaRPr lang="en-US" sz="2600" dirty="0"/>
           </a:p>
@@ -13741,7 +13863,7 @@
                 <a:ea typeface="Calibri" pitchFamily="34" charset="-122"/>
                 <a:cs typeface="Calibri" pitchFamily="34" charset="-120"/>
               </a:rPr>
-              <a:t>Time on this slide: 0:50</a:t>
+              <a:t>Time on this slide: 1:00</a:t>
             </a:r>
             <a:endParaRPr lang="en-US" sz="1300" dirty="0"/>
           </a:p>
@@ -13886,7 +14008,7 @@
               <a:buChar char="•"/>
             </a:pPr>
             <a:r>
-              <a:rPr lang="en-US" sz="1600" dirty="0">
+              <a:rPr lang="en-US" sz="1400" dirty="0">
                 <a:solidFill>
                   <a:srgbClr val="1B2430"/>
                 </a:solidFill>
@@ -13894,9 +14016,9 @@
                 <a:ea typeface="Calibri" pitchFamily="34" charset="-122"/>
                 <a:cs typeface="Calibri" pitchFamily="34" charset="-120"/>
               </a:rPr>
-              <a:t>Learned: reliability is a set of simple rules working together; congestion control matters as much as retransmission; testing tools fail in surprising ways.</a:t>
-            </a:r>
-            <a:endParaRPr lang="en-US" sz="1600" dirty="0"/>
+              <a:t>The abstract also promised TCP and plain UDP baselines, so we ran them on the same 48 unseen simulated paths.</a:t>
+            </a:r>
+            <a:endParaRPr lang="en-US" sz="1400" dirty="0"/>
           </a:p>
           <a:p>
             <a:pPr marL="342900" indent="-342900">
@@ -13907,7 +14029,7 @@
               <a:buChar char="•"/>
             </a:pPr>
             <a:r>
-              <a:rPr lang="en-US" sz="1600" dirty="0">
+              <a:rPr lang="en-US" sz="1400" dirty="0">
                 <a:solidFill>
                   <a:srgbClr val="1B2430"/>
                 </a:solidFill>
@@ -13915,9 +14037,9 @@
                 <a:ea typeface="Calibri" pitchFamily="34" charset="-122"/>
                 <a:cs typeface="Calibri" pitchFamily="34" charset="-120"/>
               </a:rPr>
-              <a:t>Next: Selective Repeat with SACK, a stronger learning agent, adaptive timeout, and tests on a real multi-machine network.</a:t>
-            </a:r>
-            <a:endParaRPr lang="en-US" sz="1600" dirty="0"/>
+              <a:t>Plain UDP delivered only 68 percent of the messages, so reliability is needed. Our TCP model, with selective acknowledgments, has the lowest median at 1.48 seconds.</a:t>
+            </a:r>
+            <a:endParaRPr lang="en-US" sz="1400" dirty="0"/>
           </a:p>
           <a:p>
             <a:pPr marL="342900" indent="-342900">
@@ -13928,7 +14050,7 @@
               <a:buChar char="•"/>
             </a:pPr>
             <a:r>
-              <a:rPr lang="en-US" sz="1600" dirty="0">
+              <a:rPr lang="en-US" sz="1400" dirty="0">
                 <a:solidFill>
                   <a:srgbClr val="1B2430"/>
                 </a:solidFill>
@@ -13936,9 +14058,72 @@
                 <a:ea typeface="Calibri" pitchFamily="34" charset="-122"/>
                 <a:cs typeface="Calibri" pitchFamily="34" charset="-120"/>
               </a:rPr>
-              <a:t>Name the limits before she does: Go-Back-N, loopback-only protocol tests, Smart-RUDP not beating AIMD.</a:t>
-            </a:r>
-            <a:endParaRPr lang="en-US" sz="1600" dirty="0"/>
+              <a:t>Smart-RUDP deep is at 3.20 seconds mean and is about even with the TCP model path by path: faster on 22, slower on 23.</a:t>
+            </a:r>
+            <a:endParaRPr lang="en-US" sz="1400" dirty="0"/>
+          </a:p>
+          <a:p>
+            <a:pPr marL="342900" indent="-342900">
+              <a:spcAft>
+                <a:spcPts val="600"/>
+              </a:spcAft>
+              <a:buSzPct val="100000"/>
+              <a:buChar char="•"/>
+            </a:pPr>
+            <a:r>
+              <a:rPr lang="en-US" sz="1400" dirty="0">
+                <a:solidFill>
+                  <a:srgbClr val="1B2430"/>
+                </a:solidFill>
+                <a:latin typeface="Calibri" pitchFamily="34" charset="0"/>
+                <a:ea typeface="Calibri" pitchFamily="34" charset="-122"/>
+                <a:cs typeface="Calibri" pitchFamily="34" charset="-120"/>
+              </a:rPr>
+              <a:t>The gap to TCP is mostly Go-Back-N. A selective-ack version of our transport cut AIMD from 7.16 to 4.90 seconds in simulation.</a:t>
+            </a:r>
+            <a:endParaRPr lang="en-US" sz="1400" dirty="0"/>
+          </a:p>
+          <a:p>
+            <a:pPr marL="342900" indent="-342900">
+              <a:spcAft>
+                <a:spcPts val="600"/>
+              </a:spcAft>
+              <a:buSzPct val="100000"/>
+              <a:buChar char="•"/>
+            </a:pPr>
+            <a:r>
+              <a:rPr lang="en-US" sz="1400" dirty="0">
+                <a:solidFill>
+                  <a:srgbClr val="1B2430"/>
+                </a:solidFill>
+                <a:latin typeface="Calibri" pitchFamily="34" charset="0"/>
+                <a:ea typeface="Calibri" pitchFamily="34" charset="-122"/>
+                <a:cs typeface="Calibri" pitchFamily="34" charset="-120"/>
+              </a:rPr>
+              <a:t>Reordering hurts Go-Back-N badly: AIMD goes from 0.82 to 6.79 seconds at 20 milliseconds of jitter. The learned agents cope better and selective ack removes most of the damage.</a:t>
+            </a:r>
+            <a:endParaRPr lang="en-US" sz="1400" dirty="0"/>
+          </a:p>
+          <a:p>
+            <a:pPr marL="342900" indent="-342900">
+              <a:spcAft>
+                <a:spcPts val="600"/>
+              </a:spcAft>
+              <a:buSzPct val="100000"/>
+              <a:buChar char="•"/>
+            </a:pPr>
+            <a:r>
+              <a:rPr lang="en-US" sz="1400" dirty="0">
+                <a:solidFill>
+                  <a:srgbClr val="1B2430"/>
+                </a:solidFill>
+                <a:latin typeface="Calibri" pitchFamily="34" charset="0"/>
+                <a:ea typeface="Calibri" pitchFamily="34" charset="-122"/>
+                <a:cs typeface="Calibri" pitchFamily="34" charset="-120"/>
+              </a:rPr>
+              <a:t>For the C experiments we repeated 20 runs per mode: Smart-RUDP is still slower on 5G and satellite and ties on lossy.</a:t>
+            </a:r>
+            <a:endParaRPr lang="en-US" sz="1400" dirty="0"/>
           </a:p>
         </p:txBody>
       </p:sp>
@@ -14014,7 +14199,7 @@
                 <a:ea typeface="Calibri" pitchFamily="34" charset="-122"/>
                 <a:cs typeface="Calibri" pitchFamily="34" charset="-120"/>
               </a:rPr>
-              <a:t>End on the limits and the fix order: SACK, adaptive timeout, real-network tests.</a:t>
+              <a:t>Q: Is the TCP row real TCP? A: No, it is a model with the same window cap; real kernel TCP needs netem on Linux, and we provide the script. Q: Why did you not implement SACK in C? A: Time; the simulation shows it is the biggest win and it is the first item of future work. Q: Is 20 runs enough? A: The intervals exclude zero for 5G and satellite and include zero for lossy.</a:t>
             </a:r>
             <a:endParaRPr lang="en-US" sz="1400" dirty="0"/>
           </a:p>
@@ -14085,7 +14270,7 @@
                 <a:ea typeface="Calibri" pitchFamily="34" charset="-122"/>
                 <a:cs typeface="Calibri" pitchFamily="34" charset="-120"/>
               </a:rPr>
-              <a:t>22. Thank you</a:t>
+              <a:t>22. Learnings and future work</a:t>
             </a:r>
             <a:endParaRPr lang="en-US" sz="2600" dirty="0"/>
           </a:p>
@@ -14124,7 +14309,7 @@
                 <a:ea typeface="Calibri" pitchFamily="34" charset="-122"/>
                 <a:cs typeface="Calibri" pitchFamily="34" charset="-120"/>
               </a:rPr>
-              <a:t>Time on this slide: 0:15</a:t>
+              <a:t>Time on this slide: 0:50</a:t>
             </a:r>
             <a:endParaRPr lang="en-US" sz="1300" dirty="0"/>
           </a:p>
@@ -14277,7 +14462,49 @@
                 <a:ea typeface="Calibri" pitchFamily="34" charset="-122"/>
                 <a:cs typeface="Calibri" pitchFamily="34" charset="-120"/>
               </a:rPr>
-              <a:t>Thank you. The code, report and captures are at github.com/Capsturrrr/rudp. Happy to take questions.</a:t>
+              <a:t>Learned: reliability is a set of simple rules working together; congestion control matters as much as retransmission; testing tools fail in surprising ways.</a:t>
+            </a:r>
+            <a:endParaRPr lang="en-US" sz="1600" dirty="0"/>
+          </a:p>
+          <a:p>
+            <a:pPr marL="342900" indent="-342900">
+              <a:spcAft>
+                <a:spcPts val="600"/>
+              </a:spcAft>
+              <a:buSzPct val="100000"/>
+              <a:buChar char="•"/>
+            </a:pPr>
+            <a:r>
+              <a:rPr lang="en-US" sz="1600" dirty="0">
+                <a:solidFill>
+                  <a:srgbClr val="1B2430"/>
+                </a:solidFill>
+                <a:latin typeface="Calibri" pitchFamily="34" charset="0"/>
+                <a:ea typeface="Calibri" pitchFamily="34" charset="-122"/>
+                <a:cs typeface="Calibri" pitchFamily="34" charset="-120"/>
+              </a:rPr>
+              <a:t>Next: Selective Repeat with SACK, a stronger learning agent, adaptive timeout, and tests on a real multi-machine network.</a:t>
+            </a:r>
+            <a:endParaRPr lang="en-US" sz="1600" dirty="0"/>
+          </a:p>
+          <a:p>
+            <a:pPr marL="342900" indent="-342900">
+              <a:spcAft>
+                <a:spcPts val="600"/>
+              </a:spcAft>
+              <a:buSzPct val="100000"/>
+              <a:buChar char="•"/>
+            </a:pPr>
+            <a:r>
+              <a:rPr lang="en-US" sz="1600" dirty="0">
+                <a:solidFill>
+                  <a:srgbClr val="1B2430"/>
+                </a:solidFill>
+                <a:latin typeface="Calibri" pitchFamily="34" charset="0"/>
+                <a:ea typeface="Calibri" pitchFamily="34" charset="-122"/>
+                <a:cs typeface="Calibri" pitchFamily="34" charset="-120"/>
+              </a:rPr>
+              <a:t>Name the limits before she does: Go-Back-N, loopback-only protocol tests, Smart-RUDP not beating AIMD.</a:t>
             </a:r>
             <a:endParaRPr lang="en-US" sz="1600" dirty="0"/>
           </a:p>
@@ -14355,7 +14582,7 @@
                 <a:ea typeface="Calibri" pitchFamily="34" charset="-122"/>
                 <a:cs typeface="Calibri" pitchFamily="34" charset="-120"/>
               </a:rPr>
-              <a:t>Pause and smile; hand over to questions.</a:t>
+              <a:t>End on the limits and the fix order: SACK, adaptive timeout, real-network tests.</a:t>
             </a:r>
             <a:endParaRPr lang="en-US" sz="1400" dirty="0"/>
           </a:p>
@@ -14426,7 +14653,7 @@
                 <a:ea typeface="Calibri" pitchFamily="34" charset="-122"/>
                 <a:cs typeface="Calibri" pitchFamily="34" charset="-120"/>
               </a:rPr>
-              <a:t>23. Appendix: slow start</a:t>
+              <a:t>23. Thank you</a:t>
             </a:r>
             <a:endParaRPr lang="en-US" sz="2600" dirty="0"/>
           </a:p>
@@ -14465,7 +14692,7 @@
                 <a:ea typeface="Calibri" pitchFamily="34" charset="-122"/>
                 <a:cs typeface="Calibri" pitchFamily="34" charset="-120"/>
               </a:rPr>
-              <a:t>Time on this slide: -</a:t>
+              <a:t>Time on this slide: 0:15</a:t>
             </a:r>
             <a:endParaRPr lang="en-US" sz="1300" dirty="0"/>
           </a:p>
@@ -14618,7 +14845,7 @@
                 <a:ea typeface="Calibri" pitchFamily="34" charset="-122"/>
                 <a:cs typeface="Calibri" pitchFamily="34" charset="-120"/>
               </a:rPr>
-              <a:t>Only if asked: the window starts at 1, adds 1 per ACK until the threshold 16, then 1/window per ACK. In the 62-packet run the final window was 18.71.</a:t>
+              <a:t>Thank you. The code, report and captures are at github.com/Capsturrrr/rudp. Happy to take questions.</a:t>
             </a:r>
             <a:endParaRPr lang="en-US" sz="1600" dirty="0"/>
           </a:p>
@@ -14696,7 +14923,7 @@
                 <a:ea typeface="Calibri" pitchFamily="34" charset="-122"/>
                 <a:cs typeface="Calibri" pitchFamily="34" charset="-120"/>
               </a:rPr>
-              <a:t>Use this slide to answer 'show me congestion avoidance'.</a:t>
+              <a:t>Pause and smile; hand over to questions.</a:t>
             </a:r>
             <a:endParaRPr lang="en-US" sz="1400" dirty="0"/>
           </a:p>
@@ -14767,7 +14994,7 @@
                 <a:ea typeface="Calibri" pitchFamily="34" charset="-122"/>
                 <a:cs typeface="Calibri" pitchFamily="34" charset="-120"/>
               </a:rPr>
-              <a:t>Hard questions and short answers (1 of 2)</a:t>
+              <a:t>24. Appendix: slow start</a:t>
             </a:r>
             <a:endParaRPr lang="en-US" sz="2600" dirty="0"/>
           </a:p>
@@ -14775,7 +15002,46 @@
       </p:sp>
       <p:sp>
         <p:nvSpPr>
-          <p:cNvPr id="3" name="Shape 1"/>
+          <p:cNvPr id="3" name="Text 1"/>
+          <p:cNvSpPr/>
+          <p:nvPr/>
+        </p:nvSpPr>
+        <p:spPr>
+          <a:xfrm>
+            <a:off x="457200" y="804672"/>
+            <a:ext cx="10972800" cy="320040"/>
+          </a:xfrm>
+          <a:prstGeom prst="rect">
+            <a:avLst/>
+          </a:prstGeom>
+          <a:noFill/>
+          <a:ln/>
+        </p:spPr>
+        <p:txBody>
+          <a:bodyPr wrap="square" lIns="0" tIns="0" rIns="0" bIns="0" rtlCol="0" anchor="ctr"/>
+          <a:lstStyle/>
+          <a:p>
+            <a:pPr indent="0" marL="0">
+              <a:buNone/>
+            </a:pPr>
+            <a:r>
+              <a:rPr lang="en-US" sz="1300" dirty="0">
+                <a:solidFill>
+                  <a:srgbClr val="5B6775"/>
+                </a:solidFill>
+                <a:latin typeface="Calibri" pitchFamily="34" charset="0"/>
+                <a:ea typeface="Calibri" pitchFamily="34" charset="-122"/>
+                <a:cs typeface="Calibri" pitchFamily="34" charset="-120"/>
+              </a:rPr>
+              <a:t>Time on this slide: -</a:t>
+            </a:r>
+            <a:endParaRPr lang="en-US" sz="1300" dirty="0"/>
+          </a:p>
+        </p:txBody>
+      </p:sp>
+      <p:sp>
+        <p:nvSpPr>
+          <p:cNvPr id="4" name="Shape 2"/>
           <p:cNvSpPr/>
           <p:nvPr/>
         </p:nvSpPr>
@@ -14798,26 +15064,47 @@
           </a:ln>
         </p:spPr>
       </p:sp>
-      <p:sp>
-        <p:nvSpPr>
-          <p:cNvPr id="4" name="Shape 2"/>
-          <p:cNvSpPr/>
-          <p:nvPr/>
-        </p:nvSpPr>
+      <p:pic>
+        <p:nvPicPr>
+          <p:cNvPr id="5" name="Image 0" descr="th-24.png">    </p:cNvPr>
+          <p:cNvPicPr>
+            <a:picLocks noChangeAspect="1"/>
+          </p:cNvPicPr>
+          <p:nvPr/>
+        </p:nvPicPr>
+        <p:blipFill>
+          <a:blip r:embed="rId1"/>
+          <a:stretch>
+            <a:fillRect/>
+          </a:stretch>
+        </p:blipFill>
         <p:spPr>
           <a:xfrm>
             <a:off x="457200" y="1371600"/>
-            <a:ext cx="11274552" cy="914400"/>
-          </a:xfrm>
-          <a:prstGeom prst="rect">
-            <a:avLst/>
-          </a:prstGeom>
-          <a:solidFill>
-            <a:srgbClr val="F2F6FB"/>
-          </a:solidFill>
-          <a:ln w="9525">
+            <a:ext cx="5669280" cy="3188970"/>
+          </a:xfrm>
+          <a:prstGeom prst="rect">
+            <a:avLst/>
+          </a:prstGeom>
+        </p:spPr>
+      </p:pic>
+      <p:sp>
+        <p:nvSpPr>
+          <p:cNvPr id="6" name="Shape 3"/>
+          <p:cNvSpPr/>
+          <p:nvPr/>
+        </p:nvSpPr>
+        <p:spPr>
+          <a:xfrm>
+            <a:off x="457200" y="1371600"/>
+            <a:ext cx="5669280" cy="3188970"/>
+          </a:xfrm>
+          <a:prstGeom prst="rect">
+            <a:avLst/>
+          </a:prstGeom>
+          <a:ln w="12700">
             <a:solidFill>
-              <a:srgbClr val="D5DEE9"/>
+              <a:srgbClr val="C9D3E0"/>
             </a:solidFill>
             <a:prstDash val="solid"/>
           </a:ln>
@@ -14825,14 +15112,14 @@
       </p:sp>
       <p:sp>
         <p:nvSpPr>
-          <p:cNvPr id="5" name="Text 3"/>
-          <p:cNvSpPr/>
-          <p:nvPr/>
-        </p:nvSpPr>
-        <p:spPr>
-          <a:xfrm>
-            <a:off x="640080" y="1417320"/>
-            <a:ext cx="10972800" cy="320040"/>
+          <p:cNvPr id="7" name="Text 4"/>
+          <p:cNvSpPr/>
+          <p:nvPr/>
+        </p:nvSpPr>
+        <p:spPr>
+          <a:xfrm>
+            <a:off x="6400800" y="1325880"/>
+            <a:ext cx="1828800" cy="320040"/>
           </a:xfrm>
           <a:prstGeom prst="rect">
             <a:avLst/>
@@ -14848,7 +15135,7 @@
               <a:buNone/>
             </a:pPr>
             <a:r>
-              <a:rPr lang="en-US" sz="1500" b="1" dirty="0">
+              <a:rPr lang="en-US" sz="1300" b="1" dirty="0">
                 <a:solidFill>
                   <a:srgbClr val="1F6FEB"/>
                 </a:solidFill>
@@ -14856,22 +15143,22 @@
                 <a:ea typeface="Calibri" pitchFamily="34" charset="-122"/>
                 <a:cs typeface="Calibri" pitchFamily="34" charset="-120"/>
               </a:rPr>
-              <a:t>Is this a lab exercise?</a:t>
-            </a:r>
-            <a:endParaRPr lang="en-US" sz="1500" dirty="0"/>
-          </a:p>
-        </p:txBody>
-      </p:sp>
-      <p:sp>
-        <p:nvSpPr>
-          <p:cNvPr id="6" name="Text 4"/>
-          <p:cNvSpPr/>
-          <p:nvPr/>
-        </p:nvSpPr>
-        <p:spPr>
-          <a:xfrm>
-            <a:off x="640080" y="1737360"/>
-            <a:ext cx="10972800" cy="530352"/>
+              <a:t>SAY</a:t>
+            </a:r>
+            <a:endParaRPr lang="en-US" sz="1300" dirty="0"/>
+          </a:p>
+        </p:txBody>
+      </p:sp>
+      <p:sp>
+        <p:nvSpPr>
+          <p:cNvPr id="8" name="Text 5"/>
+          <p:cNvSpPr/>
+          <p:nvPr/>
+        </p:nvSpPr>
+        <p:spPr>
+          <a:xfrm>
+            <a:off x="6400800" y="1645920"/>
+            <a:ext cx="5349240" cy="3017520"/>
           </a:xfrm>
           <a:prstGeom prst="rect">
             <a:avLst/>
@@ -14883,11 +15170,15 @@
           <a:bodyPr wrap="square" lIns="0" tIns="0" rIns="0" bIns="0" rtlCol="0" anchor="t"/>
           <a:lstStyle/>
           <a:p>
-            <a:pPr indent="0" marL="0">
-              <a:buNone/>
-            </a:pPr>
-            <a:r>
-              <a:rPr lang="en-US" sz="1350" dirty="0">
+            <a:pPr marL="342900" indent="-342900">
+              <a:spcAft>
+                <a:spcPts val="600"/>
+              </a:spcAft>
+              <a:buSzPct val="100000"/>
+              <a:buChar char="•"/>
+            </a:pPr>
+            <a:r>
+              <a:rPr lang="en-US" sz="1600" dirty="0">
                 <a:solidFill>
                   <a:srgbClr val="1B2430"/>
                 </a:solidFill>
@@ -14895,32 +15186,32 @@
                 <a:ea typeface="Calibri" pitchFamily="34" charset="-122"/>
                 <a:cs typeface="Calibri" pitchFamily="34" charset="-120"/>
               </a:rPr>
-              <a:t>A lab sends datagrams. We built reliability and congestion control on top, measured them, and used them in a real chat and a routed network.</a:t>
-            </a:r>
-            <a:endParaRPr lang="en-US" sz="1350" dirty="0"/>
-          </a:p>
-        </p:txBody>
-      </p:sp>
-      <p:sp>
-        <p:nvSpPr>
-          <p:cNvPr id="7" name="Shape 5"/>
-          <p:cNvSpPr/>
-          <p:nvPr/>
-        </p:nvSpPr>
-        <p:spPr>
-          <a:xfrm>
-            <a:off x="457200" y="2377440"/>
-            <a:ext cx="11274552" cy="914400"/>
+              <a:t>Only if asked: the window starts at 1, adds 1 per ACK until the threshold 16, then 1/window per ACK. In the 62-packet run the final window was 18.71.</a:t>
+            </a:r>
+            <a:endParaRPr lang="en-US" sz="1600" dirty="0"/>
+          </a:p>
+        </p:txBody>
+      </p:sp>
+      <p:sp>
+        <p:nvSpPr>
+          <p:cNvPr id="9" name="Shape 6"/>
+          <p:cNvSpPr/>
+          <p:nvPr/>
+        </p:nvSpPr>
+        <p:spPr>
+          <a:xfrm>
+            <a:off x="457200" y="4709160"/>
+            <a:ext cx="5669280" cy="1737360"/>
           </a:xfrm>
           <a:prstGeom prst="rect">
             <a:avLst/>
           </a:prstGeom>
           <a:solidFill>
-            <a:srgbClr val="F2F6FB"/>
+            <a:srgbClr val="FFF6E5"/>
           </a:solidFill>
-          <a:ln w="9525">
+          <a:ln w="12700">
             <a:solidFill>
-              <a:srgbClr val="D5DEE9"/>
+              <a:srgbClr val="F0C987"/>
             </a:solidFill>
             <a:prstDash val="solid"/>
           </a:ln>
@@ -14928,14 +15219,14 @@
       </p:sp>
       <p:sp>
         <p:nvSpPr>
-          <p:cNvPr id="8" name="Text 6"/>
-          <p:cNvSpPr/>
-          <p:nvPr/>
-        </p:nvSpPr>
-        <p:spPr>
-          <a:xfrm>
-            <a:off x="640080" y="2423160"/>
-            <a:ext cx="10972800" cy="320040"/>
+          <p:cNvPr id="10" name="Text 7"/>
+          <p:cNvSpPr/>
+          <p:nvPr/>
+        </p:nvSpPr>
+        <p:spPr>
+          <a:xfrm>
+            <a:off x="594360" y="4754880"/>
+            <a:ext cx="5394960" cy="1645920"/>
           </a:xfrm>
           <a:prstGeom prst="rect">
             <a:avLst/>
@@ -14944,53 +15235,28 @@
           <a:ln/>
         </p:spPr>
         <p:txBody>
-          <a:bodyPr wrap="square" lIns="0" tIns="0" rIns="0" bIns="0" rtlCol="0" anchor="ctr"/>
+          <a:bodyPr wrap="square" lIns="0" tIns="0" rIns="0" bIns="0" rtlCol="0" anchor="t"/>
           <a:lstStyle/>
           <a:p>
             <a:pPr indent="0" marL="0">
               <a:buNone/>
             </a:pPr>
             <a:r>
-              <a:rPr lang="en-US" sz="1500" b="1" dirty="0">
-                <a:solidFill>
-                  <a:srgbClr val="1F6FEB"/>
-                </a:solidFill>
-                <a:latin typeface="Calibri" pitchFamily="34" charset="0"/>
-                <a:ea typeface="Calibri" pitchFamily="34" charset="-122"/>
-                <a:cs typeface="Calibri" pitchFamily="34" charset="-120"/>
-              </a:rPr>
-              <a:t>Why not TCP?</a:t>
-            </a:r>
-            <a:endParaRPr lang="en-US" sz="1500" dirty="0"/>
-          </a:p>
-        </p:txBody>
-      </p:sp>
-      <p:sp>
-        <p:nvSpPr>
-          <p:cNvPr id="9" name="Text 7"/>
-          <p:cNvSpPr/>
-          <p:nvPr/>
-        </p:nvSpPr>
-        <p:spPr>
-          <a:xfrm>
-            <a:off x="640080" y="2743200"/>
-            <a:ext cx="10972800" cy="530352"/>
-          </a:xfrm>
-          <a:prstGeom prst="rect">
-            <a:avLst/>
-          </a:prstGeom>
-          <a:noFill/>
-          <a:ln/>
-        </p:spPr>
-        <p:txBody>
-          <a:bodyPr wrap="square" lIns="0" tIns="0" rIns="0" bIns="0" rtlCol="0" anchor="t"/>
-          <a:lstStyle/>
-          <a:p>
+              <a:rPr lang="en-US" sz="1400" b="1" dirty="0">
+                <a:solidFill>
+                  <a:srgbClr val="B45309"/>
+                </a:solidFill>
+                <a:latin typeface="Calibri" pitchFamily="34" charset="0"/>
+                <a:ea typeface="Calibri" pitchFamily="34" charset="-122"/>
+                <a:cs typeface="Calibri" pitchFamily="34" charset="-120"/>
+              </a:rPr>
+              <a:t>IF ASKED  </a:t>
+            </a:r>
             <a:pPr indent="0" marL="0">
               <a:buNone/>
             </a:pPr>
             <a:r>
-              <a:rPr lang="en-US" sz="1350" dirty="0">
+              <a:rPr lang="en-US" sz="1400" dirty="0">
                 <a:solidFill>
                   <a:srgbClr val="1B2430"/>
                 </a:solidFill>
@@ -14998,318 +15264,9 @@
                 <a:ea typeface="Calibri" pitchFamily="34" charset="-122"/>
                 <a:cs typeface="Calibri" pitchFamily="34" charset="-120"/>
               </a:rPr>
-              <a:t>TCP is in the kernel and cannot be changed. Building our own makes every mechanism visible. QUIC and HTTP/3 do the same.</a:t>
-            </a:r>
-            <a:endParaRPr lang="en-US" sz="1350" dirty="0"/>
-          </a:p>
-        </p:txBody>
-      </p:sp>
-      <p:sp>
-        <p:nvSpPr>
-          <p:cNvPr id="10" name="Shape 8"/>
-          <p:cNvSpPr/>
-          <p:nvPr/>
-        </p:nvSpPr>
-        <p:spPr>
-          <a:xfrm>
-            <a:off x="457200" y="3383280"/>
-            <a:ext cx="11274552" cy="914400"/>
-          </a:xfrm>
-          <a:prstGeom prst="rect">
-            <a:avLst/>
-          </a:prstGeom>
-          <a:solidFill>
-            <a:srgbClr val="F2F6FB"/>
-          </a:solidFill>
-          <a:ln w="9525">
-            <a:solidFill>
-              <a:srgbClr val="D5DEE9"/>
-            </a:solidFill>
-            <a:prstDash val="solid"/>
-          </a:ln>
-        </p:spPr>
-      </p:sp>
-      <p:sp>
-        <p:nvSpPr>
-          <p:cNvPr id="11" name="Text 9"/>
-          <p:cNvSpPr/>
-          <p:nvPr/>
-        </p:nvSpPr>
-        <p:spPr>
-          <a:xfrm>
-            <a:off x="640080" y="3429000"/>
-            <a:ext cx="10972800" cy="320040"/>
-          </a:xfrm>
-          <a:prstGeom prst="rect">
-            <a:avLst/>
-          </a:prstGeom>
-          <a:noFill/>
-          <a:ln/>
-        </p:spPr>
-        <p:txBody>
-          <a:bodyPr wrap="square" lIns="0" tIns="0" rIns="0" bIns="0" rtlCol="0" anchor="ctr"/>
-          <a:lstStyle/>
-          <a:p>
-            <a:pPr indent="0" marL="0">
-              <a:buNone/>
-            </a:pPr>
-            <a:r>
-              <a:rPr lang="en-US" sz="1500" b="1" dirty="0">
-                <a:solidFill>
-                  <a:srgbClr val="1F6FEB"/>
-                </a:solidFill>
-                <a:latin typeface="Calibri" pitchFamily="34" charset="0"/>
-                <a:ea typeface="Calibri" pitchFamily="34" charset="-122"/>
-                <a:cs typeface="Calibri" pitchFamily="34" charset="-120"/>
-              </a:rPr>
-              <a:t>Did Smart-RUDP win?</a:t>
-            </a:r>
-            <a:endParaRPr lang="en-US" sz="1500" dirty="0"/>
-          </a:p>
-        </p:txBody>
-      </p:sp>
-      <p:sp>
-        <p:nvSpPr>
-          <p:cNvPr id="12" name="Text 10"/>
-          <p:cNvSpPr/>
-          <p:nvPr/>
-        </p:nvSpPr>
-        <p:spPr>
-          <a:xfrm>
-            <a:off x="640080" y="3749040"/>
-            <a:ext cx="10972800" cy="530352"/>
-          </a:xfrm>
-          <a:prstGeom prst="rect">
-            <a:avLst/>
-          </a:prstGeom>
-          <a:noFill/>
-          <a:ln/>
-        </p:spPr>
-        <p:txBody>
-          <a:bodyPr wrap="square" lIns="0" tIns="0" rIns="0" bIns="0" rtlCol="0" anchor="t"/>
-          <a:lstStyle/>
-          <a:p>
-            <a:pPr indent="0" marL="0">
-              <a:buNone/>
-            </a:pPr>
-            <a:r>
-              <a:rPr lang="en-US" sz="1350" dirty="0">
-                <a:solidFill>
-                  <a:srgbClr val="1B2430"/>
-                </a:solidFill>
-                <a:latin typeface="Calibri" pitchFamily="34" charset="0"/>
-                <a:ea typeface="Calibri" pitchFamily="34" charset="-122"/>
-                <a:cs typeface="Calibri" pitchFamily="34" charset="-120"/>
-              </a:rPr>
-              <a:t>Experiments: tied on one path, slower on two, and we say so. Chat, retrained on simulated paths: faster than AIMD on 5 of 6 held-out paths, equal on 1, because AIMD resets to 1 on every timeout. Deep RL: a small DQN in the chat gateway gave 3.20 s mean on the same stress paths (training is seed-sensitive; chosen on validation paths). Stress test on 48 unseen random paths: mean 3.73 s Smart vs 7.16 s AIMD; faster on 27, slower on 5, within 5% on 16. Simulated; same start window 10; agent may not shrink without a congestion signal.</a:t>
-            </a:r>
-            <a:endParaRPr lang="en-US" sz="1350" dirty="0"/>
-          </a:p>
-        </p:txBody>
-      </p:sp>
-      <p:sp>
-        <p:nvSpPr>
-          <p:cNvPr id="13" name="Shape 11"/>
-          <p:cNvSpPr/>
-          <p:nvPr/>
-        </p:nvSpPr>
-        <p:spPr>
-          <a:xfrm>
-            <a:off x="457200" y="4389120"/>
-            <a:ext cx="11274552" cy="914400"/>
-          </a:xfrm>
-          <a:prstGeom prst="rect">
-            <a:avLst/>
-          </a:prstGeom>
-          <a:solidFill>
-            <a:srgbClr val="F2F6FB"/>
-          </a:solidFill>
-          <a:ln w="9525">
-            <a:solidFill>
-              <a:srgbClr val="D5DEE9"/>
-            </a:solidFill>
-            <a:prstDash val="solid"/>
-          </a:ln>
-        </p:spPr>
-      </p:sp>
-      <p:sp>
-        <p:nvSpPr>
-          <p:cNvPr id="14" name="Text 12"/>
-          <p:cNvSpPr/>
-          <p:nvPr/>
-        </p:nvSpPr>
-        <p:spPr>
-          <a:xfrm>
-            <a:off x="640080" y="4434840"/>
-            <a:ext cx="10972800" cy="320040"/>
-          </a:xfrm>
-          <a:prstGeom prst="rect">
-            <a:avLst/>
-          </a:prstGeom>
-          <a:noFill/>
-          <a:ln/>
-        </p:spPr>
-        <p:txBody>
-          <a:bodyPr wrap="square" lIns="0" tIns="0" rIns="0" bIns="0" rtlCol="0" anchor="ctr"/>
-          <a:lstStyle/>
-          <a:p>
-            <a:pPr indent="0" marL="0">
-              <a:buNone/>
-            </a:pPr>
-            <a:r>
-              <a:rPr lang="en-US" sz="1500" b="1" dirty="0">
-                <a:solidFill>
-                  <a:srgbClr val="1F6FEB"/>
-                </a:solidFill>
-                <a:latin typeface="Calibri" pitchFamily="34" charset="0"/>
-                <a:ea typeface="Calibri" pitchFamily="34" charset="-122"/>
-                <a:cs typeface="Calibri" pitchFamily="34" charset="-120"/>
-              </a:rPr>
-              <a:t>Why Go-Back-N?</a:t>
-            </a:r>
-            <a:endParaRPr lang="en-US" sz="1500" dirty="0"/>
-          </a:p>
-        </p:txBody>
-      </p:sp>
-      <p:sp>
-        <p:nvSpPr>
-          <p:cNvPr id="15" name="Text 13"/>
-          <p:cNvSpPr/>
-          <p:nvPr/>
-        </p:nvSpPr>
-        <p:spPr>
-          <a:xfrm>
-            <a:off x="640080" y="4754880"/>
-            <a:ext cx="10972800" cy="530352"/>
-          </a:xfrm>
-          <a:prstGeom prst="rect">
-            <a:avLst/>
-          </a:prstGeom>
-          <a:noFill/>
-          <a:ln/>
-        </p:spPr>
-        <p:txBody>
-          <a:bodyPr wrap="square" lIns="0" tIns="0" rIns="0" bIns="0" rtlCol="0" anchor="t"/>
-          <a:lstStyle/>
-          <a:p>
-            <a:pPr indent="0" marL="0">
-              <a:buNone/>
-            </a:pPr>
-            <a:r>
-              <a:rPr lang="en-US" sz="1350" dirty="0">
-                <a:solidFill>
-                  <a:srgbClr val="1B2430"/>
-                </a:solidFill>
-                <a:latin typeface="Calibri" pitchFamily="34" charset="0"/>
-                <a:ea typeface="Calibri" pitchFamily="34" charset="-122"/>
-                <a:cs typeface="Calibri" pitchFamily="34" charset="-120"/>
-              </a:rPr>
-              <a:t>Simpler to build and explain. It wastes bandwidth under loss; Selective Repeat with SACK is future work.</a:t>
-            </a:r>
-            <a:endParaRPr lang="en-US" sz="1350" dirty="0"/>
-          </a:p>
-        </p:txBody>
-      </p:sp>
-      <p:sp>
-        <p:nvSpPr>
-          <p:cNvPr id="16" name="Shape 14"/>
-          <p:cNvSpPr/>
-          <p:nvPr/>
-        </p:nvSpPr>
-        <p:spPr>
-          <a:xfrm>
-            <a:off x="457200" y="5394960"/>
-            <a:ext cx="11274552" cy="914400"/>
-          </a:xfrm>
-          <a:prstGeom prst="rect">
-            <a:avLst/>
-          </a:prstGeom>
-          <a:solidFill>
-            <a:srgbClr val="F2F6FB"/>
-          </a:solidFill>
-          <a:ln w="9525">
-            <a:solidFill>
-              <a:srgbClr val="D5DEE9"/>
-            </a:solidFill>
-            <a:prstDash val="solid"/>
-          </a:ln>
-        </p:spPr>
-      </p:sp>
-      <p:sp>
-        <p:nvSpPr>
-          <p:cNvPr id="17" name="Text 15"/>
-          <p:cNvSpPr/>
-          <p:nvPr/>
-        </p:nvSpPr>
-        <p:spPr>
-          <a:xfrm>
-            <a:off x="640080" y="5440680"/>
-            <a:ext cx="10972800" cy="320040"/>
-          </a:xfrm>
-          <a:prstGeom prst="rect">
-            <a:avLst/>
-          </a:prstGeom>
-          <a:noFill/>
-          <a:ln/>
-        </p:spPr>
-        <p:txBody>
-          <a:bodyPr wrap="square" lIns="0" tIns="0" rIns="0" bIns="0" rtlCol="0" anchor="ctr"/>
-          <a:lstStyle/>
-          <a:p>
-            <a:pPr indent="0" marL="0">
-              <a:buNone/>
-            </a:pPr>
-            <a:r>
-              <a:rPr lang="en-US" sz="1500" b="1" dirty="0">
-                <a:solidFill>
-                  <a:srgbClr val="1F6FEB"/>
-                </a:solidFill>
-                <a:latin typeface="Calibri" pitchFamily="34" charset="0"/>
-                <a:ea typeface="Calibri" pitchFamily="34" charset="-122"/>
-                <a:cs typeface="Calibri" pitchFamily="34" charset="-120"/>
-              </a:rPr>
-              <a:t>Tests ran on one machine?</a:t>
-            </a:r>
-            <a:endParaRPr lang="en-US" sz="1500" dirty="0"/>
-          </a:p>
-        </p:txBody>
-      </p:sp>
-      <p:sp>
-        <p:nvSpPr>
-          <p:cNvPr id="18" name="Text 16"/>
-          <p:cNvSpPr/>
-          <p:nvPr/>
-        </p:nvSpPr>
-        <p:spPr>
-          <a:xfrm>
-            <a:off x="640080" y="5760720"/>
-            <a:ext cx="10972800" cy="530352"/>
-          </a:xfrm>
-          <a:prstGeom prst="rect">
-            <a:avLst/>
-          </a:prstGeom>
-          <a:noFill/>
-          <a:ln/>
-        </p:spPr>
-        <p:txBody>
-          <a:bodyPr wrap="square" lIns="0" tIns="0" rIns="0" bIns="0" rtlCol="0" anchor="t"/>
-          <a:lstStyle/>
-          <a:p>
-            <a:pPr indent="0" marL="0">
-              <a:buNone/>
-            </a:pPr>
-            <a:r>
-              <a:rPr lang="en-US" sz="1350" dirty="0">
-                <a:solidFill>
-                  <a:srgbClr val="1B2430"/>
-                </a:solidFill>
-                <a:latin typeface="Calibri" pitchFamily="34" charset="0"/>
-                <a:ea typeface="Calibri" pitchFamily="34" charset="-122"/>
-                <a:cs typeface="Calibri" pitchFamily="34" charset="-120"/>
-              </a:rPr>
-              <a:t>Yes, with emulated delay, loss and jitter. They do not prove internet performance; the report says so. Chat between laptop and phone is a small real-network check.</a:t>
-            </a:r>
-            <a:endParaRPr lang="en-US" sz="1350" dirty="0"/>
+              <a:t>Use this slide to answer 'show me congestion avoidance'.</a:t>
+            </a:r>
+            <a:endParaRPr lang="en-US" sz="1400" dirty="0"/>
           </a:p>
         </p:txBody>
       </p:sp>
@@ -15324,6 +15281,617 @@
 <file path=ppt/slides/slide27.xml><?xml version="1.0" encoding="utf-8"?>
 <p:sld xmlns:a="http://schemas.openxmlformats.org/drawingml/2006/main" xmlns:r="http://schemas.openxmlformats.org/officeDocument/2006/relationships" xmlns:p="http://schemas.openxmlformats.org/presentationml/2006/main">
   <p:cSld name="Slide 27">
+    <p:bg>
+      <p:bgPr>
+        <a:solidFill>
+          <a:srgbClr val="FFFFFF"/>
+        </a:solidFill>
+      </p:bgPr>
+    </p:bg>
+    <p:spTree>
+      <p:nvGrpSpPr>
+        <p:cNvPr id="1" name=""/>
+        <p:cNvGrpSpPr/>
+        <p:nvPr/>
+      </p:nvGrpSpPr>
+      <p:grpSpPr>
+        <a:xfrm>
+          <a:off x="0" y="0"/>
+          <a:ext cx="0" cy="0"/>
+          <a:chOff x="0" y="0"/>
+          <a:chExt cx="0" cy="0"/>
+        </a:xfrm>
+      </p:grpSpPr>
+      <p:sp>
+        <p:nvSpPr>
+          <p:cNvPr id="2" name="Text 0"/>
+          <p:cNvSpPr/>
+          <p:nvPr/>
+        </p:nvSpPr>
+        <p:spPr>
+          <a:xfrm>
+            <a:off x="457200" y="274320"/>
+            <a:ext cx="9601200" cy="548640"/>
+          </a:xfrm>
+          <a:prstGeom prst="rect">
+            <a:avLst/>
+          </a:prstGeom>
+          <a:noFill/>
+          <a:ln/>
+        </p:spPr>
+        <p:txBody>
+          <a:bodyPr wrap="square" lIns="0" tIns="0" rIns="0" bIns="0" rtlCol="0" anchor="ctr"/>
+          <a:lstStyle/>
+          <a:p>
+            <a:pPr indent="0" marL="0">
+              <a:buNone/>
+            </a:pPr>
+            <a:r>
+              <a:rPr lang="en-US" sz="2600" b="1" dirty="0">
+                <a:solidFill>
+                  <a:srgbClr val="1B2430"/>
+                </a:solidFill>
+                <a:latin typeface="Calibri" pitchFamily="34" charset="0"/>
+                <a:ea typeface="Calibri" pitchFamily="34" charset="-122"/>
+                <a:cs typeface="Calibri" pitchFamily="34" charset="-120"/>
+              </a:rPr>
+              <a:t>Hard questions and short answers (1 of 2)</a:t>
+            </a:r>
+            <a:endParaRPr lang="en-US" sz="2600" dirty="0"/>
+          </a:p>
+        </p:txBody>
+      </p:sp>
+      <p:sp>
+        <p:nvSpPr>
+          <p:cNvPr id="3" name="Shape 1"/>
+          <p:cNvSpPr/>
+          <p:nvPr/>
+        </p:nvSpPr>
+        <p:spPr>
+          <a:xfrm>
+            <a:off x="457200" y="1143000"/>
+            <a:ext cx="11274552" cy="36576"/>
+          </a:xfrm>
+          <a:prstGeom prst="rect">
+            <a:avLst/>
+          </a:prstGeom>
+          <a:solidFill>
+            <a:srgbClr val="1F6FEB"/>
+          </a:solidFill>
+          <a:ln w="12700">
+            <a:solidFill>
+              <a:srgbClr val="1F6FEB"/>
+            </a:solidFill>
+            <a:prstDash val="solid"/>
+          </a:ln>
+        </p:spPr>
+      </p:sp>
+      <p:sp>
+        <p:nvSpPr>
+          <p:cNvPr id="4" name="Shape 2"/>
+          <p:cNvSpPr/>
+          <p:nvPr/>
+        </p:nvSpPr>
+        <p:spPr>
+          <a:xfrm>
+            <a:off x="457200" y="1371600"/>
+            <a:ext cx="11274552" cy="914400"/>
+          </a:xfrm>
+          <a:prstGeom prst="rect">
+            <a:avLst/>
+          </a:prstGeom>
+          <a:solidFill>
+            <a:srgbClr val="F2F6FB"/>
+          </a:solidFill>
+          <a:ln w="9525">
+            <a:solidFill>
+              <a:srgbClr val="D5DEE9"/>
+            </a:solidFill>
+            <a:prstDash val="solid"/>
+          </a:ln>
+        </p:spPr>
+      </p:sp>
+      <p:sp>
+        <p:nvSpPr>
+          <p:cNvPr id="5" name="Text 3"/>
+          <p:cNvSpPr/>
+          <p:nvPr/>
+        </p:nvSpPr>
+        <p:spPr>
+          <a:xfrm>
+            <a:off x="640080" y="1417320"/>
+            <a:ext cx="10972800" cy="320040"/>
+          </a:xfrm>
+          <a:prstGeom prst="rect">
+            <a:avLst/>
+          </a:prstGeom>
+          <a:noFill/>
+          <a:ln/>
+        </p:spPr>
+        <p:txBody>
+          <a:bodyPr wrap="square" lIns="0" tIns="0" rIns="0" bIns="0" rtlCol="0" anchor="ctr"/>
+          <a:lstStyle/>
+          <a:p>
+            <a:pPr indent="0" marL="0">
+              <a:buNone/>
+            </a:pPr>
+            <a:r>
+              <a:rPr lang="en-US" sz="1500" b="1" dirty="0">
+                <a:solidFill>
+                  <a:srgbClr val="1F6FEB"/>
+                </a:solidFill>
+                <a:latin typeface="Calibri" pitchFamily="34" charset="0"/>
+                <a:ea typeface="Calibri" pitchFamily="34" charset="-122"/>
+                <a:cs typeface="Calibri" pitchFamily="34" charset="-120"/>
+              </a:rPr>
+              <a:t>Is this a lab exercise?</a:t>
+            </a:r>
+            <a:endParaRPr lang="en-US" sz="1500" dirty="0"/>
+          </a:p>
+        </p:txBody>
+      </p:sp>
+      <p:sp>
+        <p:nvSpPr>
+          <p:cNvPr id="6" name="Text 4"/>
+          <p:cNvSpPr/>
+          <p:nvPr/>
+        </p:nvSpPr>
+        <p:spPr>
+          <a:xfrm>
+            <a:off x="640080" y="1737360"/>
+            <a:ext cx="10972800" cy="530352"/>
+          </a:xfrm>
+          <a:prstGeom prst="rect">
+            <a:avLst/>
+          </a:prstGeom>
+          <a:noFill/>
+          <a:ln/>
+        </p:spPr>
+        <p:txBody>
+          <a:bodyPr wrap="square" lIns="0" tIns="0" rIns="0" bIns="0" rtlCol="0" anchor="t"/>
+          <a:lstStyle/>
+          <a:p>
+            <a:pPr indent="0" marL="0">
+              <a:buNone/>
+            </a:pPr>
+            <a:r>
+              <a:rPr lang="en-US" sz="1350" dirty="0">
+                <a:solidFill>
+                  <a:srgbClr val="1B2430"/>
+                </a:solidFill>
+                <a:latin typeface="Calibri" pitchFamily="34" charset="0"/>
+                <a:ea typeface="Calibri" pitchFamily="34" charset="-122"/>
+                <a:cs typeface="Calibri" pitchFamily="34" charset="-120"/>
+              </a:rPr>
+              <a:t>A lab sends datagrams. We built reliability and congestion control on top, measured them, and used them in a real chat and a routed network.</a:t>
+            </a:r>
+            <a:endParaRPr lang="en-US" sz="1350" dirty="0"/>
+          </a:p>
+        </p:txBody>
+      </p:sp>
+      <p:sp>
+        <p:nvSpPr>
+          <p:cNvPr id="7" name="Shape 5"/>
+          <p:cNvSpPr/>
+          <p:nvPr/>
+        </p:nvSpPr>
+        <p:spPr>
+          <a:xfrm>
+            <a:off x="457200" y="2377440"/>
+            <a:ext cx="11274552" cy="914400"/>
+          </a:xfrm>
+          <a:prstGeom prst="rect">
+            <a:avLst/>
+          </a:prstGeom>
+          <a:solidFill>
+            <a:srgbClr val="F2F6FB"/>
+          </a:solidFill>
+          <a:ln w="9525">
+            <a:solidFill>
+              <a:srgbClr val="D5DEE9"/>
+            </a:solidFill>
+            <a:prstDash val="solid"/>
+          </a:ln>
+        </p:spPr>
+      </p:sp>
+      <p:sp>
+        <p:nvSpPr>
+          <p:cNvPr id="8" name="Text 6"/>
+          <p:cNvSpPr/>
+          <p:nvPr/>
+        </p:nvSpPr>
+        <p:spPr>
+          <a:xfrm>
+            <a:off x="640080" y="2423160"/>
+            <a:ext cx="10972800" cy="320040"/>
+          </a:xfrm>
+          <a:prstGeom prst="rect">
+            <a:avLst/>
+          </a:prstGeom>
+          <a:noFill/>
+          <a:ln/>
+        </p:spPr>
+        <p:txBody>
+          <a:bodyPr wrap="square" lIns="0" tIns="0" rIns="0" bIns="0" rtlCol="0" anchor="ctr"/>
+          <a:lstStyle/>
+          <a:p>
+            <a:pPr indent="0" marL="0">
+              <a:buNone/>
+            </a:pPr>
+            <a:r>
+              <a:rPr lang="en-US" sz="1500" b="1" dirty="0">
+                <a:solidFill>
+                  <a:srgbClr val="1F6FEB"/>
+                </a:solidFill>
+                <a:latin typeface="Calibri" pitchFamily="34" charset="0"/>
+                <a:ea typeface="Calibri" pitchFamily="34" charset="-122"/>
+                <a:cs typeface="Calibri" pitchFamily="34" charset="-120"/>
+              </a:rPr>
+              <a:t>Why not TCP?</a:t>
+            </a:r>
+            <a:endParaRPr lang="en-US" sz="1500" dirty="0"/>
+          </a:p>
+        </p:txBody>
+      </p:sp>
+      <p:sp>
+        <p:nvSpPr>
+          <p:cNvPr id="9" name="Text 7"/>
+          <p:cNvSpPr/>
+          <p:nvPr/>
+        </p:nvSpPr>
+        <p:spPr>
+          <a:xfrm>
+            <a:off x="640080" y="2743200"/>
+            <a:ext cx="10972800" cy="530352"/>
+          </a:xfrm>
+          <a:prstGeom prst="rect">
+            <a:avLst/>
+          </a:prstGeom>
+          <a:noFill/>
+          <a:ln/>
+        </p:spPr>
+        <p:txBody>
+          <a:bodyPr wrap="square" lIns="0" tIns="0" rIns="0" bIns="0" rtlCol="0" anchor="t"/>
+          <a:lstStyle/>
+          <a:p>
+            <a:pPr indent="0" marL="0">
+              <a:buNone/>
+            </a:pPr>
+            <a:r>
+              <a:rPr lang="en-US" sz="1350" dirty="0">
+                <a:solidFill>
+                  <a:srgbClr val="1B2430"/>
+                </a:solidFill>
+                <a:latin typeface="Calibri" pitchFamily="34" charset="0"/>
+                <a:ea typeface="Calibri" pitchFamily="34" charset="-122"/>
+                <a:cs typeface="Calibri" pitchFamily="34" charset="-120"/>
+              </a:rPr>
+              <a:t>TCP is in the kernel and cannot be changed. Building our own makes every mechanism visible. QUIC and HTTP/3 do the same.</a:t>
+            </a:r>
+            <a:endParaRPr lang="en-US" sz="1350" dirty="0"/>
+          </a:p>
+        </p:txBody>
+      </p:sp>
+      <p:sp>
+        <p:nvSpPr>
+          <p:cNvPr id="10" name="Shape 8"/>
+          <p:cNvSpPr/>
+          <p:nvPr/>
+        </p:nvSpPr>
+        <p:spPr>
+          <a:xfrm>
+            <a:off x="457200" y="3383280"/>
+            <a:ext cx="11274552" cy="914400"/>
+          </a:xfrm>
+          <a:prstGeom prst="rect">
+            <a:avLst/>
+          </a:prstGeom>
+          <a:solidFill>
+            <a:srgbClr val="F2F6FB"/>
+          </a:solidFill>
+          <a:ln w="9525">
+            <a:solidFill>
+              <a:srgbClr val="D5DEE9"/>
+            </a:solidFill>
+            <a:prstDash val="solid"/>
+          </a:ln>
+        </p:spPr>
+      </p:sp>
+      <p:sp>
+        <p:nvSpPr>
+          <p:cNvPr id="11" name="Text 9"/>
+          <p:cNvSpPr/>
+          <p:nvPr/>
+        </p:nvSpPr>
+        <p:spPr>
+          <a:xfrm>
+            <a:off x="640080" y="3429000"/>
+            <a:ext cx="10972800" cy="320040"/>
+          </a:xfrm>
+          <a:prstGeom prst="rect">
+            <a:avLst/>
+          </a:prstGeom>
+          <a:noFill/>
+          <a:ln/>
+        </p:spPr>
+        <p:txBody>
+          <a:bodyPr wrap="square" lIns="0" tIns="0" rIns="0" bIns="0" rtlCol="0" anchor="ctr"/>
+          <a:lstStyle/>
+          <a:p>
+            <a:pPr indent="0" marL="0">
+              <a:buNone/>
+            </a:pPr>
+            <a:r>
+              <a:rPr lang="en-US" sz="1500" b="1" dirty="0">
+                <a:solidFill>
+                  <a:srgbClr val="1F6FEB"/>
+                </a:solidFill>
+                <a:latin typeface="Calibri" pitchFamily="34" charset="0"/>
+                <a:ea typeface="Calibri" pitchFamily="34" charset="-122"/>
+                <a:cs typeface="Calibri" pitchFamily="34" charset="-120"/>
+              </a:rPr>
+              <a:t>Did Smart-RUDP win?</a:t>
+            </a:r>
+            <a:endParaRPr lang="en-US" sz="1500" dirty="0"/>
+          </a:p>
+        </p:txBody>
+      </p:sp>
+      <p:sp>
+        <p:nvSpPr>
+          <p:cNvPr id="12" name="Text 10"/>
+          <p:cNvSpPr/>
+          <p:nvPr/>
+        </p:nvSpPr>
+        <p:spPr>
+          <a:xfrm>
+            <a:off x="640080" y="3749040"/>
+            <a:ext cx="10972800" cy="530352"/>
+          </a:xfrm>
+          <a:prstGeom prst="rect">
+            <a:avLst/>
+          </a:prstGeom>
+          <a:noFill/>
+          <a:ln/>
+        </p:spPr>
+        <p:txBody>
+          <a:bodyPr wrap="square" lIns="0" tIns="0" rIns="0" bIns="0" rtlCol="0" anchor="t"/>
+          <a:lstStyle/>
+          <a:p>
+            <a:pPr indent="0" marL="0">
+              <a:buNone/>
+            </a:pPr>
+            <a:r>
+              <a:rPr lang="en-US" sz="1350" dirty="0">
+                <a:solidFill>
+                  <a:srgbClr val="1B2430"/>
+                </a:solidFill>
+                <a:latin typeface="Calibri" pitchFamily="34" charset="0"/>
+                <a:ea typeface="Calibri" pitchFamily="34" charset="-122"/>
+                <a:cs typeface="Calibri" pitchFamily="34" charset="-120"/>
+              </a:rPr>
+              <a:t>Experiments: tied on one path, slower on two, and we say so. Chat, retrained on simulated paths: faster than AIMD on 5 of 6 held-out paths, equal on 1, because AIMD resets to 1 on every timeout. Deep RL: a small DQN in the chat gateway gave 3.20 s mean on the same stress paths (training is seed-sensitive; chosen on validation paths). Stress test on 48 unseen random paths: mean 3.73 s Smart vs 7.16 s AIMD; faster on 27, slower on 5, within 5% on 16. Simulated; same start window 10; agent may not shrink without a congestion signal.</a:t>
+            </a:r>
+            <a:endParaRPr lang="en-US" sz="1350" dirty="0"/>
+          </a:p>
+        </p:txBody>
+      </p:sp>
+      <p:sp>
+        <p:nvSpPr>
+          <p:cNvPr id="13" name="Shape 11"/>
+          <p:cNvSpPr/>
+          <p:nvPr/>
+        </p:nvSpPr>
+        <p:spPr>
+          <a:xfrm>
+            <a:off x="457200" y="4389120"/>
+            <a:ext cx="11274552" cy="914400"/>
+          </a:xfrm>
+          <a:prstGeom prst="rect">
+            <a:avLst/>
+          </a:prstGeom>
+          <a:solidFill>
+            <a:srgbClr val="F2F6FB"/>
+          </a:solidFill>
+          <a:ln w="9525">
+            <a:solidFill>
+              <a:srgbClr val="D5DEE9"/>
+            </a:solidFill>
+            <a:prstDash val="solid"/>
+          </a:ln>
+        </p:spPr>
+      </p:sp>
+      <p:sp>
+        <p:nvSpPr>
+          <p:cNvPr id="14" name="Text 12"/>
+          <p:cNvSpPr/>
+          <p:nvPr/>
+        </p:nvSpPr>
+        <p:spPr>
+          <a:xfrm>
+            <a:off x="640080" y="4434840"/>
+            <a:ext cx="10972800" cy="320040"/>
+          </a:xfrm>
+          <a:prstGeom prst="rect">
+            <a:avLst/>
+          </a:prstGeom>
+          <a:noFill/>
+          <a:ln/>
+        </p:spPr>
+        <p:txBody>
+          <a:bodyPr wrap="square" lIns="0" tIns="0" rIns="0" bIns="0" rtlCol="0" anchor="ctr"/>
+          <a:lstStyle/>
+          <a:p>
+            <a:pPr indent="0" marL="0">
+              <a:buNone/>
+            </a:pPr>
+            <a:r>
+              <a:rPr lang="en-US" sz="1500" b="1" dirty="0">
+                <a:solidFill>
+                  <a:srgbClr val="1F6FEB"/>
+                </a:solidFill>
+                <a:latin typeface="Calibri" pitchFamily="34" charset="0"/>
+                <a:ea typeface="Calibri" pitchFamily="34" charset="-122"/>
+                <a:cs typeface="Calibri" pitchFamily="34" charset="-120"/>
+              </a:rPr>
+              <a:t>Why Go-Back-N?</a:t>
+            </a:r>
+            <a:endParaRPr lang="en-US" sz="1500" dirty="0"/>
+          </a:p>
+        </p:txBody>
+      </p:sp>
+      <p:sp>
+        <p:nvSpPr>
+          <p:cNvPr id="15" name="Text 13"/>
+          <p:cNvSpPr/>
+          <p:nvPr/>
+        </p:nvSpPr>
+        <p:spPr>
+          <a:xfrm>
+            <a:off x="640080" y="4754880"/>
+            <a:ext cx="10972800" cy="530352"/>
+          </a:xfrm>
+          <a:prstGeom prst="rect">
+            <a:avLst/>
+          </a:prstGeom>
+          <a:noFill/>
+          <a:ln/>
+        </p:spPr>
+        <p:txBody>
+          <a:bodyPr wrap="square" lIns="0" tIns="0" rIns="0" bIns="0" rtlCol="0" anchor="t"/>
+          <a:lstStyle/>
+          <a:p>
+            <a:pPr indent="0" marL="0">
+              <a:buNone/>
+            </a:pPr>
+            <a:r>
+              <a:rPr lang="en-US" sz="1350" dirty="0">
+                <a:solidFill>
+                  <a:srgbClr val="1B2430"/>
+                </a:solidFill>
+                <a:latin typeface="Calibri" pitchFamily="34" charset="0"/>
+                <a:ea typeface="Calibri" pitchFamily="34" charset="-122"/>
+                <a:cs typeface="Calibri" pitchFamily="34" charset="-120"/>
+              </a:rPr>
+              <a:t>Simpler to build and explain. It wastes bandwidth under loss; Selective Repeat with SACK is future work.</a:t>
+            </a:r>
+            <a:endParaRPr lang="en-US" sz="1350" dirty="0"/>
+          </a:p>
+        </p:txBody>
+      </p:sp>
+      <p:sp>
+        <p:nvSpPr>
+          <p:cNvPr id="16" name="Shape 14"/>
+          <p:cNvSpPr/>
+          <p:nvPr/>
+        </p:nvSpPr>
+        <p:spPr>
+          <a:xfrm>
+            <a:off x="457200" y="5394960"/>
+            <a:ext cx="11274552" cy="914400"/>
+          </a:xfrm>
+          <a:prstGeom prst="rect">
+            <a:avLst/>
+          </a:prstGeom>
+          <a:solidFill>
+            <a:srgbClr val="F2F6FB"/>
+          </a:solidFill>
+          <a:ln w="9525">
+            <a:solidFill>
+              <a:srgbClr val="D5DEE9"/>
+            </a:solidFill>
+            <a:prstDash val="solid"/>
+          </a:ln>
+        </p:spPr>
+      </p:sp>
+      <p:sp>
+        <p:nvSpPr>
+          <p:cNvPr id="17" name="Text 15"/>
+          <p:cNvSpPr/>
+          <p:nvPr/>
+        </p:nvSpPr>
+        <p:spPr>
+          <a:xfrm>
+            <a:off x="640080" y="5440680"/>
+            <a:ext cx="10972800" cy="320040"/>
+          </a:xfrm>
+          <a:prstGeom prst="rect">
+            <a:avLst/>
+          </a:prstGeom>
+          <a:noFill/>
+          <a:ln/>
+        </p:spPr>
+        <p:txBody>
+          <a:bodyPr wrap="square" lIns="0" tIns="0" rIns="0" bIns="0" rtlCol="0" anchor="ctr"/>
+          <a:lstStyle/>
+          <a:p>
+            <a:pPr indent="0" marL="0">
+              <a:buNone/>
+            </a:pPr>
+            <a:r>
+              <a:rPr lang="en-US" sz="1500" b="1" dirty="0">
+                <a:solidFill>
+                  <a:srgbClr val="1F6FEB"/>
+                </a:solidFill>
+                <a:latin typeface="Calibri" pitchFamily="34" charset="0"/>
+                <a:ea typeface="Calibri" pitchFamily="34" charset="-122"/>
+                <a:cs typeface="Calibri" pitchFamily="34" charset="-120"/>
+              </a:rPr>
+              <a:t>Tests ran on one machine?</a:t>
+            </a:r>
+            <a:endParaRPr lang="en-US" sz="1500" dirty="0"/>
+          </a:p>
+        </p:txBody>
+      </p:sp>
+      <p:sp>
+        <p:nvSpPr>
+          <p:cNvPr id="18" name="Text 16"/>
+          <p:cNvSpPr/>
+          <p:nvPr/>
+        </p:nvSpPr>
+        <p:spPr>
+          <a:xfrm>
+            <a:off x="640080" y="5760720"/>
+            <a:ext cx="10972800" cy="530352"/>
+          </a:xfrm>
+          <a:prstGeom prst="rect">
+            <a:avLst/>
+          </a:prstGeom>
+          <a:noFill/>
+          <a:ln/>
+        </p:spPr>
+        <p:txBody>
+          <a:bodyPr wrap="square" lIns="0" tIns="0" rIns="0" bIns="0" rtlCol="0" anchor="t"/>
+          <a:lstStyle/>
+          <a:p>
+            <a:pPr indent="0" marL="0">
+              <a:buNone/>
+            </a:pPr>
+            <a:r>
+              <a:rPr lang="en-US" sz="1350" dirty="0">
+                <a:solidFill>
+                  <a:srgbClr val="1B2430"/>
+                </a:solidFill>
+                <a:latin typeface="Calibri" pitchFamily="34" charset="0"/>
+                <a:ea typeface="Calibri" pitchFamily="34" charset="-122"/>
+                <a:cs typeface="Calibri" pitchFamily="34" charset="-120"/>
+              </a:rPr>
+              <a:t>Yes, with emulated delay, loss and jitter. They do not prove internet performance; the report says so. Chat between laptop and phone is a small real-network check.</a:t>
+            </a:r>
+            <a:endParaRPr lang="en-US" sz="1350" dirty="0"/>
+          </a:p>
+        </p:txBody>
+      </p:sp>
+    </p:spTree>
+  </p:cSld>
+  <p:clrMapOvr>
+    <a:masterClrMapping/>
+  </p:clrMapOvr>
+</p:sld>
+</file>
+
+<file path=ppt/slides/slide28.xml><?xml version="1.0" encoding="utf-8"?>
+<p:sld xmlns:a="http://schemas.openxmlformats.org/drawingml/2006/main" xmlns:r="http://schemas.openxmlformats.org/officeDocument/2006/relationships" xmlns:p="http://schemas.openxmlformats.org/presentationml/2006/main">
+  <p:cSld name="Slide 28">
     <p:bg>
       <p:bgPr>
         <a:solidFill>

</xml_diff>

<commit_message>
Neural agent and selective ACK in the C transport, test suite, CI evaluations, docs updated
Co-Authored-By: Claude Sonnet 5.5 <noreply@anthropic.com>
Claude-Session: https://claude.ai/code/session_01NX2zRNpdVAnzFNKmqomzKu
</commit_message>
<xml_diff>
--- a/docs/RUDP_Host_Guide.pptx
+++ b/docs/RUDP_Host_Guide.pptx
@@ -33,9 +33,10 @@
     <p:sldId id="281" r:id="rId27"/>
     <p:sldId id="282" r:id="rId28"/>
     <p:sldId id="283" r:id="rId29"/>
+    <p:sldId id="284" r:id="rId30"/>
   </p:sldIdLst>
   <p:notesMasterIdLst>
-    <p:notesMasterId r:id="rId30"/>
+    <p:notesMasterId r:id="rId31"/>
   </p:notesMasterIdLst>
   <p:sldSz cx="12192000" cy="6858000"/>
   <p:notesSz cx="6858000" cy="12192000"/>
@@ -2313,6 +2314,94 @@
             <a:fld id="{F7021451-1387-4CA6-816F-3879F97B5CBC}" type="slidenum">
               <a:rPr lang="en-US"/>
               <a:t>28</a:t>
+            </a:fld>
+            <a:endParaRPr lang="en-US"/>
+          </a:p>
+        </p:txBody>
+      </p:sp>
+    </p:spTree>
+    <p:extLst>
+      <p:ext uri="{BB962C8B-B14F-4D97-AF65-F5344CB8AC3E}">
+        <p14:creationId xmlns:p14="http://schemas.microsoft.com/office/powerpoint/2010/main" val="1024086991"/>
+      </p:ext>
+    </p:extLst>
+  </p:cSld>
+  <p:clrMapOvr>
+    <a:masterClrMapping/>
+  </p:clrMapOvr>
+</p:notes>
+</file>
+
+<file path=ppt/notesSlides/notesSlide29.xml><?xml version="1.0" encoding="utf-8"?>
+<p:notes xmlns:a="http://schemas.openxmlformats.org/drawingml/2006/main" xmlns:r="http://schemas.openxmlformats.org/officeDocument/2006/relationships" xmlns:p="http://schemas.openxmlformats.org/presentationml/2006/main">
+  <p:cSld>
+    <p:spTree>
+      <p:nvGrpSpPr>
+        <p:cNvPr id="1" name=""/>
+        <p:cNvGrpSpPr/>
+        <p:nvPr/>
+      </p:nvGrpSpPr>
+      <p:grpSpPr>
+        <a:xfrm>
+          <a:off x="0" y="0"/>
+          <a:ext cx="0" cy="0"/>
+          <a:chOff x="0" y="0"/>
+          <a:chExt cx="0" cy="0"/>
+        </a:xfrm>
+      </p:grpSpPr>
+      <p:sp>
+        <p:nvSpPr>
+          <p:cNvPr id="2" name="Slide Image Placeholder 1"/>
+          <p:cNvSpPr>
+            <a:spLocks noGrp="1" noRot="1" noChangeAspect="1"/>
+          </p:cNvSpPr>
+          <p:nvPr>
+            <p:ph type="sldImg"/>
+          </p:nvPr>
+        </p:nvSpPr>
+        <p:spPr/>
+      </p:sp>
+      <p:sp>
+        <p:nvSpPr>
+          <p:cNvPr id="3" name="Notes Placeholder 2"/>
+          <p:cNvSpPr>
+            <a:spLocks noGrp="1"/>
+          </p:cNvSpPr>
+          <p:nvPr>
+            <p:ph type="body" idx="1"/>
+          </p:nvPr>
+        </p:nvSpPr>
+        <p:spPr/>
+        <p:txBody>
+          <a:bodyPr/>
+          <a:lstStyle/>
+          <a:p>
+            <a:r>
+              <a:rPr lang="en-US" dirty="0"/>
+              <a:t/>
+            </a:r>
+            <a:endParaRPr lang="en-US" dirty="0"/>
+          </a:p>
+        </p:txBody>
+      </p:sp>
+      <p:sp>
+        <p:nvSpPr>
+          <p:cNvPr id="4" name="Slide Number Placeholder 3"/>
+          <p:cNvSpPr>
+            <a:spLocks noGrp="1"/>
+          </p:cNvSpPr>
+          <p:nvPr>
+            <p:ph type="sldNum" sz="quarter" idx="10"/>
+          </p:nvPr>
+        </p:nvSpPr>
+        <p:spPr/>
+        <p:txBody>
+          <a:bodyPr/>
+          <a:lstStyle/>
+          <a:p>
+            <a:fld id="{F7021451-1387-4CA6-816F-3879F97B5CBC}" type="slidenum">
+              <a:rPr lang="en-US"/>
+              <a:t>29</a:t>
             </a:fld>
             <a:endParaRPr lang="en-US"/>
           </a:p>
@@ -8055,7 +8144,7 @@
                           <a:ea typeface="Calibri" pitchFamily="34" charset="-122"/>
                           <a:cs typeface="Calibri" pitchFamily="34" charset="-120"/>
                         </a:rPr>
-                        <a:t>13</a:t>
+                        <a:t>14</a:t>
                       </a:r>
                       <a:endParaRPr lang="en-US" sz="1200" dirty="0">
                         <a:latin typeface="Calibri" charset="0"/>
@@ -8120,7 +8209,7 @@
                           <a:ea typeface="Calibri" pitchFamily="34" charset="-122"/>
                           <a:cs typeface="Calibri" pitchFamily="34" charset="-120"/>
                         </a:rPr>
-                        <a:t>Network design</a:t>
+                        <a:t>Packet Tracer results</a:t>
                       </a:r>
                       <a:endParaRPr lang="en-US" sz="1200" dirty="0">
                         <a:latin typeface="Calibri" charset="0"/>
@@ -8185,7 +8274,7 @@
                           <a:ea typeface="Calibri" pitchFamily="34" charset="-122"/>
                           <a:cs typeface="Calibri" pitchFamily="34" charset="-120"/>
                         </a:rPr>
-                        <a:t>0:50</a:t>
+                        <a:t>0:40</a:t>
                       </a:r>
                       <a:endParaRPr lang="en-US" sz="1200" dirty="0">
                         <a:latin typeface="Calibri" charset="0"/>
@@ -8447,7 +8536,7 @@
                           <a:ea typeface="Calibri" pitchFamily="34" charset="-122"/>
                           <a:cs typeface="Calibri" pitchFamily="34" charset="-120"/>
                         </a:rPr>
-                        <a:t>14</a:t>
+                        <a:t>15</a:t>
                       </a:r>
                       <a:endParaRPr lang="en-US" sz="1200" dirty="0">
                         <a:latin typeface="Calibri" charset="0"/>
@@ -8512,7 +8601,7 @@
                           <a:ea typeface="Calibri" pitchFamily="34" charset="-122"/>
                           <a:cs typeface="Calibri" pitchFamily="34" charset="-120"/>
                         </a:rPr>
-                        <a:t>Packet Tracer results</a:t>
+                        <a:t>Smart-RUDP design</a:t>
                       </a:r>
                       <a:endParaRPr lang="en-US" sz="1200" dirty="0">
                         <a:latin typeface="Calibri" charset="0"/>
@@ -8577,7 +8666,7 @@
                           <a:ea typeface="Calibri" pitchFamily="34" charset="-122"/>
                           <a:cs typeface="Calibri" pitchFamily="34" charset="-120"/>
                         </a:rPr>
-                        <a:t>0:40</a:t>
+                        <a:t>0:50</a:t>
                       </a:r>
                       <a:endParaRPr lang="en-US" sz="1200" dirty="0">
                         <a:latin typeface="Calibri" charset="0"/>
@@ -8839,7 +8928,7 @@
                           <a:ea typeface="Calibri" pitchFamily="34" charset="-122"/>
                           <a:cs typeface="Calibri" pitchFamily="34" charset="-120"/>
                         </a:rPr>
-                        <a:t>15</a:t>
+                        <a:t>16</a:t>
                       </a:r>
                       <a:endParaRPr lang="en-US" sz="1200" dirty="0">
                         <a:latin typeface="Calibri" charset="0"/>
@@ -8904,7 +8993,7 @@
                           <a:ea typeface="Calibri" pitchFamily="34" charset="-122"/>
                           <a:cs typeface="Calibri" pitchFamily="34" charset="-120"/>
                         </a:rPr>
-                        <a:t>Smart-RUDP design</a:t>
+                        <a:t>The AI agent in our code</a:t>
                       </a:r>
                       <a:endParaRPr lang="en-US" sz="1200" dirty="0">
                         <a:latin typeface="Calibri" charset="0"/>
@@ -8969,7 +9058,7 @@
                           <a:ea typeface="Calibri" pitchFamily="34" charset="-122"/>
                           <a:cs typeface="Calibri" pitchFamily="34" charset="-120"/>
                         </a:rPr>
-                        <a:t>0:50</a:t>
+                        <a:t>1:00</a:t>
                       </a:r>
                       <a:endParaRPr lang="en-US" sz="1200" dirty="0">
                         <a:latin typeface="Calibri" charset="0"/>
@@ -9231,7 +9320,7 @@
                           <a:ea typeface="Calibri" pitchFamily="34" charset="-122"/>
                           <a:cs typeface="Calibri" pitchFamily="34" charset="-120"/>
                         </a:rPr>
-                        <a:t>16</a:t>
+                        <a:t>17</a:t>
                       </a:r>
                       <a:endParaRPr lang="en-US" sz="1200" dirty="0">
                         <a:latin typeface="Calibri" charset="0"/>
@@ -9296,7 +9385,7 @@
                           <a:ea typeface="Calibri" pitchFamily="34" charset="-122"/>
                           <a:cs typeface="Calibri" pitchFamily="34" charset="-120"/>
                         </a:rPr>
-                        <a:t>The AI agent in our code</a:t>
+                        <a:t>Smart-RUDP result</a:t>
                       </a:r>
                       <a:endParaRPr lang="en-US" sz="1200" dirty="0">
                         <a:latin typeface="Calibri" charset="0"/>
@@ -9361,7 +9450,7 @@
                           <a:ea typeface="Calibri" pitchFamily="34" charset="-122"/>
                           <a:cs typeface="Calibri" pitchFamily="34" charset="-120"/>
                         </a:rPr>
-                        <a:t>1:00</a:t>
+                        <a:t>0:50</a:t>
                       </a:r>
                       <a:endParaRPr lang="en-US" sz="1200" dirty="0">
                         <a:latin typeface="Calibri" charset="0"/>
@@ -9623,7 +9712,7 @@
                           <a:ea typeface="Calibri" pitchFamily="34" charset="-122"/>
                           <a:cs typeface="Calibri" pitchFamily="34" charset="-120"/>
                         </a:rPr>
-                        <a:t>17</a:t>
+                        <a:t>18</a:t>
                       </a:r>
                       <a:endParaRPr lang="en-US" sz="1200" dirty="0">
                         <a:latin typeface="Calibri" charset="0"/>
@@ -9688,7 +9777,7 @@
                           <a:ea typeface="Calibri" pitchFamily="34" charset="-122"/>
                           <a:cs typeface="Calibri" pitchFamily="34" charset="-120"/>
                         </a:rPr>
-                        <a:t>Smart-RUDP result</a:t>
+                        <a:t>Wireshark traces</a:t>
                       </a:r>
                       <a:endParaRPr lang="en-US" sz="1200" dirty="0">
                         <a:latin typeface="Calibri" charset="0"/>
@@ -9753,7 +9842,7 @@
                           <a:ea typeface="Calibri" pitchFamily="34" charset="-122"/>
                           <a:cs typeface="Calibri" pitchFamily="34" charset="-120"/>
                         </a:rPr>
-                        <a:t>0:50</a:t>
+                        <a:t>0:40</a:t>
                       </a:r>
                       <a:endParaRPr lang="en-US" sz="1200" dirty="0">
                         <a:latin typeface="Calibri" charset="0"/>
@@ -10015,7 +10104,7 @@
                           <a:ea typeface="Calibri" pitchFamily="34" charset="-122"/>
                           <a:cs typeface="Calibri" pitchFamily="34" charset="-120"/>
                         </a:rPr>
-                        <a:t>18</a:t>
+                        <a:t>19</a:t>
                       </a:r>
                       <a:endParaRPr lang="en-US" sz="1200" dirty="0">
                         <a:latin typeface="Calibri" charset="0"/>
@@ -10080,7 +10169,7 @@
                           <a:ea typeface="Calibri" pitchFamily="34" charset="-122"/>
                           <a:cs typeface="Calibri" pitchFamily="34" charset="-120"/>
                         </a:rPr>
-                        <a:t>Wireshark traces</a:t>
+                        <a:t>Wireshark real capture</a:t>
                       </a:r>
                       <a:endParaRPr lang="en-US" sz="1200" dirty="0">
                         <a:latin typeface="Calibri" charset="0"/>
@@ -10145,7 +10234,7 @@
                           <a:ea typeface="Calibri" pitchFamily="34" charset="-122"/>
                           <a:cs typeface="Calibri" pitchFamily="34" charset="-120"/>
                         </a:rPr>
-                        <a:t>0:40</a:t>
+                        <a:t>0:50</a:t>
                       </a:r>
                       <a:endParaRPr lang="en-US" sz="1200" dirty="0">
                         <a:latin typeface="Calibri" charset="0"/>
@@ -10407,7 +10496,7 @@
                           <a:ea typeface="Calibri" pitchFamily="34" charset="-122"/>
                           <a:cs typeface="Calibri" pitchFamily="34" charset="-120"/>
                         </a:rPr>
-                        <a:t>19</a:t>
+                        <a:t>20</a:t>
                       </a:r>
                       <a:endParaRPr lang="en-US" sz="1200" dirty="0">
                         <a:latin typeface="Calibri" charset="0"/>
@@ -10472,7 +10561,7 @@
                           <a:ea typeface="Calibri" pitchFamily="34" charset="-122"/>
                           <a:cs typeface="Calibri" pitchFamily="34" charset="-120"/>
                         </a:rPr>
-                        <a:t>Wireshark real capture</a:t>
+                        <a:t>RUDP Chat demo</a:t>
                       </a:r>
                       <a:endParaRPr lang="en-US" sz="1200" dirty="0">
                         <a:latin typeface="Calibri" charset="0"/>
@@ -10537,7 +10626,7 @@
                           <a:ea typeface="Calibri" pitchFamily="34" charset="-122"/>
                           <a:cs typeface="Calibri" pitchFamily="34" charset="-120"/>
                         </a:rPr>
-                        <a:t>0:50</a:t>
+                        <a:t>1:00</a:t>
                       </a:r>
                       <a:endParaRPr lang="en-US" sz="1200" dirty="0">
                         <a:latin typeface="Calibri" charset="0"/>
@@ -10799,7 +10888,7 @@
                           <a:ea typeface="Calibri" pitchFamily="34" charset="-122"/>
                           <a:cs typeface="Calibri" pitchFamily="34" charset="-120"/>
                         </a:rPr>
-                        <a:t>20</a:t>
+                        <a:t>21</a:t>
                       </a:r>
                       <a:endParaRPr lang="en-US" sz="1200" dirty="0">
                         <a:latin typeface="Calibri" charset="0"/>
@@ -10864,7 +10953,7 @@
                           <a:ea typeface="Calibri" pitchFamily="34" charset="-122"/>
                           <a:cs typeface="Calibri" pitchFamily="34" charset="-120"/>
                         </a:rPr>
-                        <a:t>RUDP Chat demo</a:t>
+                        <a:t>More evidence: baselines, SACK, reordering</a:t>
                       </a:r>
                       <a:endParaRPr lang="en-US" sz="1200" dirty="0">
                         <a:latin typeface="Calibri" charset="0"/>
@@ -11191,7 +11280,7 @@
                           <a:ea typeface="Calibri" pitchFamily="34" charset="-122"/>
                           <a:cs typeface="Calibri" pitchFamily="34" charset="-120"/>
                         </a:rPr>
-                        <a:t>21</a:t>
+                        <a:t>22</a:t>
                       </a:r>
                       <a:endParaRPr lang="en-US" sz="1200" dirty="0">
                         <a:latin typeface="Calibri" charset="0"/>
@@ -11256,7 +11345,7 @@
                           <a:ea typeface="Calibri" pitchFamily="34" charset="-122"/>
                           <a:cs typeface="Calibri" pitchFamily="34" charset="-120"/>
                         </a:rPr>
-                        <a:t>More evidence: baselines, SACK, reordering</a:t>
+                        <a:t>Neural agent in the C transport</a:t>
                       </a:r>
                       <a:endParaRPr lang="en-US" sz="1200" dirty="0">
                         <a:latin typeface="Calibri" charset="0"/>
@@ -11583,7 +11672,7 @@
                           <a:ea typeface="Calibri" pitchFamily="34" charset="-122"/>
                           <a:cs typeface="Calibri" pitchFamily="34" charset="-120"/>
                         </a:rPr>
-                        <a:t>22</a:t>
+                        <a:t>23</a:t>
                       </a:r>
                       <a:endParaRPr lang="en-US" sz="1200" dirty="0">
                         <a:latin typeface="Calibri" charset="0"/>
@@ -11975,7 +12064,7 @@
                           <a:ea typeface="Calibri" pitchFamily="34" charset="-122"/>
                           <a:cs typeface="Calibri" pitchFamily="34" charset="-120"/>
                         </a:rPr>
-                        <a:t>23</a:t>
+                        <a:t>24</a:t>
                       </a:r>
                       <a:endParaRPr lang="en-US" sz="1200" dirty="0">
                         <a:latin typeface="Calibri" charset="0"/>
@@ -12367,7 +12456,7 @@
                           <a:ea typeface="Calibri" pitchFamily="34" charset="-122"/>
                           <a:cs typeface="Calibri" pitchFamily="34" charset="-120"/>
                         </a:rPr>
-                        <a:t>24</a:t>
+                        <a:t>25</a:t>
                       </a:r>
                       <a:endParaRPr lang="en-US" sz="1200" dirty="0">
                         <a:latin typeface="Calibri" charset="0"/>
@@ -12499,6 +12588,365 @@
                         </a:rPr>
                         <a:t>-</a:t>
                       </a:r>
+                      <a:endParaRPr lang="en-US" sz="1200" dirty="0">
+                        <a:latin typeface="Calibri" charset="0"/>
+                        <a:ea typeface="Calibri" charset="0"/>
+                        <a:cs typeface="Calibri" charset="0"/>
+                      </a:endParaRPr>
+                    </a:p>
+                  </a:txBody>
+                  <a:tcPr marL="91440" marR="91440" marT="45720" marB="45720">
+                    <a:lnL w="6350" cap="flat" cmpd="sng" algn="ctr">
+                      <a:solidFill>
+                        <a:srgbClr val="D5DEE9"/>
+                      </a:solidFill>
+                      <a:prstDash val="solid"/>
+                      <a:round/>
+                      <a:headEnd type="none" w="med" len="med"/>
+                      <a:tailEnd type="none" w="med" len="med"/>
+                    </a:lnL>
+                    <a:lnR w="6350" cap="flat" cmpd="sng" algn="ctr">
+                      <a:solidFill>
+                        <a:srgbClr val="D5DEE9"/>
+                      </a:solidFill>
+                      <a:prstDash val="solid"/>
+                      <a:round/>
+                      <a:headEnd type="none" w="med" len="med"/>
+                      <a:tailEnd type="none" w="med" len="med"/>
+                    </a:lnR>
+                    <a:lnT w="6350" cap="flat" cmpd="sng" algn="ctr">
+                      <a:solidFill>
+                        <a:srgbClr val="D5DEE9"/>
+                      </a:solidFill>
+                      <a:prstDash val="solid"/>
+                      <a:round/>
+                      <a:headEnd type="none" w="med" len="med"/>
+                      <a:tailEnd type="none" w="med" len="med"/>
+                    </a:lnT>
+                    <a:lnB w="6350" cap="flat" cmpd="sng" algn="ctr">
+                      <a:solidFill>
+                        <a:srgbClr val="D5DEE9"/>
+                      </a:solidFill>
+                      <a:prstDash val="solid"/>
+                      <a:round/>
+                      <a:headEnd type="none" w="med" len="med"/>
+                      <a:tailEnd type="none" w="med" len="med"/>
+                    </a:lnB>
+                  </a:tcPr>
+                </a:tc>
+              </a:tr>
+              <a:tr h="347472">
+                <a:tc>
+                  <a:txBody>
+                    <a:bodyPr/>
+                    <a:lstStyle/>
+                    <a:p>
+                      <a:pPr indent="0" marL="0">
+                        <a:buNone/>
+                      </a:pPr>
+                      <a:r>
+                        <a:rPr lang="en-US" sz="1200" dirty="0">
+                          <a:solidFill>
+                            <a:srgbClr val="1B2430"/>
+                          </a:solidFill>
+                          <a:latin typeface="Calibri" pitchFamily="34" charset="0"/>
+                          <a:ea typeface="Calibri" pitchFamily="34" charset="-122"/>
+                          <a:cs typeface="Calibri" pitchFamily="34" charset="-120"/>
+                        </a:rPr>
+                        <a:t>13</a:t>
+                      </a:r>
+                      <a:endParaRPr lang="en-US" sz="1200" dirty="0">
+                        <a:latin typeface="Calibri" charset="0"/>
+                        <a:ea typeface="Calibri" charset="0"/>
+                        <a:cs typeface="Calibri" charset="0"/>
+                      </a:endParaRPr>
+                    </a:p>
+                  </a:txBody>
+                  <a:tcPr marL="91440" marR="91440" marT="45720" marB="45720">
+                    <a:lnL w="6350" cap="flat" cmpd="sng" algn="ctr">
+                      <a:solidFill>
+                        <a:srgbClr val="D5DEE9"/>
+                      </a:solidFill>
+                      <a:prstDash val="solid"/>
+                      <a:round/>
+                      <a:headEnd type="none" w="med" len="med"/>
+                      <a:tailEnd type="none" w="med" len="med"/>
+                    </a:lnL>
+                    <a:lnR w="6350" cap="flat" cmpd="sng" algn="ctr">
+                      <a:solidFill>
+                        <a:srgbClr val="D5DEE9"/>
+                      </a:solidFill>
+                      <a:prstDash val="solid"/>
+                      <a:round/>
+                      <a:headEnd type="none" w="med" len="med"/>
+                      <a:tailEnd type="none" w="med" len="med"/>
+                    </a:lnR>
+                    <a:lnT w="6350" cap="flat" cmpd="sng" algn="ctr">
+                      <a:solidFill>
+                        <a:srgbClr val="D5DEE9"/>
+                      </a:solidFill>
+                      <a:prstDash val="solid"/>
+                      <a:round/>
+                      <a:headEnd type="none" w="med" len="med"/>
+                      <a:tailEnd type="none" w="med" len="med"/>
+                    </a:lnT>
+                    <a:lnB w="6350" cap="flat" cmpd="sng" algn="ctr">
+                      <a:solidFill>
+                        <a:srgbClr val="D5DEE9"/>
+                      </a:solidFill>
+                      <a:prstDash val="solid"/>
+                      <a:round/>
+                      <a:headEnd type="none" w="med" len="med"/>
+                      <a:tailEnd type="none" w="med" len="med"/>
+                    </a:lnB>
+                  </a:tcPr>
+                </a:tc>
+                <a:tc>
+                  <a:txBody>
+                    <a:bodyPr/>
+                    <a:lstStyle/>
+                    <a:p>
+                      <a:pPr indent="0" marL="0">
+                        <a:buNone/>
+                      </a:pPr>
+                      <a:r>
+                        <a:rPr lang="en-US" sz="1200" dirty="0">
+                          <a:solidFill>
+                            <a:srgbClr val="1B2430"/>
+                          </a:solidFill>
+                          <a:latin typeface="Calibri" pitchFamily="34" charset="0"/>
+                          <a:ea typeface="Calibri" pitchFamily="34" charset="-122"/>
+                          <a:cs typeface="Calibri" pitchFamily="34" charset="-120"/>
+                        </a:rPr>
+                        <a:t>Network design</a:t>
+                      </a:r>
+                      <a:endParaRPr lang="en-US" sz="1200" dirty="0">
+                        <a:latin typeface="Calibri" charset="0"/>
+                        <a:ea typeface="Calibri" charset="0"/>
+                        <a:cs typeface="Calibri" charset="0"/>
+                      </a:endParaRPr>
+                    </a:p>
+                  </a:txBody>
+                  <a:tcPr marL="91440" marR="91440" marT="45720" marB="45720">
+                    <a:lnL w="6350" cap="flat" cmpd="sng" algn="ctr">
+                      <a:solidFill>
+                        <a:srgbClr val="D5DEE9"/>
+                      </a:solidFill>
+                      <a:prstDash val="solid"/>
+                      <a:round/>
+                      <a:headEnd type="none" w="med" len="med"/>
+                      <a:tailEnd type="none" w="med" len="med"/>
+                    </a:lnL>
+                    <a:lnR w="6350" cap="flat" cmpd="sng" algn="ctr">
+                      <a:solidFill>
+                        <a:srgbClr val="D5DEE9"/>
+                      </a:solidFill>
+                      <a:prstDash val="solid"/>
+                      <a:round/>
+                      <a:headEnd type="none" w="med" len="med"/>
+                      <a:tailEnd type="none" w="med" len="med"/>
+                    </a:lnR>
+                    <a:lnT w="6350" cap="flat" cmpd="sng" algn="ctr">
+                      <a:solidFill>
+                        <a:srgbClr val="D5DEE9"/>
+                      </a:solidFill>
+                      <a:prstDash val="solid"/>
+                      <a:round/>
+                      <a:headEnd type="none" w="med" len="med"/>
+                      <a:tailEnd type="none" w="med" len="med"/>
+                    </a:lnT>
+                    <a:lnB w="6350" cap="flat" cmpd="sng" algn="ctr">
+                      <a:solidFill>
+                        <a:srgbClr val="D5DEE9"/>
+                      </a:solidFill>
+                      <a:prstDash val="solid"/>
+                      <a:round/>
+                      <a:headEnd type="none" w="med" len="med"/>
+                      <a:tailEnd type="none" w="med" len="med"/>
+                    </a:lnB>
+                  </a:tcPr>
+                </a:tc>
+                <a:tc>
+                  <a:txBody>
+                    <a:bodyPr/>
+                    <a:lstStyle/>
+                    <a:p>
+                      <a:pPr indent="0" marL="0">
+                        <a:buNone/>
+                      </a:pPr>
+                      <a:r>
+                        <a:rPr lang="en-US" sz="1200" dirty="0">
+                          <a:solidFill>
+                            <a:srgbClr val="1B2430"/>
+                          </a:solidFill>
+                          <a:latin typeface="Calibri" pitchFamily="34" charset="0"/>
+                          <a:ea typeface="Calibri" pitchFamily="34" charset="-122"/>
+                          <a:cs typeface="Calibri" pitchFamily="34" charset="-120"/>
+                        </a:rPr>
+                        <a:t>0:50</a:t>
+                      </a:r>
+                      <a:endParaRPr lang="en-US" sz="1200" dirty="0">
+                        <a:latin typeface="Calibri" charset="0"/>
+                        <a:ea typeface="Calibri" charset="0"/>
+                        <a:cs typeface="Calibri" charset="0"/>
+                      </a:endParaRPr>
+                    </a:p>
+                  </a:txBody>
+                  <a:tcPr marL="91440" marR="91440" marT="45720" marB="45720">
+                    <a:lnL w="6350" cap="flat" cmpd="sng" algn="ctr">
+                      <a:solidFill>
+                        <a:srgbClr val="D5DEE9"/>
+                      </a:solidFill>
+                      <a:prstDash val="solid"/>
+                      <a:round/>
+                      <a:headEnd type="none" w="med" len="med"/>
+                      <a:tailEnd type="none" w="med" len="med"/>
+                    </a:lnL>
+                    <a:lnR w="6350" cap="flat" cmpd="sng" algn="ctr">
+                      <a:solidFill>
+                        <a:srgbClr val="D5DEE9"/>
+                      </a:solidFill>
+                      <a:prstDash val="solid"/>
+                      <a:round/>
+                      <a:headEnd type="none" w="med" len="med"/>
+                      <a:tailEnd type="none" w="med" len="med"/>
+                    </a:lnR>
+                    <a:lnT w="6350" cap="flat" cmpd="sng" algn="ctr">
+                      <a:solidFill>
+                        <a:srgbClr val="D5DEE9"/>
+                      </a:solidFill>
+                      <a:prstDash val="solid"/>
+                      <a:round/>
+                      <a:headEnd type="none" w="med" len="med"/>
+                      <a:tailEnd type="none" w="med" len="med"/>
+                    </a:lnT>
+                    <a:lnB w="6350" cap="flat" cmpd="sng" algn="ctr">
+                      <a:solidFill>
+                        <a:srgbClr val="D5DEE9"/>
+                      </a:solidFill>
+                      <a:prstDash val="solid"/>
+                      <a:round/>
+                      <a:headEnd type="none" w="med" len="med"/>
+                      <a:tailEnd type="none" w="med" len="med"/>
+                    </a:lnB>
+                  </a:tcPr>
+                </a:tc>
+                <a:tc>
+                  <a:txBody>
+                    <a:bodyPr/>
+                    <a:lstStyle/>
+                    <a:p>
+                      <a:pPr indent="0" marL="0">
+                        <a:buNone/>
+                      </a:pPr>
+                      <a:endParaRPr lang="en-US" sz="1200" dirty="0">
+                        <a:latin typeface="Calibri" charset="0"/>
+                        <a:ea typeface="Calibri" charset="0"/>
+                        <a:cs typeface="Calibri" charset="0"/>
+                      </a:endParaRPr>
+                    </a:p>
+                  </a:txBody>
+                  <a:tcPr marL="91440" marR="91440" marT="45720" marB="45720">
+                    <a:lnL w="6350" cap="flat" cmpd="sng" algn="ctr">
+                      <a:solidFill>
+                        <a:srgbClr val="D5DEE9"/>
+                      </a:solidFill>
+                      <a:prstDash val="solid"/>
+                      <a:round/>
+                      <a:headEnd type="none" w="med" len="med"/>
+                      <a:tailEnd type="none" w="med" len="med"/>
+                    </a:lnL>
+                    <a:lnR w="6350" cap="flat" cmpd="sng" algn="ctr">
+                      <a:solidFill>
+                        <a:srgbClr val="D5DEE9"/>
+                      </a:solidFill>
+                      <a:prstDash val="solid"/>
+                      <a:round/>
+                      <a:headEnd type="none" w="med" len="med"/>
+                      <a:tailEnd type="none" w="med" len="med"/>
+                    </a:lnR>
+                    <a:lnT w="6350" cap="flat" cmpd="sng" algn="ctr">
+                      <a:solidFill>
+                        <a:srgbClr val="D5DEE9"/>
+                      </a:solidFill>
+                      <a:prstDash val="solid"/>
+                      <a:round/>
+                      <a:headEnd type="none" w="med" len="med"/>
+                      <a:tailEnd type="none" w="med" len="med"/>
+                    </a:lnT>
+                    <a:lnB w="6350" cap="flat" cmpd="sng" algn="ctr">
+                      <a:solidFill>
+                        <a:srgbClr val="D5DEE9"/>
+                      </a:solidFill>
+                      <a:prstDash val="solid"/>
+                      <a:round/>
+                      <a:headEnd type="none" w="med" len="med"/>
+                      <a:tailEnd type="none" w="med" len="med"/>
+                    </a:lnB>
+                  </a:tcPr>
+                </a:tc>
+                <a:tc>
+                  <a:txBody>
+                    <a:bodyPr/>
+                    <a:lstStyle/>
+                    <a:p>
+                      <a:pPr indent="0" marL="0">
+                        <a:buNone/>
+                      </a:pPr>
+                      <a:endParaRPr lang="en-US" sz="1200" dirty="0">
+                        <a:latin typeface="Calibri" charset="0"/>
+                        <a:ea typeface="Calibri" charset="0"/>
+                        <a:cs typeface="Calibri" charset="0"/>
+                      </a:endParaRPr>
+                    </a:p>
+                  </a:txBody>
+                  <a:tcPr marL="91440" marR="91440" marT="45720" marB="45720">
+                    <a:lnL w="6350" cap="flat" cmpd="sng" algn="ctr">
+                      <a:solidFill>
+                        <a:srgbClr val="D5DEE9"/>
+                      </a:solidFill>
+                      <a:prstDash val="solid"/>
+                      <a:round/>
+                      <a:headEnd type="none" w="med" len="med"/>
+                      <a:tailEnd type="none" w="med" len="med"/>
+                    </a:lnL>
+                    <a:lnR w="6350" cap="flat" cmpd="sng" algn="ctr">
+                      <a:solidFill>
+                        <a:srgbClr val="D5DEE9"/>
+                      </a:solidFill>
+                      <a:prstDash val="solid"/>
+                      <a:round/>
+                      <a:headEnd type="none" w="med" len="med"/>
+                      <a:tailEnd type="none" w="med" len="med"/>
+                    </a:lnR>
+                    <a:lnT w="6350" cap="flat" cmpd="sng" algn="ctr">
+                      <a:solidFill>
+                        <a:srgbClr val="D5DEE9"/>
+                      </a:solidFill>
+                      <a:prstDash val="solid"/>
+                      <a:round/>
+                      <a:headEnd type="none" w="med" len="med"/>
+                      <a:tailEnd type="none" w="med" len="med"/>
+                    </a:lnT>
+                    <a:lnB w="6350" cap="flat" cmpd="sng" algn="ctr">
+                      <a:solidFill>
+                        <a:srgbClr val="D5DEE9"/>
+                      </a:solidFill>
+                      <a:prstDash val="solid"/>
+                      <a:round/>
+                      <a:headEnd type="none" w="med" len="med"/>
+                      <a:tailEnd type="none" w="med" len="med"/>
+                    </a:lnB>
+                  </a:tcPr>
+                </a:tc>
+                <a:tc>
+                  <a:txBody>
+                    <a:bodyPr/>
+                    <a:lstStyle/>
+                    <a:p>
+                      <a:pPr indent="0" marL="0">
+                        <a:buNone/>
+                      </a:pPr>
                       <a:endParaRPr lang="en-US" sz="1200" dirty="0">
                         <a:latin typeface="Calibri" charset="0"/>
                         <a:ea typeface="Calibri" charset="0"/>
@@ -14270,7 +14718,7 @@
                 <a:ea typeface="Calibri" pitchFamily="34" charset="-122"/>
                 <a:cs typeface="Calibri" pitchFamily="34" charset="-120"/>
               </a:rPr>
-              <a:t>22. Learnings and future work</a:t>
+              <a:t>22. Neural agent in the C transport</a:t>
             </a:r>
             <a:endParaRPr lang="en-US" sz="2600" dirty="0"/>
           </a:p>
@@ -14309,7 +14757,7 @@
                 <a:ea typeface="Calibri" pitchFamily="34" charset="-122"/>
                 <a:cs typeface="Calibri" pitchFamily="34" charset="-120"/>
               </a:rPr>
-              <a:t>Time on this slide: 0:50</a:t>
+              <a:t>Time on this slide: 1:00</a:t>
             </a:r>
             <a:endParaRPr lang="en-US" sz="1300" dirty="0"/>
           </a:p>
@@ -14454,7 +14902,7 @@
               <a:buChar char="•"/>
             </a:pPr>
             <a:r>
-              <a:rPr lang="en-US" sz="1600" dirty="0">
+              <a:rPr lang="en-US" sz="1400" dirty="0">
                 <a:solidFill>
                   <a:srgbClr val="1B2430"/>
                 </a:solidFill>
@@ -14462,9 +14910,9 @@
                 <a:ea typeface="Calibri" pitchFamily="34" charset="-122"/>
                 <a:cs typeface="Calibri" pitchFamily="34" charset="-120"/>
               </a:rPr>
-              <a:t>Learned: reliability is a set of simple rules working together; congestion control matters as much as retransmission; testing tools fail in surprising ways.</a:t>
-            </a:r>
-            <a:endParaRPr lang="en-US" sz="1600" dirty="0"/>
+              <a:t>We then put the neural agent into the C transport, the same code as Section 8, and tested it on the same three emulated paths with 15 runs each.</a:t>
+            </a:r>
+            <a:endParaRPr lang="en-US" sz="1400" dirty="0"/>
           </a:p>
           <a:p>
             <a:pPr marL="342900" indent="-342900">
@@ -14475,7 +14923,7 @@
               <a:buChar char="•"/>
             </a:pPr>
             <a:r>
-              <a:rPr lang="en-US" sz="1600" dirty="0">
+              <a:rPr lang="en-US" sz="1400" dirty="0">
                 <a:solidFill>
                   <a:srgbClr val="1B2430"/>
                 </a:solidFill>
@@ -14483,9 +14931,9 @@
                 <a:ea typeface="Calibri" pitchFamily="34" charset="-122"/>
                 <a:cs typeface="Calibri" pitchFamily="34" charset="-120"/>
               </a:rPr>
-              <a:t>Next: Selective Repeat with SACK, a stronger learning agent, adaptive timeout, and tests on a real multi-machine network.</a:t>
-            </a:r>
-            <a:endParaRPr lang="en-US" sz="1600" dirty="0"/>
+              <a:t>AIMD and the agents all start from a window of 10. The neural agent was faster than AIMD on all three: 15 percent on 5G-like, 27 percent on lossy, 24 percent on satellite-like. The intervals exclude zero.</a:t>
+            </a:r>
+            <a:endParaRPr lang="en-US" sz="1400" dirty="0"/>
           </a:p>
           <a:p>
             <a:pPr marL="342900" indent="-342900">
@@ -14496,7 +14944,7 @@
               <a:buChar char="•"/>
             </a:pPr>
             <a:r>
-              <a:rPr lang="en-US" sz="1600" dirty="0">
+              <a:rPr lang="en-US" sz="1400" dirty="0">
                 <a:solidFill>
                   <a:srgbClr val="1B2430"/>
                 </a:solidFill>
@@ -14504,9 +14952,30 @@
                 <a:ea typeface="Calibri" pitchFamily="34" charset="-122"/>
                 <a:cs typeface="Calibri" pitchFamily="34" charset="-120"/>
               </a:rPr>
-              <a:t>Name the limits before she does: Go-Back-N, loopback-only protocol tests, Smart-RUDP not beating AIMD.</a:t>
-            </a:r>
-            <a:endParaRPr lang="en-US" sz="1600" dirty="0"/>
+              <a:t>The retrained table did not carry over: it was slower on 5G and satellite. A network generalises to unseen paths where a table does not.</a:t>
+            </a:r>
+            <a:endParaRPr lang="en-US" sz="1400" dirty="0"/>
+          </a:p>
+          <a:p>
+            <a:pPr marL="342900" indent="-342900">
+              <a:spcAft>
+                <a:spcPts val="600"/>
+              </a:spcAft>
+              <a:buSzPct val="100000"/>
+              <a:buChar char="•"/>
+            </a:pPr>
+            <a:r>
+              <a:rPr lang="en-US" sz="1400" dirty="0">
+                <a:solidFill>
+                  <a:srgbClr val="1B2430"/>
+                </a:solidFill>
+                <a:latin typeface="Calibri" pitchFamily="34" charset="0"/>
+                <a:ea typeface="Calibri" pitchFamily="34" charset="-122"/>
+                <a:cs typeface="Calibri" pitchFamily="34" charset="-120"/>
+              </a:rPr>
+              <a:t>We also added selective acknowledgments to the C code: about ten times fewer retransmissions, but no significant change in completion time on these emulated paths.</a:t>
+            </a:r>
+            <a:endParaRPr lang="en-US" sz="1400" dirty="0"/>
           </a:p>
         </p:txBody>
       </p:sp>
@@ -14582,7 +15051,7 @@
                 <a:ea typeface="Calibri" pitchFamily="34" charset="-122"/>
                 <a:cs typeface="Calibri" pitchFamily="34" charset="-120"/>
               </a:rPr>
-              <a:t>End on the limits and the fix order: SACK, adaptive timeout, real-network tests.</a:t>
+              <a:t>Q: So Smart-RUDP now beats AIMD? A: The neural version does, in the C transport on emulated paths, trained in a simulator; the original table agent in Section 8 did not. Q: Is it fair? A: Same start window; AIMD keeps a cap of 128 while the agents are capped at 32; the agent retransmits more on random loss. Q: Why no gain from SACK? A: Those paths are limited by the bottleneck rate, so extra retransmissions cost little; the simulator, with different paths, showed a large gain.</a:t>
             </a:r>
             <a:endParaRPr lang="en-US" sz="1400" dirty="0"/>
           </a:p>
@@ -14653,7 +15122,7 @@
                 <a:ea typeface="Calibri" pitchFamily="34" charset="-122"/>
                 <a:cs typeface="Calibri" pitchFamily="34" charset="-120"/>
               </a:rPr>
-              <a:t>23. Thank you</a:t>
+              <a:t>23. Learnings and future work</a:t>
             </a:r>
             <a:endParaRPr lang="en-US" sz="2600" dirty="0"/>
           </a:p>
@@ -14692,7 +15161,7 @@
                 <a:ea typeface="Calibri" pitchFamily="34" charset="-122"/>
                 <a:cs typeface="Calibri" pitchFamily="34" charset="-120"/>
               </a:rPr>
-              <a:t>Time on this slide: 0:15</a:t>
+              <a:t>Time on this slide: 0:50</a:t>
             </a:r>
             <a:endParaRPr lang="en-US" sz="1300" dirty="0"/>
           </a:p>
@@ -14845,7 +15314,49 @@
                 <a:ea typeface="Calibri" pitchFamily="34" charset="-122"/>
                 <a:cs typeface="Calibri" pitchFamily="34" charset="-120"/>
               </a:rPr>
-              <a:t>Thank you. The code, report and captures are at github.com/Capsturrrr/rudp. Happy to take questions.</a:t>
+              <a:t>Learned: reliability is a set of simple rules working together; congestion control matters as much as retransmission; testing tools fail in surprising ways.</a:t>
+            </a:r>
+            <a:endParaRPr lang="en-US" sz="1600" dirty="0"/>
+          </a:p>
+          <a:p>
+            <a:pPr marL="342900" indent="-342900">
+              <a:spcAft>
+                <a:spcPts val="600"/>
+              </a:spcAft>
+              <a:buSzPct val="100000"/>
+              <a:buChar char="•"/>
+            </a:pPr>
+            <a:r>
+              <a:rPr lang="en-US" sz="1600" dirty="0">
+                <a:solidFill>
+                  <a:srgbClr val="1B2430"/>
+                </a:solidFill>
+                <a:latin typeface="Calibri" pitchFamily="34" charset="0"/>
+                <a:ea typeface="Calibri" pitchFamily="34" charset="-122"/>
+                <a:cs typeface="Calibri" pitchFamily="34" charset="-120"/>
+              </a:rPr>
+              <a:t>Next: Selective Repeat with SACK, a stronger learning agent, adaptive timeout, and tests on a real multi-machine network.</a:t>
+            </a:r>
+            <a:endParaRPr lang="en-US" sz="1600" dirty="0"/>
+          </a:p>
+          <a:p>
+            <a:pPr marL="342900" indent="-342900">
+              <a:spcAft>
+                <a:spcPts val="600"/>
+              </a:spcAft>
+              <a:buSzPct val="100000"/>
+              <a:buChar char="•"/>
+            </a:pPr>
+            <a:r>
+              <a:rPr lang="en-US" sz="1600" dirty="0">
+                <a:solidFill>
+                  <a:srgbClr val="1B2430"/>
+                </a:solidFill>
+                <a:latin typeface="Calibri" pitchFamily="34" charset="0"/>
+                <a:ea typeface="Calibri" pitchFamily="34" charset="-122"/>
+                <a:cs typeface="Calibri" pitchFamily="34" charset="-120"/>
+              </a:rPr>
+              <a:t>Name the limits before she does: Go-Back-N, loopback-only protocol tests, Smart-RUDP not beating AIMD.</a:t>
             </a:r>
             <a:endParaRPr lang="en-US" sz="1600" dirty="0"/>
           </a:p>
@@ -14923,7 +15434,7 @@
                 <a:ea typeface="Calibri" pitchFamily="34" charset="-122"/>
                 <a:cs typeface="Calibri" pitchFamily="34" charset="-120"/>
               </a:rPr>
-              <a:t>Pause and smile; hand over to questions.</a:t>
+              <a:t>End on the limits and the fix order: SACK, adaptive timeout, real-network tests.</a:t>
             </a:r>
             <a:endParaRPr lang="en-US" sz="1400" dirty="0"/>
           </a:p>
@@ -14994,7 +15505,7 @@
                 <a:ea typeface="Calibri" pitchFamily="34" charset="-122"/>
                 <a:cs typeface="Calibri" pitchFamily="34" charset="-120"/>
               </a:rPr>
-              <a:t>24. Appendix: slow start</a:t>
+              <a:t>24. Thank you</a:t>
             </a:r>
             <a:endParaRPr lang="en-US" sz="2600" dirty="0"/>
           </a:p>
@@ -15033,7 +15544,7 @@
                 <a:ea typeface="Calibri" pitchFamily="34" charset="-122"/>
                 <a:cs typeface="Calibri" pitchFamily="34" charset="-120"/>
               </a:rPr>
-              <a:t>Time on this slide: -</a:t>
+              <a:t>Time on this slide: 0:15</a:t>
             </a:r>
             <a:endParaRPr lang="en-US" sz="1300" dirty="0"/>
           </a:p>
@@ -15186,7 +15697,7 @@
                 <a:ea typeface="Calibri" pitchFamily="34" charset="-122"/>
                 <a:cs typeface="Calibri" pitchFamily="34" charset="-120"/>
               </a:rPr>
-              <a:t>Only if asked: the window starts at 1, adds 1 per ACK until the threshold 16, then 1/window per ACK. In the 62-packet run the final window was 18.71.</a:t>
+              <a:t>Thank you. The code, report and captures are at github.com/Capsturrrr/rudp. Happy to take questions.</a:t>
             </a:r>
             <a:endParaRPr lang="en-US" sz="1600" dirty="0"/>
           </a:p>
@@ -15264,7 +15775,7 @@
                 <a:ea typeface="Calibri" pitchFamily="34" charset="-122"/>
                 <a:cs typeface="Calibri" pitchFamily="34" charset="-120"/>
               </a:rPr>
-              <a:t>Use this slide to answer 'show me congestion avoidance'.</a:t>
+              <a:t>Pause and smile; hand over to questions.</a:t>
             </a:r>
             <a:endParaRPr lang="en-US" sz="1400" dirty="0"/>
           </a:p>
@@ -15335,7 +15846,7 @@
                 <a:ea typeface="Calibri" pitchFamily="34" charset="-122"/>
                 <a:cs typeface="Calibri" pitchFamily="34" charset="-120"/>
               </a:rPr>
-              <a:t>Hard questions and short answers (1 of 2)</a:t>
+              <a:t>25. Appendix: slow start</a:t>
             </a:r>
             <a:endParaRPr lang="en-US" sz="2600" dirty="0"/>
           </a:p>
@@ -15343,7 +15854,46 @@
       </p:sp>
       <p:sp>
         <p:nvSpPr>
-          <p:cNvPr id="3" name="Shape 1"/>
+          <p:cNvPr id="3" name="Text 1"/>
+          <p:cNvSpPr/>
+          <p:nvPr/>
+        </p:nvSpPr>
+        <p:spPr>
+          <a:xfrm>
+            <a:off x="457200" y="804672"/>
+            <a:ext cx="10972800" cy="320040"/>
+          </a:xfrm>
+          <a:prstGeom prst="rect">
+            <a:avLst/>
+          </a:prstGeom>
+          <a:noFill/>
+          <a:ln/>
+        </p:spPr>
+        <p:txBody>
+          <a:bodyPr wrap="square" lIns="0" tIns="0" rIns="0" bIns="0" rtlCol="0" anchor="ctr"/>
+          <a:lstStyle/>
+          <a:p>
+            <a:pPr indent="0" marL="0">
+              <a:buNone/>
+            </a:pPr>
+            <a:r>
+              <a:rPr lang="en-US" sz="1300" dirty="0">
+                <a:solidFill>
+                  <a:srgbClr val="5B6775"/>
+                </a:solidFill>
+                <a:latin typeface="Calibri" pitchFamily="34" charset="0"/>
+                <a:ea typeface="Calibri" pitchFamily="34" charset="-122"/>
+                <a:cs typeface="Calibri" pitchFamily="34" charset="-120"/>
+              </a:rPr>
+              <a:t>Time on this slide: -</a:t>
+            </a:r>
+            <a:endParaRPr lang="en-US" sz="1300" dirty="0"/>
+          </a:p>
+        </p:txBody>
+      </p:sp>
+      <p:sp>
+        <p:nvSpPr>
+          <p:cNvPr id="4" name="Shape 2"/>
           <p:cNvSpPr/>
           <p:nvPr/>
         </p:nvSpPr>
@@ -15366,26 +15916,47 @@
           </a:ln>
         </p:spPr>
       </p:sp>
-      <p:sp>
-        <p:nvSpPr>
-          <p:cNvPr id="4" name="Shape 2"/>
-          <p:cNvSpPr/>
-          <p:nvPr/>
-        </p:nvSpPr>
+      <p:pic>
+        <p:nvPicPr>
+          <p:cNvPr id="5" name="Image 0" descr="th-25.png">    </p:cNvPr>
+          <p:cNvPicPr>
+            <a:picLocks noChangeAspect="1"/>
+          </p:cNvPicPr>
+          <p:nvPr/>
+        </p:nvPicPr>
+        <p:blipFill>
+          <a:blip r:embed="rId1"/>
+          <a:stretch>
+            <a:fillRect/>
+          </a:stretch>
+        </p:blipFill>
         <p:spPr>
           <a:xfrm>
             <a:off x="457200" y="1371600"/>
-            <a:ext cx="11274552" cy="914400"/>
-          </a:xfrm>
-          <a:prstGeom prst="rect">
-            <a:avLst/>
-          </a:prstGeom>
-          <a:solidFill>
-            <a:srgbClr val="F2F6FB"/>
-          </a:solidFill>
-          <a:ln w="9525">
+            <a:ext cx="5669280" cy="3188970"/>
+          </a:xfrm>
+          <a:prstGeom prst="rect">
+            <a:avLst/>
+          </a:prstGeom>
+        </p:spPr>
+      </p:pic>
+      <p:sp>
+        <p:nvSpPr>
+          <p:cNvPr id="6" name="Shape 3"/>
+          <p:cNvSpPr/>
+          <p:nvPr/>
+        </p:nvSpPr>
+        <p:spPr>
+          <a:xfrm>
+            <a:off x="457200" y="1371600"/>
+            <a:ext cx="5669280" cy="3188970"/>
+          </a:xfrm>
+          <a:prstGeom prst="rect">
+            <a:avLst/>
+          </a:prstGeom>
+          <a:ln w="12700">
             <a:solidFill>
-              <a:srgbClr val="D5DEE9"/>
+              <a:srgbClr val="C9D3E0"/>
             </a:solidFill>
             <a:prstDash val="solid"/>
           </a:ln>
@@ -15393,14 +15964,14 @@
       </p:sp>
       <p:sp>
         <p:nvSpPr>
-          <p:cNvPr id="5" name="Text 3"/>
-          <p:cNvSpPr/>
-          <p:nvPr/>
-        </p:nvSpPr>
-        <p:spPr>
-          <a:xfrm>
-            <a:off x="640080" y="1417320"/>
-            <a:ext cx="10972800" cy="320040"/>
+          <p:cNvPr id="7" name="Text 4"/>
+          <p:cNvSpPr/>
+          <p:nvPr/>
+        </p:nvSpPr>
+        <p:spPr>
+          <a:xfrm>
+            <a:off x="6400800" y="1325880"/>
+            <a:ext cx="1828800" cy="320040"/>
           </a:xfrm>
           <a:prstGeom prst="rect">
             <a:avLst/>
@@ -15416,7 +15987,7 @@
               <a:buNone/>
             </a:pPr>
             <a:r>
-              <a:rPr lang="en-US" sz="1500" b="1" dirty="0">
+              <a:rPr lang="en-US" sz="1300" b="1" dirty="0">
                 <a:solidFill>
                   <a:srgbClr val="1F6FEB"/>
                 </a:solidFill>
@@ -15424,22 +15995,22 @@
                 <a:ea typeface="Calibri" pitchFamily="34" charset="-122"/>
                 <a:cs typeface="Calibri" pitchFamily="34" charset="-120"/>
               </a:rPr>
-              <a:t>Is this a lab exercise?</a:t>
-            </a:r>
-            <a:endParaRPr lang="en-US" sz="1500" dirty="0"/>
-          </a:p>
-        </p:txBody>
-      </p:sp>
-      <p:sp>
-        <p:nvSpPr>
-          <p:cNvPr id="6" name="Text 4"/>
-          <p:cNvSpPr/>
-          <p:nvPr/>
-        </p:nvSpPr>
-        <p:spPr>
-          <a:xfrm>
-            <a:off x="640080" y="1737360"/>
-            <a:ext cx="10972800" cy="530352"/>
+              <a:t>SAY</a:t>
+            </a:r>
+            <a:endParaRPr lang="en-US" sz="1300" dirty="0"/>
+          </a:p>
+        </p:txBody>
+      </p:sp>
+      <p:sp>
+        <p:nvSpPr>
+          <p:cNvPr id="8" name="Text 5"/>
+          <p:cNvSpPr/>
+          <p:nvPr/>
+        </p:nvSpPr>
+        <p:spPr>
+          <a:xfrm>
+            <a:off x="6400800" y="1645920"/>
+            <a:ext cx="5349240" cy="3017520"/>
           </a:xfrm>
           <a:prstGeom prst="rect">
             <a:avLst/>
@@ -15451,11 +16022,15 @@
           <a:bodyPr wrap="square" lIns="0" tIns="0" rIns="0" bIns="0" rtlCol="0" anchor="t"/>
           <a:lstStyle/>
           <a:p>
-            <a:pPr indent="0" marL="0">
-              <a:buNone/>
-            </a:pPr>
-            <a:r>
-              <a:rPr lang="en-US" sz="1350" dirty="0">
+            <a:pPr marL="342900" indent="-342900">
+              <a:spcAft>
+                <a:spcPts val="600"/>
+              </a:spcAft>
+              <a:buSzPct val="100000"/>
+              <a:buChar char="•"/>
+            </a:pPr>
+            <a:r>
+              <a:rPr lang="en-US" sz="1600" dirty="0">
                 <a:solidFill>
                   <a:srgbClr val="1B2430"/>
                 </a:solidFill>
@@ -15463,32 +16038,32 @@
                 <a:ea typeface="Calibri" pitchFamily="34" charset="-122"/>
                 <a:cs typeface="Calibri" pitchFamily="34" charset="-120"/>
               </a:rPr>
-              <a:t>A lab sends datagrams. We built reliability and congestion control on top, measured them, and used them in a real chat and a routed network.</a:t>
-            </a:r>
-            <a:endParaRPr lang="en-US" sz="1350" dirty="0"/>
-          </a:p>
-        </p:txBody>
-      </p:sp>
-      <p:sp>
-        <p:nvSpPr>
-          <p:cNvPr id="7" name="Shape 5"/>
-          <p:cNvSpPr/>
-          <p:nvPr/>
-        </p:nvSpPr>
-        <p:spPr>
-          <a:xfrm>
-            <a:off x="457200" y="2377440"/>
-            <a:ext cx="11274552" cy="914400"/>
+              <a:t>Only if asked: the window starts at 1, adds 1 per ACK until the threshold 16, then 1/window per ACK. In the 62-packet run the final window was 18.71.</a:t>
+            </a:r>
+            <a:endParaRPr lang="en-US" sz="1600" dirty="0"/>
+          </a:p>
+        </p:txBody>
+      </p:sp>
+      <p:sp>
+        <p:nvSpPr>
+          <p:cNvPr id="9" name="Shape 6"/>
+          <p:cNvSpPr/>
+          <p:nvPr/>
+        </p:nvSpPr>
+        <p:spPr>
+          <a:xfrm>
+            <a:off x="457200" y="4709160"/>
+            <a:ext cx="5669280" cy="1737360"/>
           </a:xfrm>
           <a:prstGeom prst="rect">
             <a:avLst/>
           </a:prstGeom>
           <a:solidFill>
-            <a:srgbClr val="F2F6FB"/>
+            <a:srgbClr val="FFF6E5"/>
           </a:solidFill>
-          <a:ln w="9525">
+          <a:ln w="12700">
             <a:solidFill>
-              <a:srgbClr val="D5DEE9"/>
+              <a:srgbClr val="F0C987"/>
             </a:solidFill>
             <a:prstDash val="solid"/>
           </a:ln>
@@ -15496,14 +16071,14 @@
       </p:sp>
       <p:sp>
         <p:nvSpPr>
-          <p:cNvPr id="8" name="Text 6"/>
-          <p:cNvSpPr/>
-          <p:nvPr/>
-        </p:nvSpPr>
-        <p:spPr>
-          <a:xfrm>
-            <a:off x="640080" y="2423160"/>
-            <a:ext cx="10972800" cy="320040"/>
+          <p:cNvPr id="10" name="Text 7"/>
+          <p:cNvSpPr/>
+          <p:nvPr/>
+        </p:nvSpPr>
+        <p:spPr>
+          <a:xfrm>
+            <a:off x="594360" y="4754880"/>
+            <a:ext cx="5394960" cy="1645920"/>
           </a:xfrm>
           <a:prstGeom prst="rect">
             <a:avLst/>
@@ -15512,53 +16087,28 @@
           <a:ln/>
         </p:spPr>
         <p:txBody>
-          <a:bodyPr wrap="square" lIns="0" tIns="0" rIns="0" bIns="0" rtlCol="0" anchor="ctr"/>
+          <a:bodyPr wrap="square" lIns="0" tIns="0" rIns="0" bIns="0" rtlCol="0" anchor="t"/>
           <a:lstStyle/>
           <a:p>
             <a:pPr indent="0" marL="0">
               <a:buNone/>
             </a:pPr>
             <a:r>
-              <a:rPr lang="en-US" sz="1500" b="1" dirty="0">
-                <a:solidFill>
-                  <a:srgbClr val="1F6FEB"/>
-                </a:solidFill>
-                <a:latin typeface="Calibri" pitchFamily="34" charset="0"/>
-                <a:ea typeface="Calibri" pitchFamily="34" charset="-122"/>
-                <a:cs typeface="Calibri" pitchFamily="34" charset="-120"/>
-              </a:rPr>
-              <a:t>Why not TCP?</a:t>
-            </a:r>
-            <a:endParaRPr lang="en-US" sz="1500" dirty="0"/>
-          </a:p>
-        </p:txBody>
-      </p:sp>
-      <p:sp>
-        <p:nvSpPr>
-          <p:cNvPr id="9" name="Text 7"/>
-          <p:cNvSpPr/>
-          <p:nvPr/>
-        </p:nvSpPr>
-        <p:spPr>
-          <a:xfrm>
-            <a:off x="640080" y="2743200"/>
-            <a:ext cx="10972800" cy="530352"/>
-          </a:xfrm>
-          <a:prstGeom prst="rect">
-            <a:avLst/>
-          </a:prstGeom>
-          <a:noFill/>
-          <a:ln/>
-        </p:spPr>
-        <p:txBody>
-          <a:bodyPr wrap="square" lIns="0" tIns="0" rIns="0" bIns="0" rtlCol="0" anchor="t"/>
-          <a:lstStyle/>
-          <a:p>
+              <a:rPr lang="en-US" sz="1400" b="1" dirty="0">
+                <a:solidFill>
+                  <a:srgbClr val="B45309"/>
+                </a:solidFill>
+                <a:latin typeface="Calibri" pitchFamily="34" charset="0"/>
+                <a:ea typeface="Calibri" pitchFamily="34" charset="-122"/>
+                <a:cs typeface="Calibri" pitchFamily="34" charset="-120"/>
+              </a:rPr>
+              <a:t>IF ASKED  </a:t>
+            </a:r>
             <a:pPr indent="0" marL="0">
               <a:buNone/>
             </a:pPr>
             <a:r>
-              <a:rPr lang="en-US" sz="1350" dirty="0">
+              <a:rPr lang="en-US" sz="1400" dirty="0">
                 <a:solidFill>
                   <a:srgbClr val="1B2430"/>
                 </a:solidFill>
@@ -15566,318 +16116,9 @@
                 <a:ea typeface="Calibri" pitchFamily="34" charset="-122"/>
                 <a:cs typeface="Calibri" pitchFamily="34" charset="-120"/>
               </a:rPr>
-              <a:t>TCP is in the kernel and cannot be changed. Building our own makes every mechanism visible. QUIC and HTTP/3 do the same.</a:t>
-            </a:r>
-            <a:endParaRPr lang="en-US" sz="1350" dirty="0"/>
-          </a:p>
-        </p:txBody>
-      </p:sp>
-      <p:sp>
-        <p:nvSpPr>
-          <p:cNvPr id="10" name="Shape 8"/>
-          <p:cNvSpPr/>
-          <p:nvPr/>
-        </p:nvSpPr>
-        <p:spPr>
-          <a:xfrm>
-            <a:off x="457200" y="3383280"/>
-            <a:ext cx="11274552" cy="914400"/>
-          </a:xfrm>
-          <a:prstGeom prst="rect">
-            <a:avLst/>
-          </a:prstGeom>
-          <a:solidFill>
-            <a:srgbClr val="F2F6FB"/>
-          </a:solidFill>
-          <a:ln w="9525">
-            <a:solidFill>
-              <a:srgbClr val="D5DEE9"/>
-            </a:solidFill>
-            <a:prstDash val="solid"/>
-          </a:ln>
-        </p:spPr>
-      </p:sp>
-      <p:sp>
-        <p:nvSpPr>
-          <p:cNvPr id="11" name="Text 9"/>
-          <p:cNvSpPr/>
-          <p:nvPr/>
-        </p:nvSpPr>
-        <p:spPr>
-          <a:xfrm>
-            <a:off x="640080" y="3429000"/>
-            <a:ext cx="10972800" cy="320040"/>
-          </a:xfrm>
-          <a:prstGeom prst="rect">
-            <a:avLst/>
-          </a:prstGeom>
-          <a:noFill/>
-          <a:ln/>
-        </p:spPr>
-        <p:txBody>
-          <a:bodyPr wrap="square" lIns="0" tIns="0" rIns="0" bIns="0" rtlCol="0" anchor="ctr"/>
-          <a:lstStyle/>
-          <a:p>
-            <a:pPr indent="0" marL="0">
-              <a:buNone/>
-            </a:pPr>
-            <a:r>
-              <a:rPr lang="en-US" sz="1500" b="1" dirty="0">
-                <a:solidFill>
-                  <a:srgbClr val="1F6FEB"/>
-                </a:solidFill>
-                <a:latin typeface="Calibri" pitchFamily="34" charset="0"/>
-                <a:ea typeface="Calibri" pitchFamily="34" charset="-122"/>
-                <a:cs typeface="Calibri" pitchFamily="34" charset="-120"/>
-              </a:rPr>
-              <a:t>Did Smart-RUDP win?</a:t>
-            </a:r>
-            <a:endParaRPr lang="en-US" sz="1500" dirty="0"/>
-          </a:p>
-        </p:txBody>
-      </p:sp>
-      <p:sp>
-        <p:nvSpPr>
-          <p:cNvPr id="12" name="Text 10"/>
-          <p:cNvSpPr/>
-          <p:nvPr/>
-        </p:nvSpPr>
-        <p:spPr>
-          <a:xfrm>
-            <a:off x="640080" y="3749040"/>
-            <a:ext cx="10972800" cy="530352"/>
-          </a:xfrm>
-          <a:prstGeom prst="rect">
-            <a:avLst/>
-          </a:prstGeom>
-          <a:noFill/>
-          <a:ln/>
-        </p:spPr>
-        <p:txBody>
-          <a:bodyPr wrap="square" lIns="0" tIns="0" rIns="0" bIns="0" rtlCol="0" anchor="t"/>
-          <a:lstStyle/>
-          <a:p>
-            <a:pPr indent="0" marL="0">
-              <a:buNone/>
-            </a:pPr>
-            <a:r>
-              <a:rPr lang="en-US" sz="1350" dirty="0">
-                <a:solidFill>
-                  <a:srgbClr val="1B2430"/>
-                </a:solidFill>
-                <a:latin typeface="Calibri" pitchFamily="34" charset="0"/>
-                <a:ea typeface="Calibri" pitchFamily="34" charset="-122"/>
-                <a:cs typeface="Calibri" pitchFamily="34" charset="-120"/>
-              </a:rPr>
-              <a:t>Experiments: tied on one path, slower on two, and we say so. Chat, retrained on simulated paths: faster than AIMD on 5 of 6 held-out paths, equal on 1, because AIMD resets to 1 on every timeout. Deep RL: a small DQN in the chat gateway gave 3.20 s mean on the same stress paths (training is seed-sensitive; chosen on validation paths). Stress test on 48 unseen random paths: mean 3.73 s Smart vs 7.16 s AIMD; faster on 27, slower on 5, within 5% on 16. Simulated; same start window 10; agent may not shrink without a congestion signal.</a:t>
-            </a:r>
-            <a:endParaRPr lang="en-US" sz="1350" dirty="0"/>
-          </a:p>
-        </p:txBody>
-      </p:sp>
-      <p:sp>
-        <p:nvSpPr>
-          <p:cNvPr id="13" name="Shape 11"/>
-          <p:cNvSpPr/>
-          <p:nvPr/>
-        </p:nvSpPr>
-        <p:spPr>
-          <a:xfrm>
-            <a:off x="457200" y="4389120"/>
-            <a:ext cx="11274552" cy="914400"/>
-          </a:xfrm>
-          <a:prstGeom prst="rect">
-            <a:avLst/>
-          </a:prstGeom>
-          <a:solidFill>
-            <a:srgbClr val="F2F6FB"/>
-          </a:solidFill>
-          <a:ln w="9525">
-            <a:solidFill>
-              <a:srgbClr val="D5DEE9"/>
-            </a:solidFill>
-            <a:prstDash val="solid"/>
-          </a:ln>
-        </p:spPr>
-      </p:sp>
-      <p:sp>
-        <p:nvSpPr>
-          <p:cNvPr id="14" name="Text 12"/>
-          <p:cNvSpPr/>
-          <p:nvPr/>
-        </p:nvSpPr>
-        <p:spPr>
-          <a:xfrm>
-            <a:off x="640080" y="4434840"/>
-            <a:ext cx="10972800" cy="320040"/>
-          </a:xfrm>
-          <a:prstGeom prst="rect">
-            <a:avLst/>
-          </a:prstGeom>
-          <a:noFill/>
-          <a:ln/>
-        </p:spPr>
-        <p:txBody>
-          <a:bodyPr wrap="square" lIns="0" tIns="0" rIns="0" bIns="0" rtlCol="0" anchor="ctr"/>
-          <a:lstStyle/>
-          <a:p>
-            <a:pPr indent="0" marL="0">
-              <a:buNone/>
-            </a:pPr>
-            <a:r>
-              <a:rPr lang="en-US" sz="1500" b="1" dirty="0">
-                <a:solidFill>
-                  <a:srgbClr val="1F6FEB"/>
-                </a:solidFill>
-                <a:latin typeface="Calibri" pitchFamily="34" charset="0"/>
-                <a:ea typeface="Calibri" pitchFamily="34" charset="-122"/>
-                <a:cs typeface="Calibri" pitchFamily="34" charset="-120"/>
-              </a:rPr>
-              <a:t>Why Go-Back-N?</a:t>
-            </a:r>
-            <a:endParaRPr lang="en-US" sz="1500" dirty="0"/>
-          </a:p>
-        </p:txBody>
-      </p:sp>
-      <p:sp>
-        <p:nvSpPr>
-          <p:cNvPr id="15" name="Text 13"/>
-          <p:cNvSpPr/>
-          <p:nvPr/>
-        </p:nvSpPr>
-        <p:spPr>
-          <a:xfrm>
-            <a:off x="640080" y="4754880"/>
-            <a:ext cx="10972800" cy="530352"/>
-          </a:xfrm>
-          <a:prstGeom prst="rect">
-            <a:avLst/>
-          </a:prstGeom>
-          <a:noFill/>
-          <a:ln/>
-        </p:spPr>
-        <p:txBody>
-          <a:bodyPr wrap="square" lIns="0" tIns="0" rIns="0" bIns="0" rtlCol="0" anchor="t"/>
-          <a:lstStyle/>
-          <a:p>
-            <a:pPr indent="0" marL="0">
-              <a:buNone/>
-            </a:pPr>
-            <a:r>
-              <a:rPr lang="en-US" sz="1350" dirty="0">
-                <a:solidFill>
-                  <a:srgbClr val="1B2430"/>
-                </a:solidFill>
-                <a:latin typeface="Calibri" pitchFamily="34" charset="0"/>
-                <a:ea typeface="Calibri" pitchFamily="34" charset="-122"/>
-                <a:cs typeface="Calibri" pitchFamily="34" charset="-120"/>
-              </a:rPr>
-              <a:t>Simpler to build and explain. It wastes bandwidth under loss; Selective Repeat with SACK is future work.</a:t>
-            </a:r>
-            <a:endParaRPr lang="en-US" sz="1350" dirty="0"/>
-          </a:p>
-        </p:txBody>
-      </p:sp>
-      <p:sp>
-        <p:nvSpPr>
-          <p:cNvPr id="16" name="Shape 14"/>
-          <p:cNvSpPr/>
-          <p:nvPr/>
-        </p:nvSpPr>
-        <p:spPr>
-          <a:xfrm>
-            <a:off x="457200" y="5394960"/>
-            <a:ext cx="11274552" cy="914400"/>
-          </a:xfrm>
-          <a:prstGeom prst="rect">
-            <a:avLst/>
-          </a:prstGeom>
-          <a:solidFill>
-            <a:srgbClr val="F2F6FB"/>
-          </a:solidFill>
-          <a:ln w="9525">
-            <a:solidFill>
-              <a:srgbClr val="D5DEE9"/>
-            </a:solidFill>
-            <a:prstDash val="solid"/>
-          </a:ln>
-        </p:spPr>
-      </p:sp>
-      <p:sp>
-        <p:nvSpPr>
-          <p:cNvPr id="17" name="Text 15"/>
-          <p:cNvSpPr/>
-          <p:nvPr/>
-        </p:nvSpPr>
-        <p:spPr>
-          <a:xfrm>
-            <a:off x="640080" y="5440680"/>
-            <a:ext cx="10972800" cy="320040"/>
-          </a:xfrm>
-          <a:prstGeom prst="rect">
-            <a:avLst/>
-          </a:prstGeom>
-          <a:noFill/>
-          <a:ln/>
-        </p:spPr>
-        <p:txBody>
-          <a:bodyPr wrap="square" lIns="0" tIns="0" rIns="0" bIns="0" rtlCol="0" anchor="ctr"/>
-          <a:lstStyle/>
-          <a:p>
-            <a:pPr indent="0" marL="0">
-              <a:buNone/>
-            </a:pPr>
-            <a:r>
-              <a:rPr lang="en-US" sz="1500" b="1" dirty="0">
-                <a:solidFill>
-                  <a:srgbClr val="1F6FEB"/>
-                </a:solidFill>
-                <a:latin typeface="Calibri" pitchFamily="34" charset="0"/>
-                <a:ea typeface="Calibri" pitchFamily="34" charset="-122"/>
-                <a:cs typeface="Calibri" pitchFamily="34" charset="-120"/>
-              </a:rPr>
-              <a:t>Tests ran on one machine?</a:t>
-            </a:r>
-            <a:endParaRPr lang="en-US" sz="1500" dirty="0"/>
-          </a:p>
-        </p:txBody>
-      </p:sp>
-      <p:sp>
-        <p:nvSpPr>
-          <p:cNvPr id="18" name="Text 16"/>
-          <p:cNvSpPr/>
-          <p:nvPr/>
-        </p:nvSpPr>
-        <p:spPr>
-          <a:xfrm>
-            <a:off x="640080" y="5760720"/>
-            <a:ext cx="10972800" cy="530352"/>
-          </a:xfrm>
-          <a:prstGeom prst="rect">
-            <a:avLst/>
-          </a:prstGeom>
-          <a:noFill/>
-          <a:ln/>
-        </p:spPr>
-        <p:txBody>
-          <a:bodyPr wrap="square" lIns="0" tIns="0" rIns="0" bIns="0" rtlCol="0" anchor="t"/>
-          <a:lstStyle/>
-          <a:p>
-            <a:pPr indent="0" marL="0">
-              <a:buNone/>
-            </a:pPr>
-            <a:r>
-              <a:rPr lang="en-US" sz="1350" dirty="0">
-                <a:solidFill>
-                  <a:srgbClr val="1B2430"/>
-                </a:solidFill>
-                <a:latin typeface="Calibri" pitchFamily="34" charset="0"/>
-                <a:ea typeface="Calibri" pitchFamily="34" charset="-122"/>
-                <a:cs typeface="Calibri" pitchFamily="34" charset="-120"/>
-              </a:rPr>
-              <a:t>Yes, with emulated delay, loss and jitter. They do not prove internet performance; the report says so. Chat between laptop and phone is a small real-network check.</a:t>
-            </a:r>
-            <a:endParaRPr lang="en-US" sz="1350" dirty="0"/>
+              <a:t>Use this slide to answer 'show me congestion avoidance'.</a:t>
+            </a:r>
+            <a:endParaRPr lang="en-US" sz="1400" dirty="0"/>
           </a:p>
         </p:txBody>
       </p:sp>
@@ -15892,6 +16133,617 @@
 <file path=ppt/slides/slide28.xml><?xml version="1.0" encoding="utf-8"?>
 <p:sld xmlns:a="http://schemas.openxmlformats.org/drawingml/2006/main" xmlns:r="http://schemas.openxmlformats.org/officeDocument/2006/relationships" xmlns:p="http://schemas.openxmlformats.org/presentationml/2006/main">
   <p:cSld name="Slide 28">
+    <p:bg>
+      <p:bgPr>
+        <a:solidFill>
+          <a:srgbClr val="FFFFFF"/>
+        </a:solidFill>
+      </p:bgPr>
+    </p:bg>
+    <p:spTree>
+      <p:nvGrpSpPr>
+        <p:cNvPr id="1" name=""/>
+        <p:cNvGrpSpPr/>
+        <p:nvPr/>
+      </p:nvGrpSpPr>
+      <p:grpSpPr>
+        <a:xfrm>
+          <a:off x="0" y="0"/>
+          <a:ext cx="0" cy="0"/>
+          <a:chOff x="0" y="0"/>
+          <a:chExt cx="0" cy="0"/>
+        </a:xfrm>
+      </p:grpSpPr>
+      <p:sp>
+        <p:nvSpPr>
+          <p:cNvPr id="2" name="Text 0"/>
+          <p:cNvSpPr/>
+          <p:nvPr/>
+        </p:nvSpPr>
+        <p:spPr>
+          <a:xfrm>
+            <a:off x="457200" y="274320"/>
+            <a:ext cx="9601200" cy="548640"/>
+          </a:xfrm>
+          <a:prstGeom prst="rect">
+            <a:avLst/>
+          </a:prstGeom>
+          <a:noFill/>
+          <a:ln/>
+        </p:spPr>
+        <p:txBody>
+          <a:bodyPr wrap="square" lIns="0" tIns="0" rIns="0" bIns="0" rtlCol="0" anchor="ctr"/>
+          <a:lstStyle/>
+          <a:p>
+            <a:pPr indent="0" marL="0">
+              <a:buNone/>
+            </a:pPr>
+            <a:r>
+              <a:rPr lang="en-US" sz="2600" b="1" dirty="0">
+                <a:solidFill>
+                  <a:srgbClr val="1B2430"/>
+                </a:solidFill>
+                <a:latin typeface="Calibri" pitchFamily="34" charset="0"/>
+                <a:ea typeface="Calibri" pitchFamily="34" charset="-122"/>
+                <a:cs typeface="Calibri" pitchFamily="34" charset="-120"/>
+              </a:rPr>
+              <a:t>Hard questions and short answers (1 of 2)</a:t>
+            </a:r>
+            <a:endParaRPr lang="en-US" sz="2600" dirty="0"/>
+          </a:p>
+        </p:txBody>
+      </p:sp>
+      <p:sp>
+        <p:nvSpPr>
+          <p:cNvPr id="3" name="Shape 1"/>
+          <p:cNvSpPr/>
+          <p:nvPr/>
+        </p:nvSpPr>
+        <p:spPr>
+          <a:xfrm>
+            <a:off x="457200" y="1143000"/>
+            <a:ext cx="11274552" cy="36576"/>
+          </a:xfrm>
+          <a:prstGeom prst="rect">
+            <a:avLst/>
+          </a:prstGeom>
+          <a:solidFill>
+            <a:srgbClr val="1F6FEB"/>
+          </a:solidFill>
+          <a:ln w="12700">
+            <a:solidFill>
+              <a:srgbClr val="1F6FEB"/>
+            </a:solidFill>
+            <a:prstDash val="solid"/>
+          </a:ln>
+        </p:spPr>
+      </p:sp>
+      <p:sp>
+        <p:nvSpPr>
+          <p:cNvPr id="4" name="Shape 2"/>
+          <p:cNvSpPr/>
+          <p:nvPr/>
+        </p:nvSpPr>
+        <p:spPr>
+          <a:xfrm>
+            <a:off x="457200" y="1371600"/>
+            <a:ext cx="11274552" cy="914400"/>
+          </a:xfrm>
+          <a:prstGeom prst="rect">
+            <a:avLst/>
+          </a:prstGeom>
+          <a:solidFill>
+            <a:srgbClr val="F2F6FB"/>
+          </a:solidFill>
+          <a:ln w="9525">
+            <a:solidFill>
+              <a:srgbClr val="D5DEE9"/>
+            </a:solidFill>
+            <a:prstDash val="solid"/>
+          </a:ln>
+        </p:spPr>
+      </p:sp>
+      <p:sp>
+        <p:nvSpPr>
+          <p:cNvPr id="5" name="Text 3"/>
+          <p:cNvSpPr/>
+          <p:nvPr/>
+        </p:nvSpPr>
+        <p:spPr>
+          <a:xfrm>
+            <a:off x="640080" y="1417320"/>
+            <a:ext cx="10972800" cy="320040"/>
+          </a:xfrm>
+          <a:prstGeom prst="rect">
+            <a:avLst/>
+          </a:prstGeom>
+          <a:noFill/>
+          <a:ln/>
+        </p:spPr>
+        <p:txBody>
+          <a:bodyPr wrap="square" lIns="0" tIns="0" rIns="0" bIns="0" rtlCol="0" anchor="ctr"/>
+          <a:lstStyle/>
+          <a:p>
+            <a:pPr indent="0" marL="0">
+              <a:buNone/>
+            </a:pPr>
+            <a:r>
+              <a:rPr lang="en-US" sz="1500" b="1" dirty="0">
+                <a:solidFill>
+                  <a:srgbClr val="1F6FEB"/>
+                </a:solidFill>
+                <a:latin typeface="Calibri" pitchFamily="34" charset="0"/>
+                <a:ea typeface="Calibri" pitchFamily="34" charset="-122"/>
+                <a:cs typeface="Calibri" pitchFamily="34" charset="-120"/>
+              </a:rPr>
+              <a:t>Is this a lab exercise?</a:t>
+            </a:r>
+            <a:endParaRPr lang="en-US" sz="1500" dirty="0"/>
+          </a:p>
+        </p:txBody>
+      </p:sp>
+      <p:sp>
+        <p:nvSpPr>
+          <p:cNvPr id="6" name="Text 4"/>
+          <p:cNvSpPr/>
+          <p:nvPr/>
+        </p:nvSpPr>
+        <p:spPr>
+          <a:xfrm>
+            <a:off x="640080" y="1737360"/>
+            <a:ext cx="10972800" cy="530352"/>
+          </a:xfrm>
+          <a:prstGeom prst="rect">
+            <a:avLst/>
+          </a:prstGeom>
+          <a:noFill/>
+          <a:ln/>
+        </p:spPr>
+        <p:txBody>
+          <a:bodyPr wrap="square" lIns="0" tIns="0" rIns="0" bIns="0" rtlCol="0" anchor="t"/>
+          <a:lstStyle/>
+          <a:p>
+            <a:pPr indent="0" marL="0">
+              <a:buNone/>
+            </a:pPr>
+            <a:r>
+              <a:rPr lang="en-US" sz="1350" dirty="0">
+                <a:solidFill>
+                  <a:srgbClr val="1B2430"/>
+                </a:solidFill>
+                <a:latin typeface="Calibri" pitchFamily="34" charset="0"/>
+                <a:ea typeface="Calibri" pitchFamily="34" charset="-122"/>
+                <a:cs typeface="Calibri" pitchFamily="34" charset="-120"/>
+              </a:rPr>
+              <a:t>A lab sends datagrams. We built reliability and congestion control on top, measured them, and used them in a real chat and a routed network.</a:t>
+            </a:r>
+            <a:endParaRPr lang="en-US" sz="1350" dirty="0"/>
+          </a:p>
+        </p:txBody>
+      </p:sp>
+      <p:sp>
+        <p:nvSpPr>
+          <p:cNvPr id="7" name="Shape 5"/>
+          <p:cNvSpPr/>
+          <p:nvPr/>
+        </p:nvSpPr>
+        <p:spPr>
+          <a:xfrm>
+            <a:off x="457200" y="2377440"/>
+            <a:ext cx="11274552" cy="914400"/>
+          </a:xfrm>
+          <a:prstGeom prst="rect">
+            <a:avLst/>
+          </a:prstGeom>
+          <a:solidFill>
+            <a:srgbClr val="F2F6FB"/>
+          </a:solidFill>
+          <a:ln w="9525">
+            <a:solidFill>
+              <a:srgbClr val="D5DEE9"/>
+            </a:solidFill>
+            <a:prstDash val="solid"/>
+          </a:ln>
+        </p:spPr>
+      </p:sp>
+      <p:sp>
+        <p:nvSpPr>
+          <p:cNvPr id="8" name="Text 6"/>
+          <p:cNvSpPr/>
+          <p:nvPr/>
+        </p:nvSpPr>
+        <p:spPr>
+          <a:xfrm>
+            <a:off x="640080" y="2423160"/>
+            <a:ext cx="10972800" cy="320040"/>
+          </a:xfrm>
+          <a:prstGeom prst="rect">
+            <a:avLst/>
+          </a:prstGeom>
+          <a:noFill/>
+          <a:ln/>
+        </p:spPr>
+        <p:txBody>
+          <a:bodyPr wrap="square" lIns="0" tIns="0" rIns="0" bIns="0" rtlCol="0" anchor="ctr"/>
+          <a:lstStyle/>
+          <a:p>
+            <a:pPr indent="0" marL="0">
+              <a:buNone/>
+            </a:pPr>
+            <a:r>
+              <a:rPr lang="en-US" sz="1500" b="1" dirty="0">
+                <a:solidFill>
+                  <a:srgbClr val="1F6FEB"/>
+                </a:solidFill>
+                <a:latin typeface="Calibri" pitchFamily="34" charset="0"/>
+                <a:ea typeface="Calibri" pitchFamily="34" charset="-122"/>
+                <a:cs typeface="Calibri" pitchFamily="34" charset="-120"/>
+              </a:rPr>
+              <a:t>Why not TCP?</a:t>
+            </a:r>
+            <a:endParaRPr lang="en-US" sz="1500" dirty="0"/>
+          </a:p>
+        </p:txBody>
+      </p:sp>
+      <p:sp>
+        <p:nvSpPr>
+          <p:cNvPr id="9" name="Text 7"/>
+          <p:cNvSpPr/>
+          <p:nvPr/>
+        </p:nvSpPr>
+        <p:spPr>
+          <a:xfrm>
+            <a:off x="640080" y="2743200"/>
+            <a:ext cx="10972800" cy="530352"/>
+          </a:xfrm>
+          <a:prstGeom prst="rect">
+            <a:avLst/>
+          </a:prstGeom>
+          <a:noFill/>
+          <a:ln/>
+        </p:spPr>
+        <p:txBody>
+          <a:bodyPr wrap="square" lIns="0" tIns="0" rIns="0" bIns="0" rtlCol="0" anchor="t"/>
+          <a:lstStyle/>
+          <a:p>
+            <a:pPr indent="0" marL="0">
+              <a:buNone/>
+            </a:pPr>
+            <a:r>
+              <a:rPr lang="en-US" sz="1350" dirty="0">
+                <a:solidFill>
+                  <a:srgbClr val="1B2430"/>
+                </a:solidFill>
+                <a:latin typeface="Calibri" pitchFamily="34" charset="0"/>
+                <a:ea typeface="Calibri" pitchFamily="34" charset="-122"/>
+                <a:cs typeface="Calibri" pitchFamily="34" charset="-120"/>
+              </a:rPr>
+              <a:t>TCP is in the kernel and cannot be changed. Building our own makes every mechanism visible. QUIC and HTTP/3 do the same.</a:t>
+            </a:r>
+            <a:endParaRPr lang="en-US" sz="1350" dirty="0"/>
+          </a:p>
+        </p:txBody>
+      </p:sp>
+      <p:sp>
+        <p:nvSpPr>
+          <p:cNvPr id="10" name="Shape 8"/>
+          <p:cNvSpPr/>
+          <p:nvPr/>
+        </p:nvSpPr>
+        <p:spPr>
+          <a:xfrm>
+            <a:off x="457200" y="3383280"/>
+            <a:ext cx="11274552" cy="914400"/>
+          </a:xfrm>
+          <a:prstGeom prst="rect">
+            <a:avLst/>
+          </a:prstGeom>
+          <a:solidFill>
+            <a:srgbClr val="F2F6FB"/>
+          </a:solidFill>
+          <a:ln w="9525">
+            <a:solidFill>
+              <a:srgbClr val="D5DEE9"/>
+            </a:solidFill>
+            <a:prstDash val="solid"/>
+          </a:ln>
+        </p:spPr>
+      </p:sp>
+      <p:sp>
+        <p:nvSpPr>
+          <p:cNvPr id="11" name="Text 9"/>
+          <p:cNvSpPr/>
+          <p:nvPr/>
+        </p:nvSpPr>
+        <p:spPr>
+          <a:xfrm>
+            <a:off x="640080" y="3429000"/>
+            <a:ext cx="10972800" cy="320040"/>
+          </a:xfrm>
+          <a:prstGeom prst="rect">
+            <a:avLst/>
+          </a:prstGeom>
+          <a:noFill/>
+          <a:ln/>
+        </p:spPr>
+        <p:txBody>
+          <a:bodyPr wrap="square" lIns="0" tIns="0" rIns="0" bIns="0" rtlCol="0" anchor="ctr"/>
+          <a:lstStyle/>
+          <a:p>
+            <a:pPr indent="0" marL="0">
+              <a:buNone/>
+            </a:pPr>
+            <a:r>
+              <a:rPr lang="en-US" sz="1500" b="1" dirty="0">
+                <a:solidFill>
+                  <a:srgbClr val="1F6FEB"/>
+                </a:solidFill>
+                <a:latin typeface="Calibri" pitchFamily="34" charset="0"/>
+                <a:ea typeface="Calibri" pitchFamily="34" charset="-122"/>
+                <a:cs typeface="Calibri" pitchFamily="34" charset="-120"/>
+              </a:rPr>
+              <a:t>Did Smart-RUDP win?</a:t>
+            </a:r>
+            <a:endParaRPr lang="en-US" sz="1500" dirty="0"/>
+          </a:p>
+        </p:txBody>
+      </p:sp>
+      <p:sp>
+        <p:nvSpPr>
+          <p:cNvPr id="12" name="Text 10"/>
+          <p:cNvSpPr/>
+          <p:nvPr/>
+        </p:nvSpPr>
+        <p:spPr>
+          <a:xfrm>
+            <a:off x="640080" y="3749040"/>
+            <a:ext cx="10972800" cy="530352"/>
+          </a:xfrm>
+          <a:prstGeom prst="rect">
+            <a:avLst/>
+          </a:prstGeom>
+          <a:noFill/>
+          <a:ln/>
+        </p:spPr>
+        <p:txBody>
+          <a:bodyPr wrap="square" lIns="0" tIns="0" rIns="0" bIns="0" rtlCol="0" anchor="t"/>
+          <a:lstStyle/>
+          <a:p>
+            <a:pPr indent="0" marL="0">
+              <a:buNone/>
+            </a:pPr>
+            <a:r>
+              <a:rPr lang="en-US" sz="1350" dirty="0">
+                <a:solidFill>
+                  <a:srgbClr val="1B2430"/>
+                </a:solidFill>
+                <a:latin typeface="Calibri" pitchFamily="34" charset="0"/>
+                <a:ea typeface="Calibri" pitchFamily="34" charset="-122"/>
+                <a:cs typeface="Calibri" pitchFamily="34" charset="-120"/>
+              </a:rPr>
+              <a:t>Experiments: tied on one path, slower on two, and we say so. Chat, retrained on simulated paths: faster than AIMD on 5 of 6 held-out paths, equal on 1, because AIMD resets to 1 on every timeout. Deep RL: a small DQN in the chat gateway gave 3.20 s mean on the same stress paths (training is seed-sensitive; chosen on validation paths). Stress test on 48 unseen random paths: mean 3.73 s Smart vs 7.16 s AIMD; faster on 27, slower on 5, within 5% on 16. Simulated; same start window 10; agent may not shrink without a congestion signal.</a:t>
+            </a:r>
+            <a:endParaRPr lang="en-US" sz="1350" dirty="0"/>
+          </a:p>
+        </p:txBody>
+      </p:sp>
+      <p:sp>
+        <p:nvSpPr>
+          <p:cNvPr id="13" name="Shape 11"/>
+          <p:cNvSpPr/>
+          <p:nvPr/>
+        </p:nvSpPr>
+        <p:spPr>
+          <a:xfrm>
+            <a:off x="457200" y="4389120"/>
+            <a:ext cx="11274552" cy="914400"/>
+          </a:xfrm>
+          <a:prstGeom prst="rect">
+            <a:avLst/>
+          </a:prstGeom>
+          <a:solidFill>
+            <a:srgbClr val="F2F6FB"/>
+          </a:solidFill>
+          <a:ln w="9525">
+            <a:solidFill>
+              <a:srgbClr val="D5DEE9"/>
+            </a:solidFill>
+            <a:prstDash val="solid"/>
+          </a:ln>
+        </p:spPr>
+      </p:sp>
+      <p:sp>
+        <p:nvSpPr>
+          <p:cNvPr id="14" name="Text 12"/>
+          <p:cNvSpPr/>
+          <p:nvPr/>
+        </p:nvSpPr>
+        <p:spPr>
+          <a:xfrm>
+            <a:off x="640080" y="4434840"/>
+            <a:ext cx="10972800" cy="320040"/>
+          </a:xfrm>
+          <a:prstGeom prst="rect">
+            <a:avLst/>
+          </a:prstGeom>
+          <a:noFill/>
+          <a:ln/>
+        </p:spPr>
+        <p:txBody>
+          <a:bodyPr wrap="square" lIns="0" tIns="0" rIns="0" bIns="0" rtlCol="0" anchor="ctr"/>
+          <a:lstStyle/>
+          <a:p>
+            <a:pPr indent="0" marL="0">
+              <a:buNone/>
+            </a:pPr>
+            <a:r>
+              <a:rPr lang="en-US" sz="1500" b="1" dirty="0">
+                <a:solidFill>
+                  <a:srgbClr val="1F6FEB"/>
+                </a:solidFill>
+                <a:latin typeface="Calibri" pitchFamily="34" charset="0"/>
+                <a:ea typeface="Calibri" pitchFamily="34" charset="-122"/>
+                <a:cs typeface="Calibri" pitchFamily="34" charset="-120"/>
+              </a:rPr>
+              <a:t>Why Go-Back-N?</a:t>
+            </a:r>
+            <a:endParaRPr lang="en-US" sz="1500" dirty="0"/>
+          </a:p>
+        </p:txBody>
+      </p:sp>
+      <p:sp>
+        <p:nvSpPr>
+          <p:cNvPr id="15" name="Text 13"/>
+          <p:cNvSpPr/>
+          <p:nvPr/>
+        </p:nvSpPr>
+        <p:spPr>
+          <a:xfrm>
+            <a:off x="640080" y="4754880"/>
+            <a:ext cx="10972800" cy="530352"/>
+          </a:xfrm>
+          <a:prstGeom prst="rect">
+            <a:avLst/>
+          </a:prstGeom>
+          <a:noFill/>
+          <a:ln/>
+        </p:spPr>
+        <p:txBody>
+          <a:bodyPr wrap="square" lIns="0" tIns="0" rIns="0" bIns="0" rtlCol="0" anchor="t"/>
+          <a:lstStyle/>
+          <a:p>
+            <a:pPr indent="0" marL="0">
+              <a:buNone/>
+            </a:pPr>
+            <a:r>
+              <a:rPr lang="en-US" sz="1350" dirty="0">
+                <a:solidFill>
+                  <a:srgbClr val="1B2430"/>
+                </a:solidFill>
+                <a:latin typeface="Calibri" pitchFamily="34" charset="0"/>
+                <a:ea typeface="Calibri" pitchFamily="34" charset="-122"/>
+                <a:cs typeface="Calibri" pitchFamily="34" charset="-120"/>
+              </a:rPr>
+              <a:t>Simpler to build and explain. It wastes bandwidth under loss; Selective Repeat with SACK is future work.</a:t>
+            </a:r>
+            <a:endParaRPr lang="en-US" sz="1350" dirty="0"/>
+          </a:p>
+        </p:txBody>
+      </p:sp>
+      <p:sp>
+        <p:nvSpPr>
+          <p:cNvPr id="16" name="Shape 14"/>
+          <p:cNvSpPr/>
+          <p:nvPr/>
+        </p:nvSpPr>
+        <p:spPr>
+          <a:xfrm>
+            <a:off x="457200" y="5394960"/>
+            <a:ext cx="11274552" cy="914400"/>
+          </a:xfrm>
+          <a:prstGeom prst="rect">
+            <a:avLst/>
+          </a:prstGeom>
+          <a:solidFill>
+            <a:srgbClr val="F2F6FB"/>
+          </a:solidFill>
+          <a:ln w="9525">
+            <a:solidFill>
+              <a:srgbClr val="D5DEE9"/>
+            </a:solidFill>
+            <a:prstDash val="solid"/>
+          </a:ln>
+        </p:spPr>
+      </p:sp>
+      <p:sp>
+        <p:nvSpPr>
+          <p:cNvPr id="17" name="Text 15"/>
+          <p:cNvSpPr/>
+          <p:nvPr/>
+        </p:nvSpPr>
+        <p:spPr>
+          <a:xfrm>
+            <a:off x="640080" y="5440680"/>
+            <a:ext cx="10972800" cy="320040"/>
+          </a:xfrm>
+          <a:prstGeom prst="rect">
+            <a:avLst/>
+          </a:prstGeom>
+          <a:noFill/>
+          <a:ln/>
+        </p:spPr>
+        <p:txBody>
+          <a:bodyPr wrap="square" lIns="0" tIns="0" rIns="0" bIns="0" rtlCol="0" anchor="ctr"/>
+          <a:lstStyle/>
+          <a:p>
+            <a:pPr indent="0" marL="0">
+              <a:buNone/>
+            </a:pPr>
+            <a:r>
+              <a:rPr lang="en-US" sz="1500" b="1" dirty="0">
+                <a:solidFill>
+                  <a:srgbClr val="1F6FEB"/>
+                </a:solidFill>
+                <a:latin typeface="Calibri" pitchFamily="34" charset="0"/>
+                <a:ea typeface="Calibri" pitchFamily="34" charset="-122"/>
+                <a:cs typeface="Calibri" pitchFamily="34" charset="-120"/>
+              </a:rPr>
+              <a:t>Tests ran on one machine?</a:t>
+            </a:r>
+            <a:endParaRPr lang="en-US" sz="1500" dirty="0"/>
+          </a:p>
+        </p:txBody>
+      </p:sp>
+      <p:sp>
+        <p:nvSpPr>
+          <p:cNvPr id="18" name="Text 16"/>
+          <p:cNvSpPr/>
+          <p:nvPr/>
+        </p:nvSpPr>
+        <p:spPr>
+          <a:xfrm>
+            <a:off x="640080" y="5760720"/>
+            <a:ext cx="10972800" cy="530352"/>
+          </a:xfrm>
+          <a:prstGeom prst="rect">
+            <a:avLst/>
+          </a:prstGeom>
+          <a:noFill/>
+          <a:ln/>
+        </p:spPr>
+        <p:txBody>
+          <a:bodyPr wrap="square" lIns="0" tIns="0" rIns="0" bIns="0" rtlCol="0" anchor="t"/>
+          <a:lstStyle/>
+          <a:p>
+            <a:pPr indent="0" marL="0">
+              <a:buNone/>
+            </a:pPr>
+            <a:r>
+              <a:rPr lang="en-US" sz="1350" dirty="0">
+                <a:solidFill>
+                  <a:srgbClr val="1B2430"/>
+                </a:solidFill>
+                <a:latin typeface="Calibri" pitchFamily="34" charset="0"/>
+                <a:ea typeface="Calibri" pitchFamily="34" charset="-122"/>
+                <a:cs typeface="Calibri" pitchFamily="34" charset="-120"/>
+              </a:rPr>
+              <a:t>Yes, with emulated delay, loss and jitter. They do not prove internet performance; the report says so. Chat between laptop and phone is a small real-network check.</a:t>
+            </a:r>
+            <a:endParaRPr lang="en-US" sz="1350" dirty="0"/>
+          </a:p>
+        </p:txBody>
+      </p:sp>
+    </p:spTree>
+  </p:cSld>
+  <p:clrMapOvr>
+    <a:masterClrMapping/>
+  </p:clrMapOvr>
+</p:sld>
+</file>
+
+<file path=ppt/slides/slide29.xml><?xml version="1.0" encoding="utf-8"?>
+<p:sld xmlns:a="http://schemas.openxmlformats.org/drawingml/2006/main" xmlns:r="http://schemas.openxmlformats.org/officeDocument/2006/relationships" xmlns:p="http://schemas.openxmlformats.org/presentationml/2006/main">
+  <p:cSld name="Slide 29">
     <p:bg>
       <p:bgPr>
         <a:solidFill>

</xml_diff>